<commit_message>
docs: simplify presentation imagery
</commit_message>
<xml_diff>
--- a/docs/presentacion/eudila-presentacion-general-2026-10-26.pptx
+++ b/docs/presentacion/eudila-presentacion-general-2026-10-26.pptx
@@ -2,20 +2,20 @@
 <file path=ppt/presentation.xml><?xml version="1.0" encoding="utf-8"?>
 <p:presentation xmlns:p="http://schemas.openxmlformats.org/presentationml/2006/main">
   <p:sldMasterIdLst>
-    <p:sldMasterId xmlns:r="http://schemas.openxmlformats.org/officeDocument/2006/relationships" id="2147483648" r:id="Ree78b38177114505"/>
+    <p:sldMasterId xmlns:r="http://schemas.openxmlformats.org/officeDocument/2006/relationships" id="2147483648" r:id="Rd6b3bfdf9ae242f1"/>
   </p:sldMasterIdLst>
   <p:notesMasterIdLst>
-    <p:notesMasterId xmlns:r="http://schemas.openxmlformats.org/officeDocument/2006/relationships" r:id="R2ceb38126df24075"/>
+    <p:notesMasterId xmlns:r="http://schemas.openxmlformats.org/officeDocument/2006/relationships" r:id="R5af724b1bfb44992"/>
   </p:notesMasterIdLst>
   <p:sldIdLst>
-    <p:sldId xmlns:r="http://schemas.openxmlformats.org/officeDocument/2006/relationships" id="256" r:id="R40f79077e0374ce3"/>
-    <p:sldId xmlns:r="http://schemas.openxmlformats.org/officeDocument/2006/relationships" id="257" r:id="Rfafbb230749e4914"/>
-    <p:sldId xmlns:r="http://schemas.openxmlformats.org/officeDocument/2006/relationships" id="258" r:id="R40fb92a18b7042a6"/>
-    <p:sldId xmlns:r="http://schemas.openxmlformats.org/officeDocument/2006/relationships" id="259" r:id="R17dc15da261d4f9d"/>
-    <p:sldId xmlns:r="http://schemas.openxmlformats.org/officeDocument/2006/relationships" id="260" r:id="R9db52348975a4374"/>
-    <p:sldId xmlns:r="http://schemas.openxmlformats.org/officeDocument/2006/relationships" id="261" r:id="R671ecd9c27ff47a7"/>
-    <p:sldId xmlns:r="http://schemas.openxmlformats.org/officeDocument/2006/relationships" id="262" r:id="R856b78302c514e53"/>
-    <p:sldId xmlns:r="http://schemas.openxmlformats.org/officeDocument/2006/relationships" id="263" r:id="R00e0c8b3fa1f4644"/>
+    <p:sldId xmlns:r="http://schemas.openxmlformats.org/officeDocument/2006/relationships" id="256" r:id="R1ec1c80067334250"/>
+    <p:sldId xmlns:r="http://schemas.openxmlformats.org/officeDocument/2006/relationships" id="257" r:id="R87ee37fcaa204f35"/>
+    <p:sldId xmlns:r="http://schemas.openxmlformats.org/officeDocument/2006/relationships" id="258" r:id="R5b49d69377664844"/>
+    <p:sldId xmlns:r="http://schemas.openxmlformats.org/officeDocument/2006/relationships" id="259" r:id="R38e43629dfd44c96"/>
+    <p:sldId xmlns:r="http://schemas.openxmlformats.org/officeDocument/2006/relationships" id="260" r:id="R56e3704feea14fa2"/>
+    <p:sldId xmlns:r="http://schemas.openxmlformats.org/officeDocument/2006/relationships" id="261" r:id="R82db5a35730e404c"/>
+    <p:sldId xmlns:r="http://schemas.openxmlformats.org/officeDocument/2006/relationships" id="262" r:id="Rbe4d99d68f7f4849"/>
+    <p:sldId xmlns:r="http://schemas.openxmlformats.org/officeDocument/2006/relationships" id="263" r:id="Rce2ac3feca9d458d"/>
   </p:sldIdLst>
   <p:sldSz cx="12192000" cy="6858000"/>
   <p:notesSz cx="6858000" cy="9144000"/>
@@ -529,7 +529,12 @@
           </a:p>
           <a:p xmlns:a="http://schemas.openxmlformats.org/drawingml/2006/main">
             <a:r>
-              <a:t>Fuente: PRODUCT.md; DESIGN.md; docs/design/evidence/apertura-2026-10-26/escritorio-1440.png.</a:t>
+              <a:t>Fuente: PRODUCT.md; DESIGN.md.</a:t>
+            </a:r>
+          </a:p>
+          <a:p xmlns:a="http://schemas.openxmlformats.org/drawingml/2006/main">
+            <a:r>
+              <a:t>Imagen: recorte de docs/design/evidence/mascota-momentos-2026-10-24/saludo.png.</a:t>
             </a:r>
           </a:p>
         </p:txBody>
@@ -689,7 +694,7 @@
           </a:p>
           <a:p xmlns:a="http://schemas.openxmlformats.org/drawingml/2006/main">
             <a:r>
-              <a:t>Imagen: docs/design/evidence/mascota-animo-2026-10-24/siete-estados.png.</a:t>
+              <a:t>Imagen: docs/design/evidence/mascota-animo-2026-10-24/neutral-390.png.</a:t>
             </a:r>
           </a:p>
         </p:txBody>
@@ -954,7 +959,7 @@
           </a:p>
           <a:p xmlns:a="http://schemas.openxmlformats.org/drawingml/2006/main">
             <a:r>
-              <a:t>Imagen: docs/design/evidence/mascota-consistencia-2026-10-24/mascota-coral.png.</a:t>
+              <a:t>Imagen: recorte de docs/design/evidence/mascota-consistencia-2026-10-24/mascota-coral.png.</a:t>
             </a:r>
           </a:p>
         </p:txBody>
@@ -1086,7 +1091,7 @@
           <p:cNvPr id="3" name="Title">
             <a:extLst xmlns:a="http://schemas.openxmlformats.org/drawingml/2006/main">
               <a:ext uri="{FF2B5EF4-FFF2-40B4-BE49-F238E27FC236}">
-                <a16:creationId xmlns:a16="http://schemas.microsoft.com/office/drawing/2014/main" id="{7EEF35EE-3289-4E08-B0BC-65CBB560DC5F}"/>
+                <a16:creationId xmlns:a16="http://schemas.microsoft.com/office/drawing/2014/main" id="{D80F6018-2466-46C6-AA99-411AF9F36081}"/>
               </a:ext>
             </a:extLst>
           </p:cNvPr>
@@ -1315,7 +1320,7 @@
           <p:cNvPr id="2" name="Subtitle">
             <a:extLst xmlns:a="http://schemas.openxmlformats.org/drawingml/2006/main">
               <a:ext uri="{FF2B5EF4-FFF2-40B4-BE49-F238E27FC236}">
-                <a16:creationId xmlns:a16="http://schemas.microsoft.com/office/drawing/2014/main" id="{C55AA358-AE39-452A-B653-1806212EE4F1}"/>
+                <a16:creationId xmlns:a16="http://schemas.microsoft.com/office/drawing/2014/main" id="{6920A769-086E-422C-9B9F-57155901DC40}"/>
               </a:ext>
             </a:extLst>
           </p:cNvPr>
@@ -1561,7 +1566,7 @@
           <p:cNvPr id="2" name="Section title">
             <a:extLst xmlns:a="http://schemas.openxmlformats.org/drawingml/2006/main">
               <a:ext uri="{FF2B5EF4-FFF2-40B4-BE49-F238E27FC236}">
-                <a16:creationId xmlns:a16="http://schemas.microsoft.com/office/drawing/2014/main" id="{778052B3-B9DD-4ACF-A2FF-6F6EE4D95550}"/>
+                <a16:creationId xmlns:a16="http://schemas.microsoft.com/office/drawing/2014/main" id="{9014A102-BBB4-4BD5-9A2A-49D96582740B}"/>
               </a:ext>
             </a:extLst>
           </p:cNvPr>
@@ -1807,7 +1812,7 @@
           <p:cNvPr id="3" name="Title">
             <a:extLst xmlns:a="http://schemas.openxmlformats.org/drawingml/2006/main">
               <a:ext uri="{FF2B5EF4-FFF2-40B4-BE49-F238E27FC236}">
-                <a16:creationId xmlns:a16="http://schemas.microsoft.com/office/drawing/2014/main" id="{1E19AE73-CAAB-4ECE-A62D-E21EF36DB1AE}"/>
+                <a16:creationId xmlns:a16="http://schemas.microsoft.com/office/drawing/2014/main" id="{739C5ECD-48E5-45DC-8022-D1CFBB422C1F}"/>
               </a:ext>
             </a:extLst>
           </p:cNvPr>
@@ -2036,7 +2041,7 @@
           <p:cNvPr id="2" name="Body">
             <a:extLst xmlns:a="http://schemas.openxmlformats.org/drawingml/2006/main">
               <a:ext uri="{FF2B5EF4-FFF2-40B4-BE49-F238E27FC236}">
-                <a16:creationId xmlns:a16="http://schemas.microsoft.com/office/drawing/2014/main" id="{027B44D4-20FC-463F-B44F-C8441D69E83E}"/>
+                <a16:creationId xmlns:a16="http://schemas.microsoft.com/office/drawing/2014/main" id="{B1C9D903-2261-4AEF-BF34-8ED8BC0FF11F}"/>
               </a:ext>
             </a:extLst>
           </p:cNvPr>
@@ -2282,7 +2287,7 @@
           <p:cNvPr id="4" name="Title">
             <a:extLst xmlns:a="http://schemas.openxmlformats.org/drawingml/2006/main">
               <a:ext uri="{FF2B5EF4-FFF2-40B4-BE49-F238E27FC236}">
-                <a16:creationId xmlns:a16="http://schemas.microsoft.com/office/drawing/2014/main" id="{A7B31389-0C7D-4C57-88A8-292A3E80AF98}"/>
+                <a16:creationId xmlns:a16="http://schemas.microsoft.com/office/drawing/2014/main" id="{0137B7DA-7757-4C57-AF7E-A443792E8A7E}"/>
               </a:ext>
             </a:extLst>
           </p:cNvPr>
@@ -2511,7 +2516,7 @@
           <p:cNvPr id="2" name="Left column">
             <a:extLst xmlns:a="http://schemas.openxmlformats.org/drawingml/2006/main">
               <a:ext uri="{FF2B5EF4-FFF2-40B4-BE49-F238E27FC236}">
-                <a16:creationId xmlns:a16="http://schemas.microsoft.com/office/drawing/2014/main" id="{1B1F41DF-D444-4015-BD0B-926D0F3BBD82}"/>
+                <a16:creationId xmlns:a16="http://schemas.microsoft.com/office/drawing/2014/main" id="{A59900AE-64C1-42A9-87CB-FE1511AD6973}"/>
               </a:ext>
             </a:extLst>
           </p:cNvPr>
@@ -2740,7 +2745,7 @@
           <p:cNvPr id="3" name="Right column">
             <a:extLst xmlns:a="http://schemas.openxmlformats.org/drawingml/2006/main">
               <a:ext uri="{FF2B5EF4-FFF2-40B4-BE49-F238E27FC236}">
-                <a16:creationId xmlns:a16="http://schemas.microsoft.com/office/drawing/2014/main" id="{43EC63C6-BBFA-4B68-947F-265A38774C49}"/>
+                <a16:creationId xmlns:a16="http://schemas.microsoft.com/office/drawing/2014/main" id="{CA1640AC-7B63-45D3-83C9-5833989A8B28}"/>
               </a:ext>
             </a:extLst>
           </p:cNvPr>
@@ -2986,7 +2991,7 @@
           <p:cNvPr id="3" name="Title">
             <a:extLst xmlns:a="http://schemas.openxmlformats.org/drawingml/2006/main">
               <a:ext uri="{FF2B5EF4-FFF2-40B4-BE49-F238E27FC236}">
-                <a16:creationId xmlns:a16="http://schemas.microsoft.com/office/drawing/2014/main" id="{84F5BA89-5E4C-42C7-8AD7-A9A0D388A78C}"/>
+                <a16:creationId xmlns:a16="http://schemas.microsoft.com/office/drawing/2014/main" id="{922CC6EB-9306-463D-81A0-BBCACE4BC706}"/>
               </a:ext>
             </a:extLst>
           </p:cNvPr>
@@ -3215,7 +3220,7 @@
           <p:cNvPr id="2" name="Left column">
             <a:extLst xmlns:a="http://schemas.openxmlformats.org/drawingml/2006/main">
               <a:ext uri="{FF2B5EF4-FFF2-40B4-BE49-F238E27FC236}">
-                <a16:creationId xmlns:a16="http://schemas.microsoft.com/office/drawing/2014/main" id="{4D8B4755-B155-43FF-AAC5-B2712C09A009}"/>
+                <a16:creationId xmlns:a16="http://schemas.microsoft.com/office/drawing/2014/main" id="{975CA696-9F04-4A2C-8C0B-477EACB73BB0}"/>
               </a:ext>
             </a:extLst>
           </p:cNvPr>
@@ -3482,12 +3487,12 @@
   </p:cSld>
   <p:clrMap bg1="lt1" tx1="dk1" bg2="lt2" tx2="dk2" accent1="accent1" accent2="accent2" accent3="accent3" accent4="accent4" accent5="accent5" accent6="accent6" hlink="hlink" folHlink="folHlink"/>
   <p:sldLayoutIdLst>
-    <p:sldLayoutId xmlns:r="http://schemas.openxmlformats.org/officeDocument/2006/relationships" id="2147483649" r:id="R5dfedbe372a34904"/>
-    <p:sldLayoutId xmlns:r="http://schemas.openxmlformats.org/officeDocument/2006/relationships" id="2147483650" r:id="Raad9a7fe98654b2b"/>
-    <p:sldLayoutId xmlns:r="http://schemas.openxmlformats.org/officeDocument/2006/relationships" id="2147483651" r:id="R8902df30a202450c"/>
-    <p:sldLayoutId xmlns:r="http://schemas.openxmlformats.org/officeDocument/2006/relationships" id="2147483652" r:id="Rde125429a8524f0e"/>
-    <p:sldLayoutId xmlns:r="http://schemas.openxmlformats.org/officeDocument/2006/relationships" id="2147483653" r:id="R9254afa6967e4f6e"/>
-    <p:sldLayoutId xmlns:r="http://schemas.openxmlformats.org/officeDocument/2006/relationships" id="2147483654" r:id="R96b4378877314fa7"/>
+    <p:sldLayoutId xmlns:r="http://schemas.openxmlformats.org/officeDocument/2006/relationships" id="2147483649" r:id="R00f788dab261497f"/>
+    <p:sldLayoutId xmlns:r="http://schemas.openxmlformats.org/officeDocument/2006/relationships" id="2147483650" r:id="Ra66519ccc79143f1"/>
+    <p:sldLayoutId xmlns:r="http://schemas.openxmlformats.org/officeDocument/2006/relationships" id="2147483651" r:id="Rb2419462fc494fd5"/>
+    <p:sldLayoutId xmlns:r="http://schemas.openxmlformats.org/officeDocument/2006/relationships" id="2147483652" r:id="Re54557392a744189"/>
+    <p:sldLayoutId xmlns:r="http://schemas.openxmlformats.org/officeDocument/2006/relationships" id="2147483653" r:id="R10ff8a7db0bd43c7"/>
+    <p:sldLayoutId xmlns:r="http://schemas.openxmlformats.org/officeDocument/2006/relationships" id="2147483654" r:id="R69936b4bd1804747"/>
   </p:sldLayoutIdLst>
   <p:txStyles>
     <p:titleStyle>
@@ -4038,7 +4043,7 @@
           <p:cNvPr id="7" name="">
             <a:extLst xmlns:a="http://schemas.openxmlformats.org/drawingml/2006/main">
               <a:ext uri="{FF2B5EF4-FFF2-40B4-BE49-F238E27FC236}">
-                <a16:creationId xmlns:a16="http://schemas.microsoft.com/office/drawing/2014/main" id="{0FE41CB8-BE95-40E5-9DBD-8A51474F0EBA}"/>
+                <a16:creationId xmlns:a16="http://schemas.microsoft.com/office/drawing/2014/main" id="{7B380089-7EFA-4B38-B8CF-22DC3FD27FC4}"/>
               </a:ext>
             </a:extLst>
           </p:cNvPr>
@@ -4197,7 +4202,7 @@
           <p:cNvPr id="2" name="">
             <a:extLst xmlns:a="http://schemas.openxmlformats.org/drawingml/2006/main">
               <a:ext uri="{FF2B5EF4-FFF2-40B4-BE49-F238E27FC236}">
-                <a16:creationId xmlns:a16="http://schemas.microsoft.com/office/drawing/2014/main" id="{66401995-4CA5-4F13-8E3E-756F5F3CC3CD}"/>
+                <a16:creationId xmlns:a16="http://schemas.microsoft.com/office/drawing/2014/main" id="{4C81C653-27D2-4AF4-847D-CCBEC518CB5D}"/>
               </a:ext>
             </a:extLst>
           </p:cNvPr>
@@ -4228,7 +4233,7 @@
           <p:cNvPr id="3" name="">
             <a:extLst xmlns:a="http://schemas.openxmlformats.org/drawingml/2006/main">
               <a:ext uri="{FF2B5EF4-FFF2-40B4-BE49-F238E27FC236}">
-                <a16:creationId xmlns:a16="http://schemas.microsoft.com/office/drawing/2014/main" id="{69E0B410-C2B2-4E57-86E4-D31B1A96349B}"/>
+                <a16:creationId xmlns:a16="http://schemas.microsoft.com/office/drawing/2014/main" id="{F75663F2-476F-490B-A287-4CDFDB96A7AB}"/>
               </a:ext>
             </a:extLst>
           </p:cNvPr>
@@ -4410,7 +4415,7 @@
           <p:cNvPr id="4" name="">
             <a:extLst xmlns:a="http://schemas.openxmlformats.org/drawingml/2006/main">
               <a:ext uri="{FF2B5EF4-FFF2-40B4-BE49-F238E27FC236}">
-                <a16:creationId xmlns:a16="http://schemas.microsoft.com/office/drawing/2014/main" id="{DAC33F61-F206-4481-8678-C174FA962478}"/>
+                <a16:creationId xmlns:a16="http://schemas.microsoft.com/office/drawing/2014/main" id="{903D815F-BDC2-4ECA-B918-2565B78CBCE4}"/>
               </a:ext>
             </a:extLst>
           </p:cNvPr>
@@ -4569,7 +4574,7 @@
           <p:cNvPr id="5" name="">
             <a:extLst xmlns:a="http://schemas.openxmlformats.org/drawingml/2006/main">
               <a:ext uri="{FF2B5EF4-FFF2-40B4-BE49-F238E27FC236}">
-                <a16:creationId xmlns:a16="http://schemas.microsoft.com/office/drawing/2014/main" id="{384B08BD-64FC-4515-AA87-EABE2109DB20}"/>
+                <a16:creationId xmlns:a16="http://schemas.microsoft.com/office/drawing/2014/main" id="{C7FA2CE7-6524-408A-9439-D62FCD93720D}"/>
               </a:ext>
             </a:extLst>
           </p:cNvPr>
@@ -4728,7 +4733,7 @@
           <p:cNvPr id="6" name="">
             <a:extLst xmlns:a="http://schemas.openxmlformats.org/drawingml/2006/main">
               <a:ext uri="{FF2B5EF4-FFF2-40B4-BE49-F238E27FC236}">
-                <a16:creationId xmlns:a16="http://schemas.microsoft.com/office/drawing/2014/main" id="{91559F9B-3777-45C1-BFB2-C7EF6877BA76}"/>
+                <a16:creationId xmlns:a16="http://schemas.microsoft.com/office/drawing/2014/main" id="{352AB19F-9661-49B5-9059-709B50B11E9E}"/>
               </a:ext>
             </a:extLst>
           </p:cNvPr>
@@ -4738,7 +4743,7 @@
           <p:nvPr/>
         </p:nvPicPr>
         <p:blipFill>
-          <a:blip xmlns:r="http://schemas.openxmlformats.org/officeDocument/2006/relationships" xmlns:a="http://schemas.openxmlformats.org/drawingml/2006/main" r:embed="Rd4cc12d678c04f4e"/>
+          <a:blip xmlns:r="http://schemas.openxmlformats.org/officeDocument/2006/relationships" xmlns:a="http://schemas.openxmlformats.org/drawingml/2006/main" r:embed="Ra9a6c380fc364fb7"/>
           <a:stretch xmlns:a="http://schemas.openxmlformats.org/drawingml/2006/main"/>
         </p:blipFill>
         <p:spPr>
@@ -4754,7 +4759,7 @@
     </p:spTree>
     <p:extLst>
       <p:ext uri="{BB962C8B-B14F-4D97-AF65-F5344CB8AC3E}">
-        <p14:creationId xmlns:p14="http://schemas.microsoft.com/office/powerpoint/2010/main" val="688058092"/>
+        <p14:creationId xmlns:p14="http://schemas.microsoft.com/office/powerpoint/2010/main" val="990198949"/>
       </p:ext>
     </p:extLst>
   </p:cSld>
@@ -4785,7 +4790,7 @@
           <p:cNvPr id="11" name="">
             <a:extLst xmlns:a="http://schemas.openxmlformats.org/drawingml/2006/main">
               <a:ext uri="{FF2B5EF4-FFF2-40B4-BE49-F238E27FC236}">
-                <a16:creationId xmlns:a16="http://schemas.microsoft.com/office/drawing/2014/main" id="{3FBCE26B-0B78-46A9-81A0-093C70810A5A}"/>
+                <a16:creationId xmlns:a16="http://schemas.microsoft.com/office/drawing/2014/main" id="{05AEA018-BD70-4246-8A7E-E35A59CF44A5}"/>
               </a:ext>
             </a:extLst>
           </p:cNvPr>
@@ -4944,7 +4949,7 @@
           <p:cNvPr id="2" name="">
             <a:extLst xmlns:a="http://schemas.openxmlformats.org/drawingml/2006/main">
               <a:ext uri="{FF2B5EF4-FFF2-40B4-BE49-F238E27FC236}">
-                <a16:creationId xmlns:a16="http://schemas.microsoft.com/office/drawing/2014/main" id="{AE9361E3-A56A-4D0D-90C6-282BAB084650}"/>
+                <a16:creationId xmlns:a16="http://schemas.microsoft.com/office/drawing/2014/main" id="{89296822-1821-499F-932B-D3096239ECC9}"/>
               </a:ext>
             </a:extLst>
           </p:cNvPr>
@@ -5103,7 +5108,7 @@
           <p:cNvPr id="3" name="">
             <a:extLst xmlns:a="http://schemas.openxmlformats.org/drawingml/2006/main">
               <a:ext uri="{FF2B5EF4-FFF2-40B4-BE49-F238E27FC236}">
-                <a16:creationId xmlns:a16="http://schemas.microsoft.com/office/drawing/2014/main" id="{1F3069FF-434A-4802-AB59-3F848D735D10}"/>
+                <a16:creationId xmlns:a16="http://schemas.microsoft.com/office/drawing/2014/main" id="{CF9CF580-5120-448D-8758-78446A563162}"/>
               </a:ext>
             </a:extLst>
           </p:cNvPr>
@@ -5134,7 +5139,7 @@
           <p:cNvPr id="4" name="">
             <a:extLst xmlns:a="http://schemas.openxmlformats.org/drawingml/2006/main">
               <a:ext uri="{FF2B5EF4-FFF2-40B4-BE49-F238E27FC236}">
-                <a16:creationId xmlns:a16="http://schemas.microsoft.com/office/drawing/2014/main" id="{6296468B-9E9F-4013-A766-4F106772B5DA}"/>
+                <a16:creationId xmlns:a16="http://schemas.microsoft.com/office/drawing/2014/main" id="{B273D2B6-F673-4ECB-9CF7-809CE03664F4}"/>
               </a:ext>
             </a:extLst>
           </p:cNvPr>
@@ -5293,7 +5298,7 @@
           <p:cNvPr id="5" name="">
             <a:extLst xmlns:a="http://schemas.openxmlformats.org/drawingml/2006/main">
               <a:ext uri="{FF2B5EF4-FFF2-40B4-BE49-F238E27FC236}">
-                <a16:creationId xmlns:a16="http://schemas.microsoft.com/office/drawing/2014/main" id="{69756849-72CE-437B-BCAC-BC8A61E3F06E}"/>
+                <a16:creationId xmlns:a16="http://schemas.microsoft.com/office/drawing/2014/main" id="{76C4E8F3-4FE4-4721-B531-AB85BE63EC0F}"/>
               </a:ext>
             </a:extLst>
           </p:cNvPr>
@@ -5452,7 +5457,7 @@
           <p:cNvPr id="6" name="">
             <a:extLst xmlns:a="http://schemas.openxmlformats.org/drawingml/2006/main">
               <a:ext uri="{FF2B5EF4-FFF2-40B4-BE49-F238E27FC236}">
-                <a16:creationId xmlns:a16="http://schemas.microsoft.com/office/drawing/2014/main" id="{3BE5E012-0F33-4769-A6A9-DDF81373C3D4}"/>
+                <a16:creationId xmlns:a16="http://schemas.microsoft.com/office/drawing/2014/main" id="{305E571C-96F3-4EF8-8C8D-CC7E8EE3D676}"/>
               </a:ext>
             </a:extLst>
           </p:cNvPr>
@@ -5611,7 +5616,7 @@
           <p:cNvPr id="7" name="">
             <a:extLst xmlns:a="http://schemas.openxmlformats.org/drawingml/2006/main">
               <a:ext uri="{FF2B5EF4-FFF2-40B4-BE49-F238E27FC236}">
-                <a16:creationId xmlns:a16="http://schemas.microsoft.com/office/drawing/2014/main" id="{6CD5F243-F85F-45A4-92A2-E504D343BCDD}"/>
+                <a16:creationId xmlns:a16="http://schemas.microsoft.com/office/drawing/2014/main" id="{89C2E4B4-AFCE-4A08-8300-D8DF6010477F}"/>
               </a:ext>
             </a:extLst>
           </p:cNvPr>
@@ -5770,7 +5775,7 @@
           <p:cNvPr id="8" name="">
             <a:extLst xmlns:a="http://schemas.openxmlformats.org/drawingml/2006/main">
               <a:ext uri="{FF2B5EF4-FFF2-40B4-BE49-F238E27FC236}">
-                <a16:creationId xmlns:a16="http://schemas.microsoft.com/office/drawing/2014/main" id="{4DF6288F-DC1A-4F44-975B-446EE2B732F6}"/>
+                <a16:creationId xmlns:a16="http://schemas.microsoft.com/office/drawing/2014/main" id="{23B9A322-4B73-4BFD-A28B-94EA3F4794BD}"/>
               </a:ext>
             </a:extLst>
           </p:cNvPr>
@@ -5929,7 +5934,7 @@
           <p:cNvPr id="9" name="">
             <a:extLst xmlns:a="http://schemas.openxmlformats.org/drawingml/2006/main">
               <a:ext uri="{FF2B5EF4-FFF2-40B4-BE49-F238E27FC236}">
-                <a16:creationId xmlns:a16="http://schemas.microsoft.com/office/drawing/2014/main" id="{469684FF-6610-459C-BEFE-80B07DC68E2F}"/>
+                <a16:creationId xmlns:a16="http://schemas.microsoft.com/office/drawing/2014/main" id="{B81CCC19-6136-4D66-9458-4BB4F2073BF2}"/>
               </a:ext>
             </a:extLst>
           </p:cNvPr>
@@ -5939,17 +5944,19 @@
           <p:nvPr/>
         </p:nvPicPr>
         <p:blipFill>
-          <a:blip xmlns:r="http://schemas.openxmlformats.org/officeDocument/2006/relationships" xmlns:a="http://schemas.openxmlformats.org/drawingml/2006/main" r:embed="R24000d348a884d56"/>
-          <a:srcRect xmlns:a="http://schemas.openxmlformats.org/drawingml/2006/main" l="0" t="0" r="0" b="0"/>
+          <a:blip xmlns:r="http://schemas.openxmlformats.org/officeDocument/2006/relationships" xmlns:a="http://schemas.openxmlformats.org/drawingml/2006/main" r:embed="Rb89c0f018bd14c7c"/>
+          <a:srcRect xmlns:a="http://schemas.openxmlformats.org/drawingml/2006/main" l="50000" t="0" r="25000" b="20000"/>
           <a:stretch xmlns:a="http://schemas.openxmlformats.org/drawingml/2006/main"/>
         </p:blipFill>
         <p:spPr>
           <a:xfrm xmlns:a="http://schemas.openxmlformats.org/drawingml/2006/main">
-            <a:off x="5619750" y="2286000"/>
-            <a:ext cx="5886450" cy="3314700"/>
+            <a:off x="7239000" y="2286000"/>
+            <a:ext cx="3429000" cy="3429000"/>
           </a:xfrm>
-          <a:prstGeom xmlns:a="http://schemas.openxmlformats.org/drawingml/2006/main" prst="rect">
-            <a:avLst/>
+          <a:prstGeom xmlns:a="http://schemas.openxmlformats.org/drawingml/2006/main" prst="roundRect">
+            <a:avLst>
+              <a:gd name="adj" fmla="val 4444"/>
+            </a:avLst>
           </a:prstGeom>
         </p:spPr>
       </p:pic>
@@ -5958,7 +5965,7 @@
           <p:cNvPr id="10" name="">
             <a:extLst xmlns:a="http://schemas.openxmlformats.org/drawingml/2006/main">
               <a:ext uri="{FF2B5EF4-FFF2-40B4-BE49-F238E27FC236}">
-                <a16:creationId xmlns:a16="http://schemas.microsoft.com/office/drawing/2014/main" id="{DD05CE93-61EE-4F3C-94B1-821DD0484CFB}"/>
+                <a16:creationId xmlns:a16="http://schemas.microsoft.com/office/drawing/2014/main" id="{0EF47408-51F4-4C11-A930-D38E45690464}"/>
               </a:ext>
             </a:extLst>
           </p:cNvPr>
@@ -5969,8 +5976,8 @@
         </p:nvSpPr>
         <p:spPr>
           <a:xfrm xmlns:a="http://schemas.openxmlformats.org/drawingml/2006/main">
-            <a:off x="5619750" y="5772150"/>
-            <a:ext cx="5886450" cy="400050"/>
+            <a:off x="7048500" y="5905500"/>
+            <a:ext cx="3810000" cy="323850"/>
           </a:xfrm>
           <a:prstGeom xmlns:a="http://schemas.openxmlformats.org/drawingml/2006/main" prst="rect">
             <a:avLst/>
@@ -5987,7 +5994,7 @@
           </a:bodyPr>
           <a:lstStyle xmlns:a="http://schemas.openxmlformats.org/drawingml/2006/main">
             <a:defPPr>
-              <a:defRPr sz="1200" b="0">
+              <a:defRPr sz="1275" b="0">
                 <a:solidFill>
                   <a:srgbClr val="AEA7C3"/>
                 </a:solidFill>
@@ -5997,7 +6004,7 @@
               </a:defRPr>
             </a:defPPr>
             <a:lvl1pPr>
-              <a:defRPr sz="1200" b="0">
+              <a:defRPr sz="1275" b="0">
                 <a:solidFill>
                   <a:srgbClr val="AEA7C3"/>
                 </a:solidFill>
@@ -6007,7 +6014,7 @@
               </a:defRPr>
             </a:lvl1pPr>
             <a:lvl2pPr>
-              <a:defRPr sz="1200" b="0">
+              <a:defRPr sz="1275" b="0">
                 <a:solidFill>
                   <a:srgbClr val="AEA7C3"/>
                 </a:solidFill>
@@ -6017,7 +6024,7 @@
               </a:defRPr>
             </a:lvl2pPr>
             <a:lvl3pPr>
-              <a:defRPr sz="1200" b="0">
+              <a:defRPr sz="1275" b="0">
                 <a:solidFill>
                   <a:srgbClr val="AEA7C3"/>
                 </a:solidFill>
@@ -6027,7 +6034,7 @@
               </a:defRPr>
             </a:lvl3pPr>
             <a:lvl4pPr>
-              <a:defRPr sz="1200" b="0">
+              <a:defRPr sz="1275" b="0">
                 <a:solidFill>
                   <a:srgbClr val="AEA7C3"/>
                 </a:solidFill>
@@ -6037,7 +6044,7 @@
               </a:defRPr>
             </a:lvl4pPr>
             <a:lvl5pPr>
-              <a:defRPr sz="1200" b="0">
+              <a:defRPr sz="1275" b="0">
                 <a:solidFill>
                   <a:srgbClr val="AEA7C3"/>
                 </a:solidFill>
@@ -6047,7 +6054,7 @@
               </a:defRPr>
             </a:lvl5pPr>
             <a:lvl6pPr>
-              <a:defRPr sz="1200" b="0">
+              <a:defRPr sz="1275" b="0">
                 <a:solidFill>
                   <a:srgbClr val="AEA7C3"/>
                 </a:solidFill>
@@ -6057,7 +6064,7 @@
               </a:defRPr>
             </a:lvl6pPr>
             <a:lvl7pPr>
-              <a:defRPr sz="1200" b="0">
+              <a:defRPr sz="1275" b="0">
                 <a:solidFill>
                   <a:srgbClr val="AEA7C3"/>
                 </a:solidFill>
@@ -6067,7 +6074,7 @@
               </a:defRPr>
             </a:lvl7pPr>
             <a:lvl8pPr>
-              <a:defRPr sz="1200" b="0">
+              <a:defRPr sz="1275" b="0">
                 <a:solidFill>
                   <a:srgbClr val="AEA7C3"/>
                 </a:solidFill>
@@ -6077,7 +6084,7 @@
               </a:defRPr>
             </a:lvl8pPr>
             <a:lvl9pPr>
-              <a:defRPr sz="1200" b="0">
+              <a:defRPr sz="1275" b="0">
                 <a:solidFill>
                   <a:srgbClr val="AEA7C3"/>
                 </a:solidFill>
@@ -6089,7 +6096,7 @@
           </a:lstStyle>
           <a:p xmlns:a="http://schemas.openxmlformats.org/drawingml/2006/main">
             <a:pPr>
-              <a:defRPr sz="1200" b="0">
+              <a:defRPr sz="1275" b="0">
                 <a:solidFill>
                   <a:srgbClr val="AEA7C3"/>
                 </a:solidFill>
@@ -6099,7 +6106,7 @@
               </a:defRPr>
             </a:pPr>
             <a:r>
-              <a:rPr sz="1200" b="0">
+              <a:rPr sz="1275" b="0">
                 <a:solidFill>
                   <a:srgbClr val="AEA7C3"/>
                 </a:solidFill>
@@ -6107,7 +6114,7 @@
                 <a:ea typeface="Figtree"/>
                 <a:cs typeface="Figtree"/>
               </a:rPr>
-              <a:t>La experiencia presenta el orbe y abre el registro con una pregunta directa.</a:t>
+              <a:t>Una presencia serena acompaña la pregunta.</a:t>
             </a:r>
           </a:p>
         </p:txBody>
@@ -6115,7 +6122,7 @@
     </p:spTree>
     <p:extLst>
       <p:ext uri="{BB962C8B-B14F-4D97-AF65-F5344CB8AC3E}">
-        <p14:creationId xmlns:p14="http://schemas.microsoft.com/office/powerpoint/2010/main" val="1304511165"/>
+        <p14:creationId xmlns:p14="http://schemas.microsoft.com/office/powerpoint/2010/main" val="327135998"/>
       </p:ext>
     </p:extLst>
   </p:cSld>
@@ -6146,7 +6153,7 @@
           <p:cNvPr id="22" name="">
             <a:extLst xmlns:a="http://schemas.openxmlformats.org/drawingml/2006/main">
               <a:ext uri="{FF2B5EF4-FFF2-40B4-BE49-F238E27FC236}">
-                <a16:creationId xmlns:a16="http://schemas.microsoft.com/office/drawing/2014/main" id="{BD516E59-6847-477B-8034-C349B17534AE}"/>
+                <a16:creationId xmlns:a16="http://schemas.microsoft.com/office/drawing/2014/main" id="{4348B888-76E7-4EBC-B1CB-A4ED9ED21D5A}"/>
               </a:ext>
             </a:extLst>
           </p:cNvPr>
@@ -6305,7 +6312,7 @@
           <p:cNvPr id="2" name="">
             <a:extLst xmlns:a="http://schemas.openxmlformats.org/drawingml/2006/main">
               <a:ext uri="{FF2B5EF4-FFF2-40B4-BE49-F238E27FC236}">
-                <a16:creationId xmlns:a16="http://schemas.microsoft.com/office/drawing/2014/main" id="{EA6BDE9B-5873-4157-B9F5-168F1B2EEB92}"/>
+                <a16:creationId xmlns:a16="http://schemas.microsoft.com/office/drawing/2014/main" id="{12E594C7-BEFB-4B75-8199-F796509249AF}"/>
               </a:ext>
             </a:extLst>
           </p:cNvPr>
@@ -6464,7 +6471,7 @@
           <p:cNvPr id="3" name="">
             <a:extLst xmlns:a="http://schemas.openxmlformats.org/drawingml/2006/main">
               <a:ext uri="{FF2B5EF4-FFF2-40B4-BE49-F238E27FC236}">
-                <a16:creationId xmlns:a16="http://schemas.microsoft.com/office/drawing/2014/main" id="{E786DA2B-972C-4525-B723-4282BA6D62E6}"/>
+                <a16:creationId xmlns:a16="http://schemas.microsoft.com/office/drawing/2014/main" id="{AF6E16C3-3AA1-4955-A273-FDEA8554DA26}"/>
               </a:ext>
             </a:extLst>
           </p:cNvPr>
@@ -6495,7 +6502,7 @@
           <p:cNvPr id="4" name="">
             <a:extLst xmlns:a="http://schemas.openxmlformats.org/drawingml/2006/main">
               <a:ext uri="{FF2B5EF4-FFF2-40B4-BE49-F238E27FC236}">
-                <a16:creationId xmlns:a16="http://schemas.microsoft.com/office/drawing/2014/main" id="{EB511E3E-C704-4CC7-BD78-243279388E3D}"/>
+                <a16:creationId xmlns:a16="http://schemas.microsoft.com/office/drawing/2014/main" id="{A591F429-8CE5-4431-8E65-F00706B7FC0B}"/>
               </a:ext>
             </a:extLst>
           </p:cNvPr>
@@ -6654,7 +6661,7 @@
           <p:cNvPr id="5" name="">
             <a:extLst xmlns:a="http://schemas.openxmlformats.org/drawingml/2006/main">
               <a:ext uri="{FF2B5EF4-FFF2-40B4-BE49-F238E27FC236}">
-                <a16:creationId xmlns:a16="http://schemas.microsoft.com/office/drawing/2014/main" id="{36F83E8E-26BA-4BF5-855B-46479D0BDBE4}"/>
+                <a16:creationId xmlns:a16="http://schemas.microsoft.com/office/drawing/2014/main" id="{8437BB55-D46A-490E-807D-29FF707BF5A7}"/>
               </a:ext>
             </a:extLst>
           </p:cNvPr>
@@ -6813,7 +6820,7 @@
           <p:cNvPr id="6" name="">
             <a:extLst xmlns:a="http://schemas.openxmlformats.org/drawingml/2006/main">
               <a:ext uri="{FF2B5EF4-FFF2-40B4-BE49-F238E27FC236}">
-                <a16:creationId xmlns:a16="http://schemas.microsoft.com/office/drawing/2014/main" id="{65230662-6200-426E-837C-98D251C9C3EC}"/>
+                <a16:creationId xmlns:a16="http://schemas.microsoft.com/office/drawing/2014/main" id="{BB8950D4-35D6-40A9-98CB-E4B6E5FA61C9}"/>
               </a:ext>
             </a:extLst>
           </p:cNvPr>
@@ -6823,7 +6830,7 @@
           <p:nvPr/>
         </p:nvPicPr>
         <p:blipFill>
-          <a:blip xmlns:r="http://schemas.openxmlformats.org/officeDocument/2006/relationships" xmlns:a="http://schemas.openxmlformats.org/drawingml/2006/main" r:embed="R1554b7d782ed4d13"/>
+          <a:blip xmlns:r="http://schemas.openxmlformats.org/officeDocument/2006/relationships" xmlns:a="http://schemas.openxmlformats.org/drawingml/2006/main" r:embed="Rb8ceba73f6fd41ef"/>
           <a:srcRect xmlns:a="http://schemas.openxmlformats.org/drawingml/2006/main" l="0" t="6000" r="0" b="41000"/>
           <a:stretch xmlns:a="http://schemas.openxmlformats.org/drawingml/2006/main"/>
         </p:blipFill>
@@ -6844,7 +6851,7 @@
           <p:cNvPr id="7" name="">
             <a:extLst xmlns:a="http://schemas.openxmlformats.org/drawingml/2006/main">
               <a:ext uri="{FF2B5EF4-FFF2-40B4-BE49-F238E27FC236}">
-                <a16:creationId xmlns:a16="http://schemas.microsoft.com/office/drawing/2014/main" id="{02BBF6BF-C08D-4DA5-94B2-B6FEE111D9D7}"/>
+                <a16:creationId xmlns:a16="http://schemas.microsoft.com/office/drawing/2014/main" id="{1F20B8ED-A326-4AA2-81FE-54B1B9C3BD9D}"/>
               </a:ext>
             </a:extLst>
           </p:cNvPr>
@@ -7003,7 +7010,7 @@
           <p:cNvPr id="8" name="">
             <a:extLst xmlns:a="http://schemas.openxmlformats.org/drawingml/2006/main">
               <a:ext uri="{FF2B5EF4-FFF2-40B4-BE49-F238E27FC236}">
-                <a16:creationId xmlns:a16="http://schemas.microsoft.com/office/drawing/2014/main" id="{64E054F5-BE59-4E21-8051-D0176D6E4B0C}"/>
+                <a16:creationId xmlns:a16="http://schemas.microsoft.com/office/drawing/2014/main" id="{FE50695F-EFAB-46C9-AC0B-0A82D1EA7908}"/>
               </a:ext>
             </a:extLst>
           </p:cNvPr>
@@ -7162,7 +7169,7 @@
           <p:cNvPr id="9" name="">
             <a:extLst xmlns:a="http://schemas.openxmlformats.org/drawingml/2006/main">
               <a:ext uri="{FF2B5EF4-FFF2-40B4-BE49-F238E27FC236}">
-                <a16:creationId xmlns:a16="http://schemas.microsoft.com/office/drawing/2014/main" id="{1A1396DB-D397-4B27-BB1F-6BEF300BED04}"/>
+                <a16:creationId xmlns:a16="http://schemas.microsoft.com/office/drawing/2014/main" id="{8F644FB3-B191-47C9-BDD6-3FFE69CAE465}"/>
               </a:ext>
             </a:extLst>
           </p:cNvPr>
@@ -7321,7 +7328,7 @@
           <p:cNvPr id="10" name="">
             <a:extLst xmlns:a="http://schemas.openxmlformats.org/drawingml/2006/main">
               <a:ext uri="{FF2B5EF4-FFF2-40B4-BE49-F238E27FC236}">
-                <a16:creationId xmlns:a16="http://schemas.microsoft.com/office/drawing/2014/main" id="{DAD5EB87-36FC-4A7D-A105-2462D861CA9B}"/>
+                <a16:creationId xmlns:a16="http://schemas.microsoft.com/office/drawing/2014/main" id="{B247509E-195E-4D8B-A06C-6BE20E326398}"/>
               </a:ext>
             </a:extLst>
           </p:cNvPr>
@@ -7480,7 +7487,7 @@
           <p:cNvPr id="11" name="">
             <a:extLst xmlns:a="http://schemas.openxmlformats.org/drawingml/2006/main">
               <a:ext uri="{FF2B5EF4-FFF2-40B4-BE49-F238E27FC236}">
-                <a16:creationId xmlns:a16="http://schemas.microsoft.com/office/drawing/2014/main" id="{DC4EB222-5AD8-491F-ACA8-9E2B932F616B}"/>
+                <a16:creationId xmlns:a16="http://schemas.microsoft.com/office/drawing/2014/main" id="{F33B640E-BA36-4CF9-9113-F5AFF450425F}"/>
               </a:ext>
             </a:extLst>
           </p:cNvPr>
@@ -7639,7 +7646,7 @@
           <p:cNvPr id="12" name="">
             <a:extLst xmlns:a="http://schemas.openxmlformats.org/drawingml/2006/main">
               <a:ext uri="{FF2B5EF4-FFF2-40B4-BE49-F238E27FC236}">
-                <a16:creationId xmlns:a16="http://schemas.microsoft.com/office/drawing/2014/main" id="{5F453981-11AB-403E-A18D-ED65A90833BF}"/>
+                <a16:creationId xmlns:a16="http://schemas.microsoft.com/office/drawing/2014/main" id="{5AB5FDF7-37B4-4D5C-AB02-4E49DFE55B2B}"/>
               </a:ext>
             </a:extLst>
           </p:cNvPr>
@@ -7798,7 +7805,7 @@
           <p:cNvPr id="13" name="">
             <a:extLst xmlns:a="http://schemas.openxmlformats.org/drawingml/2006/main">
               <a:ext uri="{FF2B5EF4-FFF2-40B4-BE49-F238E27FC236}">
-                <a16:creationId xmlns:a16="http://schemas.microsoft.com/office/drawing/2014/main" id="{28CE71C7-BD84-4BFC-87A0-CB8977842045}"/>
+                <a16:creationId xmlns:a16="http://schemas.microsoft.com/office/drawing/2014/main" id="{A90ED4E9-CDBE-4EFE-ABD1-6241A0360092}"/>
               </a:ext>
             </a:extLst>
           </p:cNvPr>
@@ -7957,7 +7964,7 @@
           <p:cNvPr id="14" name="">
             <a:extLst xmlns:a="http://schemas.openxmlformats.org/drawingml/2006/main">
               <a:ext uri="{FF2B5EF4-FFF2-40B4-BE49-F238E27FC236}">
-                <a16:creationId xmlns:a16="http://schemas.microsoft.com/office/drawing/2014/main" id="{472DF341-EC1D-4319-B0F1-893CCB446B42}"/>
+                <a16:creationId xmlns:a16="http://schemas.microsoft.com/office/drawing/2014/main" id="{A3C2B332-31AC-4C8D-9D8A-E7CD7BA36563}"/>
               </a:ext>
             </a:extLst>
           </p:cNvPr>
@@ -8116,7 +8123,7 @@
           <p:cNvPr id="15" name="">
             <a:extLst xmlns:a="http://schemas.openxmlformats.org/drawingml/2006/main">
               <a:ext uri="{FF2B5EF4-FFF2-40B4-BE49-F238E27FC236}">
-                <a16:creationId xmlns:a16="http://schemas.microsoft.com/office/drawing/2014/main" id="{9C0D2A6E-03D5-40B4-B575-F9C182342BD9}"/>
+                <a16:creationId xmlns:a16="http://schemas.microsoft.com/office/drawing/2014/main" id="{DB465776-A9FA-4093-9FD9-92622B2E98F3}"/>
               </a:ext>
             </a:extLst>
           </p:cNvPr>
@@ -8275,7 +8282,7 @@
           <p:cNvPr id="16" name="">
             <a:extLst xmlns:a="http://schemas.openxmlformats.org/drawingml/2006/main">
               <a:ext uri="{FF2B5EF4-FFF2-40B4-BE49-F238E27FC236}">
-                <a16:creationId xmlns:a16="http://schemas.microsoft.com/office/drawing/2014/main" id="{1421C764-66AE-45AF-B8CE-0ABF57E29FB0}"/>
+                <a16:creationId xmlns:a16="http://schemas.microsoft.com/office/drawing/2014/main" id="{C2BB5EB3-0680-42A9-82FC-9B0BFE398D05}"/>
               </a:ext>
             </a:extLst>
           </p:cNvPr>
@@ -8434,7 +8441,7 @@
           <p:cNvPr id="17" name="">
             <a:extLst xmlns:a="http://schemas.openxmlformats.org/drawingml/2006/main">
               <a:ext uri="{FF2B5EF4-FFF2-40B4-BE49-F238E27FC236}">
-                <a16:creationId xmlns:a16="http://schemas.microsoft.com/office/drawing/2014/main" id="{DBB55029-0B47-4699-AB0D-C851C99A5248}"/>
+                <a16:creationId xmlns:a16="http://schemas.microsoft.com/office/drawing/2014/main" id="{05FDC628-205D-4DC5-A0C1-E5C05D95D09A}"/>
               </a:ext>
             </a:extLst>
           </p:cNvPr>
@@ -8593,7 +8600,7 @@
           <p:cNvPr id="18" name="">
             <a:extLst xmlns:a="http://schemas.openxmlformats.org/drawingml/2006/main">
               <a:ext uri="{FF2B5EF4-FFF2-40B4-BE49-F238E27FC236}">
-                <a16:creationId xmlns:a16="http://schemas.microsoft.com/office/drawing/2014/main" id="{27370136-49E8-4E6F-8E00-AC7C7A2030FE}"/>
+                <a16:creationId xmlns:a16="http://schemas.microsoft.com/office/drawing/2014/main" id="{ADF56842-491A-420A-AF61-3E445CA3E8EB}"/>
               </a:ext>
             </a:extLst>
           </p:cNvPr>
@@ -8752,7 +8759,7 @@
           <p:cNvPr id="19" name="">
             <a:extLst xmlns:a="http://schemas.openxmlformats.org/drawingml/2006/main">
               <a:ext uri="{FF2B5EF4-FFF2-40B4-BE49-F238E27FC236}">
-                <a16:creationId xmlns:a16="http://schemas.microsoft.com/office/drawing/2014/main" id="{C9623F34-E2FD-4067-9C62-0A5AE1B46F61}"/>
+                <a16:creationId xmlns:a16="http://schemas.microsoft.com/office/drawing/2014/main" id="{7CBE4FD8-D3C5-483C-8CEF-0F153974970B}"/>
               </a:ext>
             </a:extLst>
           </p:cNvPr>
@@ -8911,7 +8918,7 @@
           <p:cNvPr id="20" name="">
             <a:extLst xmlns:a="http://schemas.openxmlformats.org/drawingml/2006/main">
               <a:ext uri="{FF2B5EF4-FFF2-40B4-BE49-F238E27FC236}">
-                <a16:creationId xmlns:a16="http://schemas.microsoft.com/office/drawing/2014/main" id="{6C14DFBA-5C53-464C-A9D8-2D883CBCA7D2}"/>
+                <a16:creationId xmlns:a16="http://schemas.microsoft.com/office/drawing/2014/main" id="{910A3D39-DC27-470C-8138-7ACB03AE5FB6}"/>
               </a:ext>
             </a:extLst>
           </p:cNvPr>
@@ -9070,7 +9077,7 @@
           <p:cNvPr id="21" name="">
             <a:extLst xmlns:a="http://schemas.openxmlformats.org/drawingml/2006/main">
               <a:ext uri="{FF2B5EF4-FFF2-40B4-BE49-F238E27FC236}">
-                <a16:creationId xmlns:a16="http://schemas.microsoft.com/office/drawing/2014/main" id="{FCADD366-CC7D-4FCB-A0F3-FD6909D3D628}"/>
+                <a16:creationId xmlns:a16="http://schemas.microsoft.com/office/drawing/2014/main" id="{A17C3B80-C0B7-46FB-9225-1C131F9DAE00}"/>
               </a:ext>
             </a:extLst>
           </p:cNvPr>
@@ -9227,7 +9234,7 @@
     </p:spTree>
     <p:extLst>
       <p:ext uri="{BB962C8B-B14F-4D97-AF65-F5344CB8AC3E}">
-        <p14:creationId xmlns:p14="http://schemas.microsoft.com/office/powerpoint/2010/main" val="508198900"/>
+        <p14:creationId xmlns:p14="http://schemas.microsoft.com/office/powerpoint/2010/main" val="1102767826"/>
       </p:ext>
     </p:extLst>
   </p:cSld>
@@ -9258,7 +9265,7 @@
           <p:cNvPr id="11" name="">
             <a:extLst xmlns:a="http://schemas.openxmlformats.org/drawingml/2006/main">
               <a:ext uri="{FF2B5EF4-FFF2-40B4-BE49-F238E27FC236}">
-                <a16:creationId xmlns:a16="http://schemas.microsoft.com/office/drawing/2014/main" id="{1154AE1F-0262-4B55-87DA-15E6163FCC0A}"/>
+                <a16:creationId xmlns:a16="http://schemas.microsoft.com/office/drawing/2014/main" id="{BCCBCCE5-1EC3-408D-A292-4C7844A1A76C}"/>
               </a:ext>
             </a:extLst>
           </p:cNvPr>
@@ -9417,7 +9424,7 @@
           <p:cNvPr id="2" name="">
             <a:extLst xmlns:a="http://schemas.openxmlformats.org/drawingml/2006/main">
               <a:ext uri="{FF2B5EF4-FFF2-40B4-BE49-F238E27FC236}">
-                <a16:creationId xmlns:a16="http://schemas.microsoft.com/office/drawing/2014/main" id="{D93334A7-ECE3-4896-BB0C-B1AE66EA452A}"/>
+                <a16:creationId xmlns:a16="http://schemas.microsoft.com/office/drawing/2014/main" id="{81D8A487-38DF-49DE-A95C-60A7A891E798}"/>
               </a:ext>
             </a:extLst>
           </p:cNvPr>
@@ -9576,7 +9583,7 @@
           <p:cNvPr id="3" name="">
             <a:extLst xmlns:a="http://schemas.openxmlformats.org/drawingml/2006/main">
               <a:ext uri="{FF2B5EF4-FFF2-40B4-BE49-F238E27FC236}">
-                <a16:creationId xmlns:a16="http://schemas.microsoft.com/office/drawing/2014/main" id="{E30A121C-2DE9-42E7-A8AF-1013908BE169}"/>
+                <a16:creationId xmlns:a16="http://schemas.microsoft.com/office/drawing/2014/main" id="{4EC356ED-D1CC-4EB9-A913-482C7A345E48}"/>
               </a:ext>
             </a:extLst>
           </p:cNvPr>
@@ -9607,7 +9614,7 @@
           <p:cNvPr id="4" name="">
             <a:extLst xmlns:a="http://schemas.openxmlformats.org/drawingml/2006/main">
               <a:ext uri="{FF2B5EF4-FFF2-40B4-BE49-F238E27FC236}">
-                <a16:creationId xmlns:a16="http://schemas.microsoft.com/office/drawing/2014/main" id="{B5409FD9-D345-4E9D-90EF-5B5CFF8E6D6B}"/>
+                <a16:creationId xmlns:a16="http://schemas.microsoft.com/office/drawing/2014/main" id="{285C202D-DFB0-4444-A7E3-F36BC9FC8B37}"/>
               </a:ext>
             </a:extLst>
           </p:cNvPr>
@@ -9766,7 +9773,7 @@
           <p:cNvPr id="5" name="">
             <a:extLst xmlns:a="http://schemas.openxmlformats.org/drawingml/2006/main">
               <a:ext uri="{FF2B5EF4-FFF2-40B4-BE49-F238E27FC236}">
-                <a16:creationId xmlns:a16="http://schemas.microsoft.com/office/drawing/2014/main" id="{228E8E13-302E-4C05-8282-2786C929389E}"/>
+                <a16:creationId xmlns:a16="http://schemas.microsoft.com/office/drawing/2014/main" id="{39064DE1-C6CE-4749-B298-4ACEAE5AEBDB}"/>
               </a:ext>
             </a:extLst>
           </p:cNvPr>
@@ -9925,7 +9932,7 @@
           <p:cNvPr id="6" name="">
             <a:extLst xmlns:a="http://schemas.openxmlformats.org/drawingml/2006/main">
               <a:ext uri="{FF2B5EF4-FFF2-40B4-BE49-F238E27FC236}">
-                <a16:creationId xmlns:a16="http://schemas.microsoft.com/office/drawing/2014/main" id="{65ACF0CF-7049-4384-BA8A-285EC7B68A4C}"/>
+                <a16:creationId xmlns:a16="http://schemas.microsoft.com/office/drawing/2014/main" id="{FCF5B86F-EDC2-46B9-AC03-ECE6C92D9BC5}"/>
               </a:ext>
             </a:extLst>
           </p:cNvPr>
@@ -9935,19 +9942,19 @@
           <p:nvPr/>
         </p:nvPicPr>
         <p:blipFill>
-          <a:blip xmlns:r="http://schemas.openxmlformats.org/officeDocument/2006/relationships" xmlns:a="http://schemas.openxmlformats.org/drawingml/2006/main" r:embed="Rcc29f63444ee484a"/>
-          <a:srcRect xmlns:a="http://schemas.openxmlformats.org/drawingml/2006/main" l="89" t="0" r="89" b="0"/>
-          <a:stretch xmlns:a="http://schemas.openxmlformats.org/drawingml/2006/main">
-            <a:fillRect l="0" t="0" r="0" b="0"/>
-          </a:stretch>
+          <a:blip xmlns:r="http://schemas.openxmlformats.org/officeDocument/2006/relationships" xmlns:a="http://schemas.openxmlformats.org/drawingml/2006/main" r:embed="R38771c19ec8d43af"/>
+          <a:srcRect xmlns:a="http://schemas.openxmlformats.org/drawingml/2006/main" l="0" t="3000" r="0" b="39000"/>
+          <a:stretch xmlns:a="http://schemas.openxmlformats.org/drawingml/2006/main"/>
         </p:blipFill>
         <p:spPr>
           <a:xfrm xmlns:a="http://schemas.openxmlformats.org/drawingml/2006/main">
-            <a:off x="590550" y="2266950"/>
-            <a:ext cx="11010900" cy="2771775"/>
+            <a:off x="857250" y="2266950"/>
+            <a:ext cx="3429000" cy="4000500"/>
           </a:xfrm>
-          <a:prstGeom xmlns:a="http://schemas.openxmlformats.org/drawingml/2006/main" prst="rect">
-            <a:avLst/>
+          <a:prstGeom xmlns:a="http://schemas.openxmlformats.org/drawingml/2006/main" prst="roundRect">
+            <a:avLst>
+              <a:gd name="adj" fmla="val 4444"/>
+            </a:avLst>
           </a:prstGeom>
         </p:spPr>
       </p:pic>
@@ -9956,7 +9963,7 @@
           <p:cNvPr id="7" name="">
             <a:extLst xmlns:a="http://schemas.openxmlformats.org/drawingml/2006/main">
               <a:ext uri="{FF2B5EF4-FFF2-40B4-BE49-F238E27FC236}">
-                <a16:creationId xmlns:a16="http://schemas.microsoft.com/office/drawing/2014/main" id="{4DDFDBC0-75F2-4360-83B0-9BECBF6B8581}"/>
+                <a16:creationId xmlns:a16="http://schemas.microsoft.com/office/drawing/2014/main" id="{40B0CD8B-6F4E-4A7A-AF50-702ED541B2F4}"/>
               </a:ext>
             </a:extLst>
           </p:cNvPr>
@@ -9967,8 +9974,8 @@
         </p:nvSpPr>
         <p:spPr>
           <a:xfrm xmlns:a="http://schemas.openxmlformats.org/drawingml/2006/main">
-            <a:off x="704850" y="5314950"/>
-            <a:ext cx="2095500" cy="266700"/>
+            <a:off x="5334000" y="2476500"/>
+            <a:ext cx="4953000" cy="438150"/>
           </a:xfrm>
           <a:prstGeom xmlns:a="http://schemas.openxmlformats.org/drawingml/2006/main" prst="rect">
             <a:avLst/>
@@ -9985,9 +9992,9 @@
           </a:bodyPr>
           <a:lstStyle xmlns:a="http://schemas.openxmlformats.org/drawingml/2006/main">
             <a:defPPr>
-              <a:defRPr sz="1350" b="1">
-                <a:solidFill>
-                  <a:srgbClr val="D8A4F2"/>
+              <a:defRPr sz="2325" b="1">
+                <a:solidFill>
+                  <a:srgbClr val="F4F1FA"/>
                 </a:solidFill>
                 <a:latin typeface="Figtree"/>
                 <a:ea typeface="Figtree"/>
@@ -9995,9 +10002,9 @@
               </a:defRPr>
             </a:defPPr>
             <a:lvl1pPr>
-              <a:defRPr sz="1350" b="1">
-                <a:solidFill>
-                  <a:srgbClr val="D8A4F2"/>
+              <a:defRPr sz="2325" b="1">
+                <a:solidFill>
+                  <a:srgbClr val="F4F1FA"/>
                 </a:solidFill>
                 <a:latin typeface="Figtree"/>
                 <a:ea typeface="Figtree"/>
@@ -10005,9 +10012,9 @@
               </a:defRPr>
             </a:lvl1pPr>
             <a:lvl2pPr>
-              <a:defRPr sz="1350" b="1">
-                <a:solidFill>
-                  <a:srgbClr val="D8A4F2"/>
+              <a:defRPr sz="2325" b="1">
+                <a:solidFill>
+                  <a:srgbClr val="F4F1FA"/>
                 </a:solidFill>
                 <a:latin typeface="Figtree"/>
                 <a:ea typeface="Figtree"/>
@@ -10015,9 +10022,9 @@
               </a:defRPr>
             </a:lvl2pPr>
             <a:lvl3pPr>
-              <a:defRPr sz="1350" b="1">
-                <a:solidFill>
-                  <a:srgbClr val="D8A4F2"/>
+              <a:defRPr sz="2325" b="1">
+                <a:solidFill>
+                  <a:srgbClr val="F4F1FA"/>
                 </a:solidFill>
                 <a:latin typeface="Figtree"/>
                 <a:ea typeface="Figtree"/>
@@ -10025,9 +10032,9 @@
               </a:defRPr>
             </a:lvl3pPr>
             <a:lvl4pPr>
-              <a:defRPr sz="1350" b="1">
-                <a:solidFill>
-                  <a:srgbClr val="D8A4F2"/>
+              <a:defRPr sz="2325" b="1">
+                <a:solidFill>
+                  <a:srgbClr val="F4F1FA"/>
                 </a:solidFill>
                 <a:latin typeface="Figtree"/>
                 <a:ea typeface="Figtree"/>
@@ -10035,9 +10042,9 @@
               </a:defRPr>
             </a:lvl4pPr>
             <a:lvl5pPr>
-              <a:defRPr sz="1350" b="1">
-                <a:solidFill>
-                  <a:srgbClr val="D8A4F2"/>
+              <a:defRPr sz="2325" b="1">
+                <a:solidFill>
+                  <a:srgbClr val="F4F1FA"/>
                 </a:solidFill>
                 <a:latin typeface="Figtree"/>
                 <a:ea typeface="Figtree"/>
@@ -10045,9 +10052,9 @@
               </a:defRPr>
             </a:lvl5pPr>
             <a:lvl6pPr>
-              <a:defRPr sz="1350" b="1">
-                <a:solidFill>
-                  <a:srgbClr val="D8A4F2"/>
+              <a:defRPr sz="2325" b="1">
+                <a:solidFill>
+                  <a:srgbClr val="F4F1FA"/>
                 </a:solidFill>
                 <a:latin typeface="Figtree"/>
                 <a:ea typeface="Figtree"/>
@@ -10055,9 +10062,9 @@
               </a:defRPr>
             </a:lvl6pPr>
             <a:lvl7pPr>
-              <a:defRPr sz="1350" b="1">
-                <a:solidFill>
-                  <a:srgbClr val="D8A4F2"/>
+              <a:defRPr sz="2325" b="1">
+                <a:solidFill>
+                  <a:srgbClr val="F4F1FA"/>
                 </a:solidFill>
                 <a:latin typeface="Figtree"/>
                 <a:ea typeface="Figtree"/>
@@ -10065,9 +10072,9 @@
               </a:defRPr>
             </a:lvl7pPr>
             <a:lvl8pPr>
-              <a:defRPr sz="1350" b="1">
-                <a:solidFill>
-                  <a:srgbClr val="D8A4F2"/>
+              <a:defRPr sz="2325" b="1">
+                <a:solidFill>
+                  <a:srgbClr val="F4F1FA"/>
                 </a:solidFill>
                 <a:latin typeface="Figtree"/>
                 <a:ea typeface="Figtree"/>
@@ -10075,9 +10082,9 @@
               </a:defRPr>
             </a:lvl8pPr>
             <a:lvl9pPr>
-              <a:defRPr sz="1350" b="1">
-                <a:solidFill>
-                  <a:srgbClr val="D8A4F2"/>
+              <a:defRPr sz="2325" b="1">
+                <a:solidFill>
+                  <a:srgbClr val="F4F1FA"/>
                 </a:solidFill>
                 <a:latin typeface="Figtree"/>
                 <a:ea typeface="Figtree"/>
@@ -10087,9 +10094,9 @@
           </a:lstStyle>
           <a:p xmlns:a="http://schemas.openxmlformats.org/drawingml/2006/main">
             <a:pPr>
-              <a:defRPr sz="1350" b="1">
-                <a:solidFill>
-                  <a:srgbClr val="D8A4F2"/>
+              <a:defRPr sz="2325" b="1">
+                <a:solidFill>
+                  <a:srgbClr val="F4F1FA"/>
                 </a:solidFill>
                 <a:latin typeface="Figtree"/>
                 <a:ea typeface="Figtree"/>
@@ -10097,15 +10104,15 @@
               </a:defRPr>
             </a:pPr>
             <a:r>
-              <a:rPr sz="1350" b="1">
-                <a:solidFill>
-                  <a:srgbClr val="D8A4F2"/>
+              <a:rPr sz="2325" b="1">
+                <a:solidFill>
+                  <a:srgbClr val="F4F1FA"/>
                 </a:solidFill>
                 <a:latin typeface="Figtree"/>
                 <a:ea typeface="Figtree"/>
                 <a:cs typeface="Figtree"/>
               </a:rPr>
-              <a:t>Muy desagradable</a:t>
+              <a:t>Una escala con matices</a:t>
             </a:r>
           </a:p>
         </p:txBody>
@@ -10115,7 +10122,7 @@
           <p:cNvPr id="8" name="">
             <a:extLst xmlns:a="http://schemas.openxmlformats.org/drawingml/2006/main">
               <a:ext uri="{FF2B5EF4-FFF2-40B4-BE49-F238E27FC236}">
-                <a16:creationId xmlns:a16="http://schemas.microsoft.com/office/drawing/2014/main" id="{04793688-8DDC-44AE-887C-26D56311D115}"/>
+                <a16:creationId xmlns:a16="http://schemas.microsoft.com/office/drawing/2014/main" id="{88DE5170-5A54-4B67-A36B-AA7D4332C6C7}"/>
               </a:ext>
             </a:extLst>
           </p:cNvPr>
@@ -10126,8 +10133,8 @@
         </p:nvSpPr>
         <p:spPr>
           <a:xfrm xmlns:a="http://schemas.openxmlformats.org/drawingml/2006/main">
-            <a:off x="5010150" y="5314950"/>
-            <a:ext cx="2095500" cy="266700"/>
+            <a:off x="5334000" y="3105150"/>
+            <a:ext cx="2857500" cy="2400300"/>
           </a:xfrm>
           <a:prstGeom xmlns:a="http://schemas.openxmlformats.org/drawingml/2006/main" prst="rect">
             <a:avLst/>
@@ -10144,9 +10151,9 @@
           </a:bodyPr>
           <a:lstStyle xmlns:a="http://schemas.openxmlformats.org/drawingml/2006/main">
             <a:defPPr>
-              <a:defRPr sz="1350" b="1">
-                <a:solidFill>
-                  <a:srgbClr val="8EE2DF"/>
+              <a:defRPr sz="1725" b="1">
+                <a:solidFill>
+                  <a:srgbClr val="F6C2CF"/>
                 </a:solidFill>
                 <a:latin typeface="Figtree"/>
                 <a:ea typeface="Figtree"/>
@@ -10154,9 +10161,9 @@
               </a:defRPr>
             </a:defPPr>
             <a:lvl1pPr>
-              <a:defRPr sz="1350" b="1">
-                <a:solidFill>
-                  <a:srgbClr val="8EE2DF"/>
+              <a:defRPr sz="1725" b="1">
+                <a:solidFill>
+                  <a:srgbClr val="F6C2CF"/>
                 </a:solidFill>
                 <a:latin typeface="Figtree"/>
                 <a:ea typeface="Figtree"/>
@@ -10164,9 +10171,9 @@
               </a:defRPr>
             </a:lvl1pPr>
             <a:lvl2pPr>
-              <a:defRPr sz="1350" b="1">
-                <a:solidFill>
-                  <a:srgbClr val="8EE2DF"/>
+              <a:defRPr sz="1725" b="1">
+                <a:solidFill>
+                  <a:srgbClr val="F6C2CF"/>
                 </a:solidFill>
                 <a:latin typeface="Figtree"/>
                 <a:ea typeface="Figtree"/>
@@ -10174,9 +10181,9 @@
               </a:defRPr>
             </a:lvl2pPr>
             <a:lvl3pPr>
-              <a:defRPr sz="1350" b="1">
-                <a:solidFill>
-                  <a:srgbClr val="8EE2DF"/>
+              <a:defRPr sz="1725" b="1">
+                <a:solidFill>
+                  <a:srgbClr val="F6C2CF"/>
                 </a:solidFill>
                 <a:latin typeface="Figtree"/>
                 <a:ea typeface="Figtree"/>
@@ -10184,9 +10191,9 @@
               </a:defRPr>
             </a:lvl3pPr>
             <a:lvl4pPr>
-              <a:defRPr sz="1350" b="1">
-                <a:solidFill>
-                  <a:srgbClr val="8EE2DF"/>
+              <a:defRPr sz="1725" b="1">
+                <a:solidFill>
+                  <a:srgbClr val="F6C2CF"/>
                 </a:solidFill>
                 <a:latin typeface="Figtree"/>
                 <a:ea typeface="Figtree"/>
@@ -10194,9 +10201,9 @@
               </a:defRPr>
             </a:lvl4pPr>
             <a:lvl5pPr>
-              <a:defRPr sz="1350" b="1">
-                <a:solidFill>
-                  <a:srgbClr val="8EE2DF"/>
+              <a:defRPr sz="1725" b="1">
+                <a:solidFill>
+                  <a:srgbClr val="F6C2CF"/>
                 </a:solidFill>
                 <a:latin typeface="Figtree"/>
                 <a:ea typeface="Figtree"/>
@@ -10204,9 +10211,9 @@
               </a:defRPr>
             </a:lvl5pPr>
             <a:lvl6pPr>
-              <a:defRPr sz="1350" b="1">
-                <a:solidFill>
-                  <a:srgbClr val="8EE2DF"/>
+              <a:defRPr sz="1725" b="1">
+                <a:solidFill>
+                  <a:srgbClr val="F6C2CF"/>
                 </a:solidFill>
                 <a:latin typeface="Figtree"/>
                 <a:ea typeface="Figtree"/>
@@ -10214,9 +10221,9 @@
               </a:defRPr>
             </a:lvl6pPr>
             <a:lvl7pPr>
-              <a:defRPr sz="1350" b="1">
-                <a:solidFill>
-                  <a:srgbClr val="8EE2DF"/>
+              <a:defRPr sz="1725" b="1">
+                <a:solidFill>
+                  <a:srgbClr val="F6C2CF"/>
                 </a:solidFill>
                 <a:latin typeface="Figtree"/>
                 <a:ea typeface="Figtree"/>
@@ -10224,9 +10231,9 @@
               </a:defRPr>
             </a:lvl7pPr>
             <a:lvl8pPr>
-              <a:defRPr sz="1350" b="1">
-                <a:solidFill>
-                  <a:srgbClr val="8EE2DF"/>
+              <a:defRPr sz="1725" b="1">
+                <a:solidFill>
+                  <a:srgbClr val="F6C2CF"/>
                 </a:solidFill>
                 <a:latin typeface="Figtree"/>
                 <a:ea typeface="Figtree"/>
@@ -10234,9 +10241,9 @@
               </a:defRPr>
             </a:lvl8pPr>
             <a:lvl9pPr>
-              <a:defRPr sz="1350" b="1">
-                <a:solidFill>
-                  <a:srgbClr val="8EE2DF"/>
+              <a:defRPr sz="1725" b="1">
+                <a:solidFill>
+                  <a:srgbClr val="F6C2CF"/>
                 </a:solidFill>
                 <a:latin typeface="Figtree"/>
                 <a:ea typeface="Figtree"/>
@@ -10246,9 +10253,9 @@
           </a:lstStyle>
           <a:p xmlns:a="http://schemas.openxmlformats.org/drawingml/2006/main">
             <a:pPr>
-              <a:defRPr sz="1350" b="1">
-                <a:solidFill>
-                  <a:srgbClr val="8EE2DF"/>
+              <a:defRPr sz="1725" b="1">
+                <a:solidFill>
+                  <a:srgbClr val="F6C2CF"/>
                 </a:solidFill>
                 <a:latin typeface="Figtree"/>
                 <a:ea typeface="Figtree"/>
@@ -10256,15 +10263,153 @@
               </a:defRPr>
             </a:pPr>
             <a:r>
-              <a:rPr sz="1350" b="1">
-                <a:solidFill>
-                  <a:srgbClr val="8EE2DF"/>
+              <a:rPr sz="1725" b="1">
+                <a:solidFill>
+                  <a:srgbClr val="F6C2CF"/>
+                </a:solidFill>
+                <a:latin typeface="Figtree"/>
+                <a:ea typeface="Figtree"/>
+                <a:cs typeface="Figtree"/>
+              </a:rPr>
+              <a:t>Muy desagradable</a:t>
+            </a:r>
+          </a:p>
+          <a:p xmlns:a="http://schemas.openxmlformats.org/drawingml/2006/main">
+            <a:pPr>
+              <a:defRPr sz="1725" b="1">
+                <a:solidFill>
+                  <a:srgbClr val="F6C2CF"/>
+                </a:solidFill>
+                <a:latin typeface="Figtree"/>
+                <a:ea typeface="Figtree"/>
+                <a:cs typeface="Figtree"/>
+              </a:defRPr>
+            </a:pPr>
+            <a:r>
+              <a:rPr sz="1725" b="1">
+                <a:solidFill>
+                  <a:srgbClr val="F6C2CF"/>
+                </a:solidFill>
+                <a:latin typeface="Figtree"/>
+                <a:ea typeface="Figtree"/>
+                <a:cs typeface="Figtree"/>
+              </a:rPr>
+              <a:t>Desagradable</a:t>
+            </a:r>
+          </a:p>
+          <a:p xmlns:a="http://schemas.openxmlformats.org/drawingml/2006/main">
+            <a:pPr>
+              <a:defRPr sz="1725" b="1">
+                <a:solidFill>
+                  <a:srgbClr val="F6C2CF"/>
+                </a:solidFill>
+                <a:latin typeface="Figtree"/>
+                <a:ea typeface="Figtree"/>
+                <a:cs typeface="Figtree"/>
+              </a:defRPr>
+            </a:pPr>
+            <a:r>
+              <a:rPr sz="1725" b="1">
+                <a:solidFill>
+                  <a:srgbClr val="F6C2CF"/>
+                </a:solidFill>
+                <a:latin typeface="Figtree"/>
+                <a:ea typeface="Figtree"/>
+                <a:cs typeface="Figtree"/>
+              </a:rPr>
+              <a:t>Algo desagradable</a:t>
+            </a:r>
+          </a:p>
+          <a:p xmlns:a="http://schemas.openxmlformats.org/drawingml/2006/main">
+            <a:pPr>
+              <a:defRPr sz="1725" b="1">
+                <a:solidFill>
+                  <a:srgbClr val="F6C2CF"/>
+                </a:solidFill>
+                <a:latin typeface="Figtree"/>
+                <a:ea typeface="Figtree"/>
+                <a:cs typeface="Figtree"/>
+              </a:defRPr>
+            </a:pPr>
+            <a:r>
+              <a:rPr sz="1725" b="1">
+                <a:solidFill>
+                  <a:srgbClr val="F6C2CF"/>
                 </a:solidFill>
                 <a:latin typeface="Figtree"/>
                 <a:ea typeface="Figtree"/>
                 <a:cs typeface="Figtree"/>
               </a:rPr>
               <a:t>Neutral</a:t>
+            </a:r>
+          </a:p>
+          <a:p xmlns:a="http://schemas.openxmlformats.org/drawingml/2006/main">
+            <a:pPr>
+              <a:defRPr sz="1725" b="1">
+                <a:solidFill>
+                  <a:srgbClr val="F6C2CF"/>
+                </a:solidFill>
+                <a:latin typeface="Figtree"/>
+                <a:ea typeface="Figtree"/>
+                <a:cs typeface="Figtree"/>
+              </a:defRPr>
+            </a:pPr>
+            <a:r>
+              <a:rPr sz="1725" b="1">
+                <a:solidFill>
+                  <a:srgbClr val="F6C2CF"/>
+                </a:solidFill>
+                <a:latin typeface="Figtree"/>
+                <a:ea typeface="Figtree"/>
+                <a:cs typeface="Figtree"/>
+              </a:rPr>
+              <a:t>Algo agradable</a:t>
+            </a:r>
+          </a:p>
+          <a:p xmlns:a="http://schemas.openxmlformats.org/drawingml/2006/main">
+            <a:pPr>
+              <a:defRPr sz="1725" b="1">
+                <a:solidFill>
+                  <a:srgbClr val="F6C2CF"/>
+                </a:solidFill>
+                <a:latin typeface="Figtree"/>
+                <a:ea typeface="Figtree"/>
+                <a:cs typeface="Figtree"/>
+              </a:defRPr>
+            </a:pPr>
+            <a:r>
+              <a:rPr sz="1725" b="1">
+                <a:solidFill>
+                  <a:srgbClr val="F6C2CF"/>
+                </a:solidFill>
+                <a:latin typeface="Figtree"/>
+                <a:ea typeface="Figtree"/>
+                <a:cs typeface="Figtree"/>
+              </a:rPr>
+              <a:t>Agradable</a:t>
+            </a:r>
+          </a:p>
+          <a:p xmlns:a="http://schemas.openxmlformats.org/drawingml/2006/main">
+            <a:pPr>
+              <a:defRPr sz="1725" b="1">
+                <a:solidFill>
+                  <a:srgbClr val="F6C2CF"/>
+                </a:solidFill>
+                <a:latin typeface="Figtree"/>
+                <a:ea typeface="Figtree"/>
+                <a:cs typeface="Figtree"/>
+              </a:defRPr>
+            </a:pPr>
+            <a:r>
+              <a:rPr sz="1725" b="1">
+                <a:solidFill>
+                  <a:srgbClr val="F6C2CF"/>
+                </a:solidFill>
+                <a:latin typeface="Figtree"/>
+                <a:ea typeface="Figtree"/>
+                <a:cs typeface="Figtree"/>
+              </a:rPr>
+              <a:t>Muy agradable</a:t>
             </a:r>
           </a:p>
         </p:txBody>
@@ -10274,7 +10419,7 @@
           <p:cNvPr id="9" name="">
             <a:extLst xmlns:a="http://schemas.openxmlformats.org/drawingml/2006/main">
               <a:ext uri="{FF2B5EF4-FFF2-40B4-BE49-F238E27FC236}">
-                <a16:creationId xmlns:a16="http://schemas.microsoft.com/office/drawing/2014/main" id="{D4A4C375-7030-4015-AED3-F7D02B0A978C}"/>
+                <a16:creationId xmlns:a16="http://schemas.microsoft.com/office/drawing/2014/main" id="{B4EFB529-A415-46E5-A94C-7A0FB8BC7CEA}"/>
               </a:ext>
             </a:extLst>
           </p:cNvPr>
@@ -10285,167 +10430,8 @@
         </p:nvSpPr>
         <p:spPr>
           <a:xfrm xmlns:a="http://schemas.openxmlformats.org/drawingml/2006/main">
-            <a:off x="9391650" y="5314950"/>
-            <a:ext cx="2095500" cy="266700"/>
-          </a:xfrm>
-          <a:prstGeom xmlns:a="http://schemas.openxmlformats.org/drawingml/2006/main" prst="rect">
-            <a:avLst/>
-          </a:prstGeom>
-          <a:noFill xmlns:a="http://schemas.openxmlformats.org/drawingml/2006/main"/>
-          <a:ln xmlns:a="http://schemas.openxmlformats.org/drawingml/2006/main" w="0">
-            <a:noFill/>
-            <a:prstDash val="solid"/>
-          </a:ln>
-        </p:spPr>
-        <p:txBody>
-          <a:bodyPr xmlns:a="http://schemas.openxmlformats.org/drawingml/2006/main">
-            <a:noAutofit/>
-          </a:bodyPr>
-          <a:lstStyle xmlns:a="http://schemas.openxmlformats.org/drawingml/2006/main">
-            <a:defPPr>
-              <a:defRPr sz="1350" b="1">
-                <a:solidFill>
-                  <a:srgbClr val="F6C2CF"/>
-                </a:solidFill>
-                <a:latin typeface="Figtree"/>
-                <a:ea typeface="Figtree"/>
-                <a:cs typeface="Figtree"/>
-              </a:defRPr>
-            </a:defPPr>
-            <a:lvl1pPr>
-              <a:defRPr sz="1350" b="1">
-                <a:solidFill>
-                  <a:srgbClr val="F6C2CF"/>
-                </a:solidFill>
-                <a:latin typeface="Figtree"/>
-                <a:ea typeface="Figtree"/>
-                <a:cs typeface="Figtree"/>
-              </a:defRPr>
-            </a:lvl1pPr>
-            <a:lvl2pPr>
-              <a:defRPr sz="1350" b="1">
-                <a:solidFill>
-                  <a:srgbClr val="F6C2CF"/>
-                </a:solidFill>
-                <a:latin typeface="Figtree"/>
-                <a:ea typeface="Figtree"/>
-                <a:cs typeface="Figtree"/>
-              </a:defRPr>
-            </a:lvl2pPr>
-            <a:lvl3pPr>
-              <a:defRPr sz="1350" b="1">
-                <a:solidFill>
-                  <a:srgbClr val="F6C2CF"/>
-                </a:solidFill>
-                <a:latin typeface="Figtree"/>
-                <a:ea typeface="Figtree"/>
-                <a:cs typeface="Figtree"/>
-              </a:defRPr>
-            </a:lvl3pPr>
-            <a:lvl4pPr>
-              <a:defRPr sz="1350" b="1">
-                <a:solidFill>
-                  <a:srgbClr val="F6C2CF"/>
-                </a:solidFill>
-                <a:latin typeface="Figtree"/>
-                <a:ea typeface="Figtree"/>
-                <a:cs typeface="Figtree"/>
-              </a:defRPr>
-            </a:lvl4pPr>
-            <a:lvl5pPr>
-              <a:defRPr sz="1350" b="1">
-                <a:solidFill>
-                  <a:srgbClr val="F6C2CF"/>
-                </a:solidFill>
-                <a:latin typeface="Figtree"/>
-                <a:ea typeface="Figtree"/>
-                <a:cs typeface="Figtree"/>
-              </a:defRPr>
-            </a:lvl5pPr>
-            <a:lvl6pPr>
-              <a:defRPr sz="1350" b="1">
-                <a:solidFill>
-                  <a:srgbClr val="F6C2CF"/>
-                </a:solidFill>
-                <a:latin typeface="Figtree"/>
-                <a:ea typeface="Figtree"/>
-                <a:cs typeface="Figtree"/>
-              </a:defRPr>
-            </a:lvl6pPr>
-            <a:lvl7pPr>
-              <a:defRPr sz="1350" b="1">
-                <a:solidFill>
-                  <a:srgbClr val="F6C2CF"/>
-                </a:solidFill>
-                <a:latin typeface="Figtree"/>
-                <a:ea typeface="Figtree"/>
-                <a:cs typeface="Figtree"/>
-              </a:defRPr>
-            </a:lvl7pPr>
-            <a:lvl8pPr>
-              <a:defRPr sz="1350" b="1">
-                <a:solidFill>
-                  <a:srgbClr val="F6C2CF"/>
-                </a:solidFill>
-                <a:latin typeface="Figtree"/>
-                <a:ea typeface="Figtree"/>
-                <a:cs typeface="Figtree"/>
-              </a:defRPr>
-            </a:lvl8pPr>
-            <a:lvl9pPr>
-              <a:defRPr sz="1350" b="1">
-                <a:solidFill>
-                  <a:srgbClr val="F6C2CF"/>
-                </a:solidFill>
-                <a:latin typeface="Figtree"/>
-                <a:ea typeface="Figtree"/>
-                <a:cs typeface="Figtree"/>
-              </a:defRPr>
-            </a:lvl9pPr>
-          </a:lstStyle>
-          <a:p xmlns:a="http://schemas.openxmlformats.org/drawingml/2006/main">
-            <a:pPr>
-              <a:defRPr sz="1350" b="1">
-                <a:solidFill>
-                  <a:srgbClr val="F6C2CF"/>
-                </a:solidFill>
-                <a:latin typeface="Figtree"/>
-                <a:ea typeface="Figtree"/>
-                <a:cs typeface="Figtree"/>
-              </a:defRPr>
-            </a:pPr>
-            <a:r>
-              <a:rPr sz="1350" b="1">
-                <a:solidFill>
-                  <a:srgbClr val="F6C2CF"/>
-                </a:solidFill>
-                <a:latin typeface="Figtree"/>
-                <a:ea typeface="Figtree"/>
-                <a:cs typeface="Figtree"/>
-              </a:rPr>
-              <a:t>Muy agradable</a:t>
-            </a:r>
-          </a:p>
-        </p:txBody>
-      </p:sp>
-      <p:sp>
-        <p:nvSpPr>
-          <p:cNvPr id="10" name="">
-            <a:extLst xmlns:a="http://schemas.openxmlformats.org/drawingml/2006/main">
-              <a:ext uri="{FF2B5EF4-FFF2-40B4-BE49-F238E27FC236}">
-                <a16:creationId xmlns:a16="http://schemas.microsoft.com/office/drawing/2014/main" id="{F9F77DF1-EBE7-402D-9CBE-E19AF39DC794}"/>
-              </a:ext>
-            </a:extLst>
-          </p:cNvPr>
-          <p:cNvSpPr>
-            <a:spLocks xmlns:a="http://schemas.openxmlformats.org/drawingml/2006/main" noGrp="1"/>
-          </p:cNvSpPr>
-          <p:nvPr/>
-        </p:nvSpPr>
-        <p:spPr>
-          <a:xfrm xmlns:a="http://schemas.openxmlformats.org/drawingml/2006/main">
-            <a:off x="2000250" y="5848350"/>
-            <a:ext cx="8191500" cy="514350"/>
+            <a:off x="8334375" y="3105150"/>
+            <a:ext cx="2857500" cy="1447800"/>
           </a:xfrm>
           <a:prstGeom xmlns:a="http://schemas.openxmlformats.org/drawingml/2006/main" prst="rect">
             <a:avLst/>
@@ -10582,7 +10568,166 @@
                 <a:ea typeface="Figtree"/>
                 <a:cs typeface="Figtree"/>
               </a:rPr>
-              <a:t>Cada estado vale por sí mismo. La interfaz evita felicitar los estados agradables o reprochar los difíciles.</a:t>
+              <a:t>Cada estado vale por sí mismo. La interfaz evita premiar los estados agradables o reprochar los difíciles.</a:t>
+            </a:r>
+          </a:p>
+        </p:txBody>
+      </p:sp>
+      <p:sp>
+        <p:nvSpPr>
+          <p:cNvPr id="10" name="">
+            <a:extLst xmlns:a="http://schemas.openxmlformats.org/drawingml/2006/main">
+              <a:ext uri="{FF2B5EF4-FFF2-40B4-BE49-F238E27FC236}">
+                <a16:creationId xmlns:a16="http://schemas.microsoft.com/office/drawing/2014/main" id="{A8C62D93-84F4-4CAE-87ED-9AFF5F3E9AF0}"/>
+              </a:ext>
+            </a:extLst>
+          </p:cNvPr>
+          <p:cNvSpPr>
+            <a:spLocks xmlns:a="http://schemas.openxmlformats.org/drawingml/2006/main" noGrp="1"/>
+          </p:cNvSpPr>
+          <p:nvPr/>
+        </p:nvSpPr>
+        <p:spPr>
+          <a:xfrm xmlns:a="http://schemas.openxmlformats.org/drawingml/2006/main">
+            <a:off x="8334375" y="4819650"/>
+            <a:ext cx="2857500" cy="1104900"/>
+          </a:xfrm>
+          <a:prstGeom xmlns:a="http://schemas.openxmlformats.org/drawingml/2006/main" prst="rect">
+            <a:avLst/>
+          </a:prstGeom>
+          <a:noFill xmlns:a="http://schemas.openxmlformats.org/drawingml/2006/main"/>
+          <a:ln xmlns:a="http://schemas.openxmlformats.org/drawingml/2006/main" w="0">
+            <a:noFill/>
+            <a:prstDash val="solid"/>
+          </a:ln>
+        </p:spPr>
+        <p:txBody>
+          <a:bodyPr xmlns:a="http://schemas.openxmlformats.org/drawingml/2006/main">
+            <a:noAutofit/>
+          </a:bodyPr>
+          <a:lstStyle xmlns:a="http://schemas.openxmlformats.org/drawingml/2006/main">
+            <a:defPPr>
+              <a:defRPr sz="1500" b="0">
+                <a:solidFill>
+                  <a:srgbClr val="F4F1FA"/>
+                </a:solidFill>
+                <a:latin typeface="Figtree"/>
+                <a:ea typeface="Figtree"/>
+                <a:cs typeface="Figtree"/>
+              </a:defRPr>
+            </a:defPPr>
+            <a:lvl1pPr>
+              <a:defRPr sz="1500" b="0">
+                <a:solidFill>
+                  <a:srgbClr val="F4F1FA"/>
+                </a:solidFill>
+                <a:latin typeface="Figtree"/>
+                <a:ea typeface="Figtree"/>
+                <a:cs typeface="Figtree"/>
+              </a:defRPr>
+            </a:lvl1pPr>
+            <a:lvl2pPr>
+              <a:defRPr sz="1500" b="0">
+                <a:solidFill>
+                  <a:srgbClr val="F4F1FA"/>
+                </a:solidFill>
+                <a:latin typeface="Figtree"/>
+                <a:ea typeface="Figtree"/>
+                <a:cs typeface="Figtree"/>
+              </a:defRPr>
+            </a:lvl2pPr>
+            <a:lvl3pPr>
+              <a:defRPr sz="1500" b="0">
+                <a:solidFill>
+                  <a:srgbClr val="F4F1FA"/>
+                </a:solidFill>
+                <a:latin typeface="Figtree"/>
+                <a:ea typeface="Figtree"/>
+                <a:cs typeface="Figtree"/>
+              </a:defRPr>
+            </a:lvl3pPr>
+            <a:lvl4pPr>
+              <a:defRPr sz="1500" b="0">
+                <a:solidFill>
+                  <a:srgbClr val="F4F1FA"/>
+                </a:solidFill>
+                <a:latin typeface="Figtree"/>
+                <a:ea typeface="Figtree"/>
+                <a:cs typeface="Figtree"/>
+              </a:defRPr>
+            </a:lvl4pPr>
+            <a:lvl5pPr>
+              <a:defRPr sz="1500" b="0">
+                <a:solidFill>
+                  <a:srgbClr val="F4F1FA"/>
+                </a:solidFill>
+                <a:latin typeface="Figtree"/>
+                <a:ea typeface="Figtree"/>
+                <a:cs typeface="Figtree"/>
+              </a:defRPr>
+            </a:lvl5pPr>
+            <a:lvl6pPr>
+              <a:defRPr sz="1500" b="0">
+                <a:solidFill>
+                  <a:srgbClr val="F4F1FA"/>
+                </a:solidFill>
+                <a:latin typeface="Figtree"/>
+                <a:ea typeface="Figtree"/>
+                <a:cs typeface="Figtree"/>
+              </a:defRPr>
+            </a:lvl6pPr>
+            <a:lvl7pPr>
+              <a:defRPr sz="1500" b="0">
+                <a:solidFill>
+                  <a:srgbClr val="F4F1FA"/>
+                </a:solidFill>
+                <a:latin typeface="Figtree"/>
+                <a:ea typeface="Figtree"/>
+                <a:cs typeface="Figtree"/>
+              </a:defRPr>
+            </a:lvl7pPr>
+            <a:lvl8pPr>
+              <a:defRPr sz="1500" b="0">
+                <a:solidFill>
+                  <a:srgbClr val="F4F1FA"/>
+                </a:solidFill>
+                <a:latin typeface="Figtree"/>
+                <a:ea typeface="Figtree"/>
+                <a:cs typeface="Figtree"/>
+              </a:defRPr>
+            </a:lvl8pPr>
+            <a:lvl9pPr>
+              <a:defRPr sz="1500" b="0">
+                <a:solidFill>
+                  <a:srgbClr val="F4F1FA"/>
+                </a:solidFill>
+                <a:latin typeface="Figtree"/>
+                <a:ea typeface="Figtree"/>
+                <a:cs typeface="Figtree"/>
+              </a:defRPr>
+            </a:lvl9pPr>
+          </a:lstStyle>
+          <a:p xmlns:a="http://schemas.openxmlformats.org/drawingml/2006/main">
+            <a:pPr>
+              <a:defRPr sz="1500" b="0">
+                <a:solidFill>
+                  <a:srgbClr val="F4F1FA"/>
+                </a:solidFill>
+                <a:latin typeface="Figtree"/>
+                <a:ea typeface="Figtree"/>
+                <a:cs typeface="Figtree"/>
+              </a:defRPr>
+            </a:pPr>
+            <a:r>
+              <a:rPr sz="1500" b="0">
+                <a:solidFill>
+                  <a:srgbClr val="F4F1FA"/>
+                </a:solidFill>
+                <a:latin typeface="Figtree"/>
+                <a:ea typeface="Figtree"/>
+                <a:cs typeface="Figtree"/>
+              </a:rPr>
+              <a:t>La escala describe cómo se siente la persona. No funciona como una categoría clínica.</a:t>
             </a:r>
           </a:p>
         </p:txBody>
@@ -10590,7 +10735,7 @@
     </p:spTree>
     <p:extLst>
       <p:ext uri="{BB962C8B-B14F-4D97-AF65-F5344CB8AC3E}">
-        <p14:creationId xmlns:p14="http://schemas.microsoft.com/office/powerpoint/2010/main" val="794455033"/>
+        <p14:creationId xmlns:p14="http://schemas.microsoft.com/office/powerpoint/2010/main" val="1716075880"/>
       </p:ext>
     </p:extLst>
   </p:cSld>
@@ -10621,7 +10766,7 @@
           <p:cNvPr id="13" name="">
             <a:extLst xmlns:a="http://schemas.openxmlformats.org/drawingml/2006/main">
               <a:ext uri="{FF2B5EF4-FFF2-40B4-BE49-F238E27FC236}">
-                <a16:creationId xmlns:a16="http://schemas.microsoft.com/office/drawing/2014/main" id="{7FDFA840-DEA0-479D-924C-3E6BF35FF484}"/>
+                <a16:creationId xmlns:a16="http://schemas.microsoft.com/office/drawing/2014/main" id="{148703D7-B06A-4E13-A261-46332E9BEA40}"/>
               </a:ext>
             </a:extLst>
           </p:cNvPr>
@@ -10780,7 +10925,7 @@
           <p:cNvPr id="2" name="">
             <a:extLst xmlns:a="http://schemas.openxmlformats.org/drawingml/2006/main">
               <a:ext uri="{FF2B5EF4-FFF2-40B4-BE49-F238E27FC236}">
-                <a16:creationId xmlns:a16="http://schemas.microsoft.com/office/drawing/2014/main" id="{F0242E4E-E749-4A8D-9EB5-C9BAD00F4E00}"/>
+                <a16:creationId xmlns:a16="http://schemas.microsoft.com/office/drawing/2014/main" id="{A731A63F-9128-43F4-B652-BED9B38EFD41}"/>
               </a:ext>
             </a:extLst>
           </p:cNvPr>
@@ -10939,7 +11084,7 @@
           <p:cNvPr id="3" name="">
             <a:extLst xmlns:a="http://schemas.openxmlformats.org/drawingml/2006/main">
               <a:ext uri="{FF2B5EF4-FFF2-40B4-BE49-F238E27FC236}">
-                <a16:creationId xmlns:a16="http://schemas.microsoft.com/office/drawing/2014/main" id="{15ABB21E-7BD2-4FF3-8A74-F2BD782AD29E}"/>
+                <a16:creationId xmlns:a16="http://schemas.microsoft.com/office/drawing/2014/main" id="{68114C29-6F1B-46C7-B4F6-AD66AA369466}"/>
               </a:ext>
             </a:extLst>
           </p:cNvPr>
@@ -10970,7 +11115,7 @@
           <p:cNvPr id="4" name="">
             <a:extLst xmlns:a="http://schemas.openxmlformats.org/drawingml/2006/main">
               <a:ext uri="{FF2B5EF4-FFF2-40B4-BE49-F238E27FC236}">
-                <a16:creationId xmlns:a16="http://schemas.microsoft.com/office/drawing/2014/main" id="{463C5AB1-0520-4E4D-BF62-5ECBCEA5C6E9}"/>
+                <a16:creationId xmlns:a16="http://schemas.microsoft.com/office/drawing/2014/main" id="{79AFEEB8-CD5B-49C9-BB62-A5A7AB9F5F94}"/>
               </a:ext>
             </a:extLst>
           </p:cNvPr>
@@ -11129,7 +11274,7 @@
           <p:cNvPr id="5" name="">
             <a:extLst xmlns:a="http://schemas.openxmlformats.org/drawingml/2006/main">
               <a:ext uri="{FF2B5EF4-FFF2-40B4-BE49-F238E27FC236}">
-                <a16:creationId xmlns:a16="http://schemas.microsoft.com/office/drawing/2014/main" id="{AFB0170F-BEEE-4CF2-BD97-EE2D75B0F9E5}"/>
+                <a16:creationId xmlns:a16="http://schemas.microsoft.com/office/drawing/2014/main" id="{CB94328A-2C18-48AA-B1FB-AC7C0197B57C}"/>
               </a:ext>
             </a:extLst>
           </p:cNvPr>
@@ -11288,7 +11433,7 @@
           <p:cNvPr id="6" name="">
             <a:extLst xmlns:a="http://schemas.openxmlformats.org/drawingml/2006/main">
               <a:ext uri="{FF2B5EF4-FFF2-40B4-BE49-F238E27FC236}">
-                <a16:creationId xmlns:a16="http://schemas.microsoft.com/office/drawing/2014/main" id="{59959965-7038-41B7-838F-31E999631418}"/>
+                <a16:creationId xmlns:a16="http://schemas.microsoft.com/office/drawing/2014/main" id="{6C2BFF19-DE32-499E-BE00-7FFB032B30F6}"/>
               </a:ext>
             </a:extLst>
           </p:cNvPr>
@@ -11298,18 +11443,18 @@
           <p:nvPr/>
         </p:nvPicPr>
         <p:blipFill>
-          <a:blip xmlns:r="http://schemas.openxmlformats.org/officeDocument/2006/relationships" xmlns:a="http://schemas.openxmlformats.org/drawingml/2006/main" r:embed="R09635a6a4866453d"/>
-          <a:srcRect xmlns:a="http://schemas.openxmlformats.org/drawingml/2006/main" l="0" t="3000" r="0" b="45000"/>
+          <a:blip xmlns:r="http://schemas.openxmlformats.org/officeDocument/2006/relationships" xmlns:a="http://schemas.openxmlformats.org/drawingml/2006/main" r:embed="R5637e03520c54d2c"/>
+          <a:srcRect xmlns:a="http://schemas.openxmlformats.org/drawingml/2006/main" l="0" t="4000" r="0" b="61000"/>
           <a:stretch xmlns:a="http://schemas.openxmlformats.org/drawingml/2006/main"/>
         </p:blipFill>
         <p:spPr>
           <a:xfrm xmlns:a="http://schemas.openxmlformats.org/drawingml/2006/main">
-            <a:off x="876300" y="2190750"/>
-            <a:ext cx="3714750" cy="4171950"/>
+            <a:off x="876300" y="2571750"/>
+            <a:ext cx="3714750" cy="2857500"/>
           </a:xfrm>
           <a:prstGeom xmlns:a="http://schemas.openxmlformats.org/drawingml/2006/main" prst="roundRect">
             <a:avLst>
-              <a:gd name="adj" fmla="val 4103"/>
+              <a:gd name="adj" fmla="val 5333"/>
             </a:avLst>
           </a:prstGeom>
         </p:spPr>
@@ -11319,7 +11464,7 @@
           <p:cNvPr id="7" name="">
             <a:extLst xmlns:a="http://schemas.openxmlformats.org/drawingml/2006/main">
               <a:ext uri="{FF2B5EF4-FFF2-40B4-BE49-F238E27FC236}">
-                <a16:creationId xmlns:a16="http://schemas.microsoft.com/office/drawing/2014/main" id="{D9C7FE41-0049-415B-AA3B-C555218E3D59}"/>
+                <a16:creationId xmlns:a16="http://schemas.microsoft.com/office/drawing/2014/main" id="{DEBC6848-1089-4E5A-B7E0-4756CDC03AD8}"/>
               </a:ext>
             </a:extLst>
           </p:cNvPr>
@@ -11478,7 +11623,7 @@
           <p:cNvPr id="8" name="">
             <a:extLst xmlns:a="http://schemas.openxmlformats.org/drawingml/2006/main">
               <a:ext uri="{FF2B5EF4-FFF2-40B4-BE49-F238E27FC236}">
-                <a16:creationId xmlns:a16="http://schemas.microsoft.com/office/drawing/2014/main" id="{3EBD597B-0C24-4C95-8FE5-1213B02347D0}"/>
+                <a16:creationId xmlns:a16="http://schemas.microsoft.com/office/drawing/2014/main" id="{6FF258F6-7D5C-4FAD-85FA-44C1F9498C53}"/>
               </a:ext>
             </a:extLst>
           </p:cNvPr>
@@ -11637,7 +11782,7 @@
           <p:cNvPr id="9" name="">
             <a:extLst xmlns:a="http://schemas.openxmlformats.org/drawingml/2006/main">
               <a:ext uri="{FF2B5EF4-FFF2-40B4-BE49-F238E27FC236}">
-                <a16:creationId xmlns:a16="http://schemas.microsoft.com/office/drawing/2014/main" id="{05698449-4268-42B8-9E28-DDD589540792}"/>
+                <a16:creationId xmlns:a16="http://schemas.microsoft.com/office/drawing/2014/main" id="{27027013-D132-4448-AD2A-9ADF283A14DB}"/>
               </a:ext>
             </a:extLst>
           </p:cNvPr>
@@ -11796,7 +11941,7 @@
           <p:cNvPr id="10" name="">
             <a:extLst xmlns:a="http://schemas.openxmlformats.org/drawingml/2006/main">
               <a:ext uri="{FF2B5EF4-FFF2-40B4-BE49-F238E27FC236}">
-                <a16:creationId xmlns:a16="http://schemas.microsoft.com/office/drawing/2014/main" id="{09213170-AB6F-41E0-BFB1-998C640E2CBF}"/>
+                <a16:creationId xmlns:a16="http://schemas.microsoft.com/office/drawing/2014/main" id="{D0A2AA56-86D2-485E-A984-13925483A534}"/>
               </a:ext>
             </a:extLst>
           </p:cNvPr>
@@ -11955,7 +12100,7 @@
           <p:cNvPr id="11" name="">
             <a:extLst xmlns:a="http://schemas.openxmlformats.org/drawingml/2006/main">
               <a:ext uri="{FF2B5EF4-FFF2-40B4-BE49-F238E27FC236}">
-                <a16:creationId xmlns:a16="http://schemas.microsoft.com/office/drawing/2014/main" id="{B27459DE-9C78-465C-9C76-A53E6935C278}"/>
+                <a16:creationId xmlns:a16="http://schemas.microsoft.com/office/drawing/2014/main" id="{AB978E4C-C763-4830-B2BC-D910C116AD72}"/>
               </a:ext>
             </a:extLst>
           </p:cNvPr>
@@ -12114,7 +12259,7 @@
           <p:cNvPr id="12" name="">
             <a:extLst xmlns:a="http://schemas.openxmlformats.org/drawingml/2006/main">
               <a:ext uri="{FF2B5EF4-FFF2-40B4-BE49-F238E27FC236}">
-                <a16:creationId xmlns:a16="http://schemas.microsoft.com/office/drawing/2014/main" id="{3932173E-B269-43A0-9313-ABE79654C106}"/>
+                <a16:creationId xmlns:a16="http://schemas.microsoft.com/office/drawing/2014/main" id="{76B02DDA-1E28-4F8A-8841-D7B7CF1D9402}"/>
               </a:ext>
             </a:extLst>
           </p:cNvPr>
@@ -12271,7 +12416,7 @@
     </p:spTree>
     <p:extLst>
       <p:ext uri="{BB962C8B-B14F-4D97-AF65-F5344CB8AC3E}">
-        <p14:creationId xmlns:p14="http://schemas.microsoft.com/office/powerpoint/2010/main" val="1999019147"/>
+        <p14:creationId xmlns:p14="http://schemas.microsoft.com/office/powerpoint/2010/main" val="1139697095"/>
       </p:ext>
     </p:extLst>
   </p:cSld>
@@ -12302,7 +12447,7 @@
           <p:cNvPr id="12" name="">
             <a:extLst xmlns:a="http://schemas.openxmlformats.org/drawingml/2006/main">
               <a:ext uri="{FF2B5EF4-FFF2-40B4-BE49-F238E27FC236}">
-                <a16:creationId xmlns:a16="http://schemas.microsoft.com/office/drawing/2014/main" id="{2FAB85B8-45DD-45B2-8A18-FF7F25A0DB59}"/>
+                <a16:creationId xmlns:a16="http://schemas.microsoft.com/office/drawing/2014/main" id="{692E5BE6-C642-4365-ABDD-3CF6AF025700}"/>
               </a:ext>
             </a:extLst>
           </p:cNvPr>
@@ -12461,7 +12606,7 @@
           <p:cNvPr id="2" name="">
             <a:extLst xmlns:a="http://schemas.openxmlformats.org/drawingml/2006/main">
               <a:ext uri="{FF2B5EF4-FFF2-40B4-BE49-F238E27FC236}">
-                <a16:creationId xmlns:a16="http://schemas.microsoft.com/office/drawing/2014/main" id="{26C8AE92-3326-486C-8C4A-D7971230AFE3}"/>
+                <a16:creationId xmlns:a16="http://schemas.microsoft.com/office/drawing/2014/main" id="{001C4574-8374-4B7F-AF21-1102E2A31D64}"/>
               </a:ext>
             </a:extLst>
           </p:cNvPr>
@@ -12620,7 +12765,7 @@
           <p:cNvPr id="3" name="">
             <a:extLst xmlns:a="http://schemas.openxmlformats.org/drawingml/2006/main">
               <a:ext uri="{FF2B5EF4-FFF2-40B4-BE49-F238E27FC236}">
-                <a16:creationId xmlns:a16="http://schemas.microsoft.com/office/drawing/2014/main" id="{5FA7BB67-0324-4AA0-9E01-CEA4E095FDAD}"/>
+                <a16:creationId xmlns:a16="http://schemas.microsoft.com/office/drawing/2014/main" id="{AF5B9DEE-C142-4771-A357-5BC13B4A0A11}"/>
               </a:ext>
             </a:extLst>
           </p:cNvPr>
@@ -12651,7 +12796,7 @@
           <p:cNvPr id="4" name="">
             <a:extLst xmlns:a="http://schemas.openxmlformats.org/drawingml/2006/main">
               <a:ext uri="{FF2B5EF4-FFF2-40B4-BE49-F238E27FC236}">
-                <a16:creationId xmlns:a16="http://schemas.microsoft.com/office/drawing/2014/main" id="{05958DAA-4412-4723-AF54-EBC850897551}"/>
+                <a16:creationId xmlns:a16="http://schemas.microsoft.com/office/drawing/2014/main" id="{B7070594-E27B-47E6-A9F9-2F084DFC2F75}"/>
               </a:ext>
             </a:extLst>
           </p:cNvPr>
@@ -12810,7 +12955,7 @@
           <p:cNvPr id="5" name="">
             <a:extLst xmlns:a="http://schemas.openxmlformats.org/drawingml/2006/main">
               <a:ext uri="{FF2B5EF4-FFF2-40B4-BE49-F238E27FC236}">
-                <a16:creationId xmlns:a16="http://schemas.microsoft.com/office/drawing/2014/main" id="{91983518-EA26-43D6-917D-85AE8A90670E}"/>
+                <a16:creationId xmlns:a16="http://schemas.microsoft.com/office/drawing/2014/main" id="{7581A661-306E-48A4-AA58-FDF7FDAEED85}"/>
               </a:ext>
             </a:extLst>
           </p:cNvPr>
@@ -12969,7 +13114,7 @@
           <p:cNvPr id="6" name="">
             <a:extLst xmlns:a="http://schemas.openxmlformats.org/drawingml/2006/main">
               <a:ext uri="{FF2B5EF4-FFF2-40B4-BE49-F238E27FC236}">
-                <a16:creationId xmlns:a16="http://schemas.microsoft.com/office/drawing/2014/main" id="{436B8694-944B-4CC4-86D2-BE8FA3E5FE2C}"/>
+                <a16:creationId xmlns:a16="http://schemas.microsoft.com/office/drawing/2014/main" id="{DA1F3844-5F7C-4239-97D6-184D5524E867}"/>
               </a:ext>
             </a:extLst>
           </p:cNvPr>
@@ -13128,7 +13273,7 @@
           <p:cNvPr id="7" name="">
             <a:extLst xmlns:a="http://schemas.openxmlformats.org/drawingml/2006/main">
               <a:ext uri="{FF2B5EF4-FFF2-40B4-BE49-F238E27FC236}">
-                <a16:creationId xmlns:a16="http://schemas.microsoft.com/office/drawing/2014/main" id="{425F9E83-EE5E-4FF9-9487-E6E23E1B7249}"/>
+                <a16:creationId xmlns:a16="http://schemas.microsoft.com/office/drawing/2014/main" id="{9FD59C05-E94C-4A6B-BD64-C4C54DB48C31}"/>
               </a:ext>
             </a:extLst>
           </p:cNvPr>
@@ -13287,7 +13432,7 @@
           <p:cNvPr id="8" name="">
             <a:extLst xmlns:a="http://schemas.openxmlformats.org/drawingml/2006/main">
               <a:ext uri="{FF2B5EF4-FFF2-40B4-BE49-F238E27FC236}">
-                <a16:creationId xmlns:a16="http://schemas.microsoft.com/office/drawing/2014/main" id="{D131F667-5D88-4651-A2B2-76082AE066AB}"/>
+                <a16:creationId xmlns:a16="http://schemas.microsoft.com/office/drawing/2014/main" id="{2C49EB52-DD31-4AD2-A38C-5C43B666FF19}"/>
               </a:ext>
             </a:extLst>
           </p:cNvPr>
@@ -13446,7 +13591,7 @@
           <p:cNvPr id="9" name="">
             <a:extLst xmlns:a="http://schemas.openxmlformats.org/drawingml/2006/main">
               <a:ext uri="{FF2B5EF4-FFF2-40B4-BE49-F238E27FC236}">
-                <a16:creationId xmlns:a16="http://schemas.microsoft.com/office/drawing/2014/main" id="{3642B114-AA97-46EB-AA5D-F7BD689E9219}"/>
+                <a16:creationId xmlns:a16="http://schemas.microsoft.com/office/drawing/2014/main" id="{9259193B-CBA2-4DB8-A27D-49B736D11592}"/>
               </a:ext>
             </a:extLst>
           </p:cNvPr>
@@ -13605,7 +13750,7 @@
           <p:cNvPr id="10" name="">
             <a:extLst xmlns:a="http://schemas.openxmlformats.org/drawingml/2006/main">
               <a:ext uri="{FF2B5EF4-FFF2-40B4-BE49-F238E27FC236}">
-                <a16:creationId xmlns:a16="http://schemas.microsoft.com/office/drawing/2014/main" id="{F4DE8D5E-F4F5-442A-9452-2C0CD6D1D045}"/>
+                <a16:creationId xmlns:a16="http://schemas.microsoft.com/office/drawing/2014/main" id="{122BC7CD-B8B0-4D94-8BD4-F21885A4DCB6}"/>
               </a:ext>
             </a:extLst>
           </p:cNvPr>
@@ -13615,18 +13760,18 @@
           <p:nvPr/>
         </p:nvPicPr>
         <p:blipFill>
-          <a:blip xmlns:r="http://schemas.openxmlformats.org/officeDocument/2006/relationships" xmlns:a="http://schemas.openxmlformats.org/drawingml/2006/main" r:embed="R6b9513d9e46a4792"/>
-          <a:srcRect xmlns:a="http://schemas.openxmlformats.org/drawingml/2006/main" l="25000" t="50000" r="50000" b="0"/>
+          <a:blip xmlns:r="http://schemas.openxmlformats.org/officeDocument/2006/relationships" xmlns:a="http://schemas.openxmlformats.org/drawingml/2006/main" r:embed="R96456ca7ec274ce1"/>
+          <a:srcRect xmlns:a="http://schemas.openxmlformats.org/drawingml/2006/main" l="25000" t="50000" r="50000" b="25000"/>
           <a:stretch xmlns:a="http://schemas.openxmlformats.org/drawingml/2006/main"/>
         </p:blipFill>
         <p:spPr>
           <a:xfrm xmlns:a="http://schemas.openxmlformats.org/drawingml/2006/main">
-            <a:off x="6724650" y="2209800"/>
-            <a:ext cx="3829050" cy="4171950"/>
+            <a:off x="6667500" y="2724150"/>
+            <a:ext cx="4095750" cy="2724150"/>
           </a:xfrm>
           <a:prstGeom xmlns:a="http://schemas.openxmlformats.org/drawingml/2006/main" prst="roundRect">
             <a:avLst>
-              <a:gd name="adj" fmla="val 3980"/>
+              <a:gd name="adj" fmla="val 5594"/>
             </a:avLst>
           </a:prstGeom>
         </p:spPr>
@@ -13636,7 +13781,7 @@
           <p:cNvPr id="11" name="">
             <a:extLst xmlns:a="http://schemas.openxmlformats.org/drawingml/2006/main">
               <a:ext uri="{FF2B5EF4-FFF2-40B4-BE49-F238E27FC236}">
-                <a16:creationId xmlns:a16="http://schemas.microsoft.com/office/drawing/2014/main" id="{70D1CB1E-E93D-4784-AF84-ABF4467C0037}"/>
+                <a16:creationId xmlns:a16="http://schemas.microsoft.com/office/drawing/2014/main" id="{3D2151B2-E038-408A-B7CE-03F3982FA747}"/>
               </a:ext>
             </a:extLst>
           </p:cNvPr>
@@ -13793,7 +13938,7 @@
     </p:spTree>
     <p:extLst>
       <p:ext uri="{BB962C8B-B14F-4D97-AF65-F5344CB8AC3E}">
-        <p14:creationId xmlns:p14="http://schemas.microsoft.com/office/powerpoint/2010/main" val="1329025581"/>
+        <p14:creationId xmlns:p14="http://schemas.microsoft.com/office/powerpoint/2010/main" val="1436177375"/>
       </p:ext>
     </p:extLst>
   </p:cSld>
@@ -13824,7 +13969,7 @@
           <p:cNvPr id="11" name="">
             <a:extLst xmlns:a="http://schemas.openxmlformats.org/drawingml/2006/main">
               <a:ext uri="{FF2B5EF4-FFF2-40B4-BE49-F238E27FC236}">
-                <a16:creationId xmlns:a16="http://schemas.microsoft.com/office/drawing/2014/main" id="{BE05CA2B-D9C9-4823-90FA-E0513612EB95}"/>
+                <a16:creationId xmlns:a16="http://schemas.microsoft.com/office/drawing/2014/main" id="{BD45934E-FE9C-43F2-8862-133F73D73DF7}"/>
               </a:ext>
             </a:extLst>
           </p:cNvPr>
@@ -13983,7 +14128,7 @@
           <p:cNvPr id="2" name="">
             <a:extLst xmlns:a="http://schemas.openxmlformats.org/drawingml/2006/main">
               <a:ext uri="{FF2B5EF4-FFF2-40B4-BE49-F238E27FC236}">
-                <a16:creationId xmlns:a16="http://schemas.microsoft.com/office/drawing/2014/main" id="{044A130C-0B6F-430C-84D6-E8EF4786651E}"/>
+                <a16:creationId xmlns:a16="http://schemas.microsoft.com/office/drawing/2014/main" id="{A03B8E0E-4854-493C-A5D4-50A59FB0B2CF}"/>
               </a:ext>
             </a:extLst>
           </p:cNvPr>
@@ -14142,7 +14287,7 @@
           <p:cNvPr id="3" name="">
             <a:extLst xmlns:a="http://schemas.openxmlformats.org/drawingml/2006/main">
               <a:ext uri="{FF2B5EF4-FFF2-40B4-BE49-F238E27FC236}">
-                <a16:creationId xmlns:a16="http://schemas.microsoft.com/office/drawing/2014/main" id="{57D9493C-2BEA-4AC3-810B-0D49A6635CB7}"/>
+                <a16:creationId xmlns:a16="http://schemas.microsoft.com/office/drawing/2014/main" id="{AD0D2D7E-737D-4C1B-942B-2C1A64C4CAC6}"/>
               </a:ext>
             </a:extLst>
           </p:cNvPr>
@@ -14173,7 +14318,7 @@
           <p:cNvPr id="4" name="">
             <a:extLst xmlns:a="http://schemas.openxmlformats.org/drawingml/2006/main">
               <a:ext uri="{FF2B5EF4-FFF2-40B4-BE49-F238E27FC236}">
-                <a16:creationId xmlns:a16="http://schemas.microsoft.com/office/drawing/2014/main" id="{EC176C5F-13D9-4FF7-AA82-2B426CFD2DBB}"/>
+                <a16:creationId xmlns:a16="http://schemas.microsoft.com/office/drawing/2014/main" id="{BBDD4063-04DA-462D-9EE7-479F42F39CF5}"/>
               </a:ext>
             </a:extLst>
           </p:cNvPr>
@@ -14332,7 +14477,7 @@
           <p:cNvPr id="5" name="">
             <a:extLst xmlns:a="http://schemas.openxmlformats.org/drawingml/2006/main">
               <a:ext uri="{FF2B5EF4-FFF2-40B4-BE49-F238E27FC236}">
-                <a16:creationId xmlns:a16="http://schemas.microsoft.com/office/drawing/2014/main" id="{913F4C96-914A-4776-80E0-1A39BDE0440A}"/>
+                <a16:creationId xmlns:a16="http://schemas.microsoft.com/office/drawing/2014/main" id="{5AB6BE9D-B946-41DE-8DF6-16FEBC9AACE1}"/>
               </a:ext>
             </a:extLst>
           </p:cNvPr>
@@ -14491,7 +14636,7 @@
           <p:cNvPr id="6" name="">
             <a:extLst xmlns:a="http://schemas.openxmlformats.org/drawingml/2006/main">
               <a:ext uri="{FF2B5EF4-FFF2-40B4-BE49-F238E27FC236}">
-                <a16:creationId xmlns:a16="http://schemas.microsoft.com/office/drawing/2014/main" id="{AD98AD6B-79BD-46D9-A32F-352FAB7B838A}"/>
+                <a16:creationId xmlns:a16="http://schemas.microsoft.com/office/drawing/2014/main" id="{659D6087-5F68-4EA1-88B2-D732F6DA7DF8}"/>
               </a:ext>
             </a:extLst>
           </p:cNvPr>
@@ -14650,7 +14795,7 @@
           <p:cNvPr id="7" name="">
             <a:extLst xmlns:a="http://schemas.openxmlformats.org/drawingml/2006/main">
               <a:ext uri="{FF2B5EF4-FFF2-40B4-BE49-F238E27FC236}">
-                <a16:creationId xmlns:a16="http://schemas.microsoft.com/office/drawing/2014/main" id="{1181B984-9694-449B-8CAE-BAC5CF7B2E10}"/>
+                <a16:creationId xmlns:a16="http://schemas.microsoft.com/office/drawing/2014/main" id="{77BE9D50-C774-4ECC-ABD8-3604AC6DC42E}"/>
               </a:ext>
             </a:extLst>
           </p:cNvPr>
@@ -14809,7 +14954,7 @@
           <p:cNvPr id="8" name="">
             <a:extLst xmlns:a="http://schemas.openxmlformats.org/drawingml/2006/main">
               <a:ext uri="{FF2B5EF4-FFF2-40B4-BE49-F238E27FC236}">
-                <a16:creationId xmlns:a16="http://schemas.microsoft.com/office/drawing/2014/main" id="{9FB70525-D6D7-490E-9D75-67CB77BDBB83}"/>
+                <a16:creationId xmlns:a16="http://schemas.microsoft.com/office/drawing/2014/main" id="{5ECA7666-D7ED-4222-A553-4F29DDD3C1F3}"/>
               </a:ext>
             </a:extLst>
           </p:cNvPr>
@@ -14968,7 +15113,7 @@
           <p:cNvPr id="9" name="">
             <a:extLst xmlns:a="http://schemas.openxmlformats.org/drawingml/2006/main">
               <a:ext uri="{FF2B5EF4-FFF2-40B4-BE49-F238E27FC236}">
-                <a16:creationId xmlns:a16="http://schemas.microsoft.com/office/drawing/2014/main" id="{9DB6FB65-DF5A-4793-843B-7BB436F58644}"/>
+                <a16:creationId xmlns:a16="http://schemas.microsoft.com/office/drawing/2014/main" id="{6BEA0DD1-EC39-4656-9707-4A917898F7EB}"/>
               </a:ext>
             </a:extLst>
           </p:cNvPr>
@@ -15127,7 +15272,7 @@
           <p:cNvPr id="10" name="">
             <a:extLst xmlns:a="http://schemas.openxmlformats.org/drawingml/2006/main">
               <a:ext uri="{FF2B5EF4-FFF2-40B4-BE49-F238E27FC236}">
-                <a16:creationId xmlns:a16="http://schemas.microsoft.com/office/drawing/2014/main" id="{0CDF22D5-2AF0-4B13-A157-1359311FD49B}"/>
+                <a16:creationId xmlns:a16="http://schemas.microsoft.com/office/drawing/2014/main" id="{20DF029C-CA3F-481D-B2D7-737D702EE16B}"/>
               </a:ext>
             </a:extLst>
           </p:cNvPr>
@@ -15137,24 +15282,26 @@
           <p:nvPr/>
         </p:nvPicPr>
         <p:blipFill>
-          <a:blip xmlns:r="http://schemas.openxmlformats.org/officeDocument/2006/relationships" xmlns:a="http://schemas.openxmlformats.org/drawingml/2006/main" r:embed="R459c6cf00c45401b"/>
-          <a:srcRect xmlns:a="http://schemas.openxmlformats.org/drawingml/2006/main" l="0" t="0" r="0" b="0"/>
+          <a:blip xmlns:r="http://schemas.openxmlformats.org/officeDocument/2006/relationships" xmlns:a="http://schemas.openxmlformats.org/drawingml/2006/main" r:embed="R1cff2cd7fb114bf3"/>
+          <a:srcRect xmlns:a="http://schemas.openxmlformats.org/drawingml/2006/main" l="0" t="0" r="85500" b="0"/>
           <a:stretch xmlns:a="http://schemas.openxmlformats.org/drawingml/2006/main"/>
         </p:blipFill>
         <p:spPr>
           <a:xfrm xmlns:a="http://schemas.openxmlformats.org/drawingml/2006/main">
-            <a:off x="6305550" y="2266950"/>
-            <a:ext cx="5200650" cy="3886200"/>
+            <a:off x="7810500" y="2266950"/>
+            <a:ext cx="2857500" cy="3886200"/>
           </a:xfrm>
-          <a:prstGeom xmlns:a="http://schemas.openxmlformats.org/drawingml/2006/main" prst="rect">
-            <a:avLst/>
+          <a:prstGeom xmlns:a="http://schemas.openxmlformats.org/drawingml/2006/main" prst="roundRect">
+            <a:avLst>
+              <a:gd name="adj" fmla="val 5333"/>
+            </a:avLst>
           </a:prstGeom>
         </p:spPr>
       </p:pic>
     </p:spTree>
     <p:extLst>
       <p:ext uri="{BB962C8B-B14F-4D97-AF65-F5344CB8AC3E}">
-        <p14:creationId xmlns:p14="http://schemas.microsoft.com/office/powerpoint/2010/main" val="1077456879"/>
+        <p14:creationId xmlns:p14="http://schemas.microsoft.com/office/powerpoint/2010/main" val="1151976101"/>
       </p:ext>
     </p:extLst>
   </p:cSld>
@@ -15185,7 +15332,7 @@
           <p:cNvPr id="9" name="">
             <a:extLst xmlns:a="http://schemas.openxmlformats.org/drawingml/2006/main">
               <a:ext uri="{FF2B5EF4-FFF2-40B4-BE49-F238E27FC236}">
-                <a16:creationId xmlns:a16="http://schemas.microsoft.com/office/drawing/2014/main" id="{86CDE4E0-7781-47D7-A859-39BAB5F98339}"/>
+                <a16:creationId xmlns:a16="http://schemas.microsoft.com/office/drawing/2014/main" id="{7C87C0CA-D5B9-4508-A2FA-3E3A67407F5C}"/>
               </a:ext>
             </a:extLst>
           </p:cNvPr>
@@ -15344,7 +15491,7 @@
           <p:cNvPr id="2" name="">
             <a:extLst xmlns:a="http://schemas.openxmlformats.org/drawingml/2006/main">
               <a:ext uri="{FF2B5EF4-FFF2-40B4-BE49-F238E27FC236}">
-                <a16:creationId xmlns:a16="http://schemas.microsoft.com/office/drawing/2014/main" id="{1FC37114-F5F2-4393-A2EC-9CFECFDC268A}"/>
+                <a16:creationId xmlns:a16="http://schemas.microsoft.com/office/drawing/2014/main" id="{D497444A-845E-4C99-BD8E-95DE45B9884D}"/>
               </a:ext>
             </a:extLst>
           </p:cNvPr>
@@ -15503,7 +15650,7 @@
           <p:cNvPr id="3" name="">
             <a:extLst xmlns:a="http://schemas.openxmlformats.org/drawingml/2006/main">
               <a:ext uri="{FF2B5EF4-FFF2-40B4-BE49-F238E27FC236}">
-                <a16:creationId xmlns:a16="http://schemas.microsoft.com/office/drawing/2014/main" id="{DAC3BC4A-1ED4-416A-820A-8BFB9DD831DE}"/>
+                <a16:creationId xmlns:a16="http://schemas.microsoft.com/office/drawing/2014/main" id="{BF772747-CD78-454D-B46E-FE32EC09F846}"/>
               </a:ext>
             </a:extLst>
           </p:cNvPr>
@@ -15534,7 +15681,7 @@
           <p:cNvPr id="4" name="">
             <a:extLst xmlns:a="http://schemas.openxmlformats.org/drawingml/2006/main">
               <a:ext uri="{FF2B5EF4-FFF2-40B4-BE49-F238E27FC236}">
-                <a16:creationId xmlns:a16="http://schemas.microsoft.com/office/drawing/2014/main" id="{7E7E5B4F-B0CC-4EFA-A16F-19BCDBEDA677}"/>
+                <a16:creationId xmlns:a16="http://schemas.microsoft.com/office/drawing/2014/main" id="{A295F70F-A35D-4D09-9E9F-63EDD626C0F5}"/>
               </a:ext>
             </a:extLst>
           </p:cNvPr>
@@ -15693,7 +15840,7 @@
           <p:cNvPr id="5" name="">
             <a:extLst xmlns:a="http://schemas.openxmlformats.org/drawingml/2006/main">
               <a:ext uri="{FF2B5EF4-FFF2-40B4-BE49-F238E27FC236}">
-                <a16:creationId xmlns:a16="http://schemas.microsoft.com/office/drawing/2014/main" id="{479E004D-9FE6-4F62-B47E-E057FBE7BFE4}"/>
+                <a16:creationId xmlns:a16="http://schemas.microsoft.com/office/drawing/2014/main" id="{1E070CAD-6ABD-49F7-9C43-55E3B1F94042}"/>
               </a:ext>
             </a:extLst>
           </p:cNvPr>
@@ -15852,7 +15999,7 @@
           <p:cNvPr id="6" name="">
             <a:extLst xmlns:a="http://schemas.openxmlformats.org/drawingml/2006/main">
               <a:ext uri="{FF2B5EF4-FFF2-40B4-BE49-F238E27FC236}">
-                <a16:creationId xmlns:a16="http://schemas.microsoft.com/office/drawing/2014/main" id="{1E97FFF6-AA2A-488B-B447-B069963776A5}"/>
+                <a16:creationId xmlns:a16="http://schemas.microsoft.com/office/drawing/2014/main" id="{44EEF70D-AA59-4BD2-A1EE-C2F925F8064B}"/>
               </a:ext>
             </a:extLst>
           </p:cNvPr>
@@ -16011,7 +16158,7 @@
           <p:cNvPr id="7" name="">
             <a:extLst xmlns:a="http://schemas.openxmlformats.org/drawingml/2006/main">
               <a:ext uri="{FF2B5EF4-FFF2-40B4-BE49-F238E27FC236}">
-                <a16:creationId xmlns:a16="http://schemas.microsoft.com/office/drawing/2014/main" id="{033B7E6D-7FF1-4770-B833-DE1431150DAF}"/>
+                <a16:creationId xmlns:a16="http://schemas.microsoft.com/office/drawing/2014/main" id="{149FD37D-2A78-4CA5-85DE-1EF0358E42AF}"/>
               </a:ext>
             </a:extLst>
           </p:cNvPr>
@@ -16021,7 +16168,7 @@
           <p:nvPr/>
         </p:nvPicPr>
         <p:blipFill>
-          <a:blip xmlns:r="http://schemas.openxmlformats.org/officeDocument/2006/relationships" xmlns:a="http://schemas.openxmlformats.org/drawingml/2006/main" r:embed="Rc828232dd99e4563"/>
+          <a:blip xmlns:r="http://schemas.openxmlformats.org/officeDocument/2006/relationships" xmlns:a="http://schemas.openxmlformats.org/drawingml/2006/main" r:embed="R09f7711a59644211"/>
           <a:stretch xmlns:a="http://schemas.openxmlformats.org/drawingml/2006/main"/>
         </p:blipFill>
         <p:spPr>
@@ -16039,7 +16186,7 @@
           <p:cNvPr id="8" name="">
             <a:extLst xmlns:a="http://schemas.openxmlformats.org/drawingml/2006/main">
               <a:ext uri="{FF2B5EF4-FFF2-40B4-BE49-F238E27FC236}">
-                <a16:creationId xmlns:a16="http://schemas.microsoft.com/office/drawing/2014/main" id="{DF2833A5-5E0A-4CFF-A861-A28611FB433F}"/>
+                <a16:creationId xmlns:a16="http://schemas.microsoft.com/office/drawing/2014/main" id="{E65AF497-B4A8-4056-B840-0A1EB1F153AE}"/>
               </a:ext>
             </a:extLst>
           </p:cNvPr>
@@ -16196,7 +16343,7 @@
     </p:spTree>
     <p:extLst>
       <p:ext uri="{BB962C8B-B14F-4D97-AF65-F5344CB8AC3E}">
-        <p14:creationId xmlns:p14="http://schemas.microsoft.com/office/powerpoint/2010/main" val="1794443723"/>
+        <p14:creationId xmlns:p14="http://schemas.microsoft.com/office/powerpoint/2010/main" val="1766995183"/>
       </p:ext>
     </p:extLst>
   </p:cSld>

</xml_diff>

<commit_message>
Mejora la calidad de imagenes de la presentacion
</commit_message>
<xml_diff>
--- a/docs/presentacion/eudila-presentacion-general-2026-10-26.pptx
+++ b/docs/presentacion/eudila-presentacion-general-2026-10-26.pptx
@@ -2,20 +2,20 @@
 <file path=ppt/presentation.xml><?xml version="1.0" encoding="utf-8"?>
 <p:presentation xmlns:p="http://schemas.openxmlformats.org/presentationml/2006/main">
   <p:sldMasterIdLst>
-    <p:sldMasterId xmlns:r="http://schemas.openxmlformats.org/officeDocument/2006/relationships" id="2147483648" r:id="Rd6b3bfdf9ae242f1"/>
+    <p:sldMasterId xmlns:r="http://schemas.openxmlformats.org/officeDocument/2006/relationships" id="2147483648" r:id="R352a5e08b3484d0a"/>
   </p:sldMasterIdLst>
   <p:notesMasterIdLst>
-    <p:notesMasterId xmlns:r="http://schemas.openxmlformats.org/officeDocument/2006/relationships" r:id="R5af724b1bfb44992"/>
+    <p:notesMasterId xmlns:r="http://schemas.openxmlformats.org/officeDocument/2006/relationships" r:id="R38464449ab2b4699"/>
   </p:notesMasterIdLst>
   <p:sldIdLst>
-    <p:sldId xmlns:r="http://schemas.openxmlformats.org/officeDocument/2006/relationships" id="256" r:id="R1ec1c80067334250"/>
-    <p:sldId xmlns:r="http://schemas.openxmlformats.org/officeDocument/2006/relationships" id="257" r:id="R87ee37fcaa204f35"/>
-    <p:sldId xmlns:r="http://schemas.openxmlformats.org/officeDocument/2006/relationships" id="258" r:id="R5b49d69377664844"/>
-    <p:sldId xmlns:r="http://schemas.openxmlformats.org/officeDocument/2006/relationships" id="259" r:id="R38e43629dfd44c96"/>
-    <p:sldId xmlns:r="http://schemas.openxmlformats.org/officeDocument/2006/relationships" id="260" r:id="R56e3704feea14fa2"/>
-    <p:sldId xmlns:r="http://schemas.openxmlformats.org/officeDocument/2006/relationships" id="261" r:id="R82db5a35730e404c"/>
-    <p:sldId xmlns:r="http://schemas.openxmlformats.org/officeDocument/2006/relationships" id="262" r:id="Rbe4d99d68f7f4849"/>
-    <p:sldId xmlns:r="http://schemas.openxmlformats.org/officeDocument/2006/relationships" id="263" r:id="Rce2ac3feca9d458d"/>
+    <p:sldId xmlns:r="http://schemas.openxmlformats.org/officeDocument/2006/relationships" id="256" r:id="R02681c9edd1b47e4"/>
+    <p:sldId xmlns:r="http://schemas.openxmlformats.org/officeDocument/2006/relationships" id="257" r:id="R7cdf278b435a4218"/>
+    <p:sldId xmlns:r="http://schemas.openxmlformats.org/officeDocument/2006/relationships" id="258" r:id="R7a0a8fc31a924cc1"/>
+    <p:sldId xmlns:r="http://schemas.openxmlformats.org/officeDocument/2006/relationships" id="259" r:id="R748145b23dd64822"/>
+    <p:sldId xmlns:r="http://schemas.openxmlformats.org/officeDocument/2006/relationships" id="260" r:id="Rcb2f1c3632fd4f85"/>
+    <p:sldId xmlns:r="http://schemas.openxmlformats.org/officeDocument/2006/relationships" id="261" r:id="Rb0dff0d00c3a4758"/>
+    <p:sldId xmlns:r="http://schemas.openxmlformats.org/officeDocument/2006/relationships" id="262" r:id="R9696dda9510849a3"/>
+    <p:sldId xmlns:r="http://schemas.openxmlformats.org/officeDocument/2006/relationships" id="263" r:id="R47768475225048e1"/>
   </p:sldIdLst>
   <p:sldSz cx="12192000" cy="6858000"/>
   <p:notesSz cx="6858000" cy="9144000"/>
@@ -534,7 +534,7 @@
           </a:p>
           <a:p xmlns:a="http://schemas.openxmlformats.org/drawingml/2006/main">
             <a:r>
-              <a:t>Imagen: recorte de docs/design/evidence/mascota-momentos-2026-10-24/saludo.png.</a:t>
+              <a:t>Imagen: public/brand/icon-512.png, activo oficial de marca.</a:t>
             </a:r>
           </a:p>
         </p:txBody>
@@ -614,7 +614,7 @@
           </a:p>
           <a:p xmlns:a="http://schemas.openxmlformats.org/drawingml/2006/main">
             <a:r>
-              <a:t>Imagen: landing/assets/app-registro.png, captura real de la app.</a:t>
+              <a:t>Imagen: captura real de la app a triple resolución, sin recorte en PowerPoint.</a:t>
             </a:r>
           </a:p>
         </p:txBody>
@@ -694,7 +694,7 @@
           </a:p>
           <a:p xmlns:a="http://schemas.openxmlformats.org/drawingml/2006/main">
             <a:r>
-              <a:t>Imagen: docs/design/evidence/mascota-animo-2026-10-24/neutral-390.png.</a:t>
+              <a:t>Imagen: captura real de la app a triple resolución, preparada sin recortes parciales.</a:t>
             </a:r>
           </a:p>
         </p:txBody>
@@ -779,7 +779,7 @@
           </a:p>
           <a:p xmlns:a="http://schemas.openxmlformats.org/drawingml/2006/main">
             <a:r>
-              <a:t>Imagen: landing/assets/app-hoy.png; incluye un ejemplo ficticio identificado.</a:t>
+              <a:t>Imagen: captura real de la app a triple resolución; incluye un ejemplo ficticio.</a:t>
             </a:r>
           </a:p>
         </p:txBody>
@@ -869,7 +869,7 @@
           </a:p>
           <a:p xmlns:a="http://schemas.openxmlformats.org/drawingml/2006/main">
             <a:r>
-              <a:t>Imagen: recorte de docs/design/evidence/mascota-consistencia-2026-10-24/accion-coral.png.</a:t>
+              <a:t>Imagen: captura real de la app a triple resolución, sin recorte en PowerPoint.</a:t>
             </a:r>
           </a:p>
         </p:txBody>
@@ -959,7 +959,7 @@
           </a:p>
           <a:p xmlns:a="http://schemas.openxmlformats.org/drawingml/2006/main">
             <a:r>
-              <a:t>Imagen: recorte de docs/design/evidence/mascota-consistencia-2026-10-24/mascota-coral.png.</a:t>
+              <a:t>Imagen: captura real de la app a triple resolución, sin recorte en PowerPoint.</a:t>
             </a:r>
           </a:p>
         </p:txBody>
@@ -1091,7 +1091,7 @@
           <p:cNvPr id="3" name="Title">
             <a:extLst xmlns:a="http://schemas.openxmlformats.org/drawingml/2006/main">
               <a:ext uri="{FF2B5EF4-FFF2-40B4-BE49-F238E27FC236}">
-                <a16:creationId xmlns:a16="http://schemas.microsoft.com/office/drawing/2014/main" id="{D80F6018-2466-46C6-AA99-411AF9F36081}"/>
+                <a16:creationId xmlns:a16="http://schemas.microsoft.com/office/drawing/2014/main" id="{9CA609FB-405E-4882-82A6-041CF2198AAB}"/>
               </a:ext>
             </a:extLst>
           </p:cNvPr>
@@ -1320,7 +1320,7 @@
           <p:cNvPr id="2" name="Subtitle">
             <a:extLst xmlns:a="http://schemas.openxmlformats.org/drawingml/2006/main">
               <a:ext uri="{FF2B5EF4-FFF2-40B4-BE49-F238E27FC236}">
-                <a16:creationId xmlns:a16="http://schemas.microsoft.com/office/drawing/2014/main" id="{6920A769-086E-422C-9B9F-57155901DC40}"/>
+                <a16:creationId xmlns:a16="http://schemas.microsoft.com/office/drawing/2014/main" id="{E87E9DC9-4635-41D9-80D0-90348C0EA8C5}"/>
               </a:ext>
             </a:extLst>
           </p:cNvPr>
@@ -1566,7 +1566,7 @@
           <p:cNvPr id="2" name="Section title">
             <a:extLst xmlns:a="http://schemas.openxmlformats.org/drawingml/2006/main">
               <a:ext uri="{FF2B5EF4-FFF2-40B4-BE49-F238E27FC236}">
-                <a16:creationId xmlns:a16="http://schemas.microsoft.com/office/drawing/2014/main" id="{9014A102-BBB4-4BD5-9A2A-49D96582740B}"/>
+                <a16:creationId xmlns:a16="http://schemas.microsoft.com/office/drawing/2014/main" id="{326708AF-B21B-4219-8AA6-35A7918F61BC}"/>
               </a:ext>
             </a:extLst>
           </p:cNvPr>
@@ -1812,7 +1812,7 @@
           <p:cNvPr id="3" name="Title">
             <a:extLst xmlns:a="http://schemas.openxmlformats.org/drawingml/2006/main">
               <a:ext uri="{FF2B5EF4-FFF2-40B4-BE49-F238E27FC236}">
-                <a16:creationId xmlns:a16="http://schemas.microsoft.com/office/drawing/2014/main" id="{739C5ECD-48E5-45DC-8022-D1CFBB422C1F}"/>
+                <a16:creationId xmlns:a16="http://schemas.microsoft.com/office/drawing/2014/main" id="{9962493B-F786-412E-8E62-40B8FC09249D}"/>
               </a:ext>
             </a:extLst>
           </p:cNvPr>
@@ -2041,7 +2041,7 @@
           <p:cNvPr id="2" name="Body">
             <a:extLst xmlns:a="http://schemas.openxmlformats.org/drawingml/2006/main">
               <a:ext uri="{FF2B5EF4-FFF2-40B4-BE49-F238E27FC236}">
-                <a16:creationId xmlns:a16="http://schemas.microsoft.com/office/drawing/2014/main" id="{B1C9D903-2261-4AEF-BF34-8ED8BC0FF11F}"/>
+                <a16:creationId xmlns:a16="http://schemas.microsoft.com/office/drawing/2014/main" id="{60424006-99C9-4005-BA79-7EFE31DC086A}"/>
               </a:ext>
             </a:extLst>
           </p:cNvPr>
@@ -2287,7 +2287,7 @@
           <p:cNvPr id="4" name="Title">
             <a:extLst xmlns:a="http://schemas.openxmlformats.org/drawingml/2006/main">
               <a:ext uri="{FF2B5EF4-FFF2-40B4-BE49-F238E27FC236}">
-                <a16:creationId xmlns:a16="http://schemas.microsoft.com/office/drawing/2014/main" id="{0137B7DA-7757-4C57-AF7E-A443792E8A7E}"/>
+                <a16:creationId xmlns:a16="http://schemas.microsoft.com/office/drawing/2014/main" id="{7E91C23F-9171-450C-9964-65BB88A86D75}"/>
               </a:ext>
             </a:extLst>
           </p:cNvPr>
@@ -2516,7 +2516,7 @@
           <p:cNvPr id="2" name="Left column">
             <a:extLst xmlns:a="http://schemas.openxmlformats.org/drawingml/2006/main">
               <a:ext uri="{FF2B5EF4-FFF2-40B4-BE49-F238E27FC236}">
-                <a16:creationId xmlns:a16="http://schemas.microsoft.com/office/drawing/2014/main" id="{A59900AE-64C1-42A9-87CB-FE1511AD6973}"/>
+                <a16:creationId xmlns:a16="http://schemas.microsoft.com/office/drawing/2014/main" id="{4A3BA875-72D3-4913-AFC6-416037CAE461}"/>
               </a:ext>
             </a:extLst>
           </p:cNvPr>
@@ -2745,7 +2745,7 @@
           <p:cNvPr id="3" name="Right column">
             <a:extLst xmlns:a="http://schemas.openxmlformats.org/drawingml/2006/main">
               <a:ext uri="{FF2B5EF4-FFF2-40B4-BE49-F238E27FC236}">
-                <a16:creationId xmlns:a16="http://schemas.microsoft.com/office/drawing/2014/main" id="{CA1640AC-7B63-45D3-83C9-5833989A8B28}"/>
+                <a16:creationId xmlns:a16="http://schemas.microsoft.com/office/drawing/2014/main" id="{9A3A79C0-DBEF-49E7-8210-2C034444DFA9}"/>
               </a:ext>
             </a:extLst>
           </p:cNvPr>
@@ -2991,7 +2991,7 @@
           <p:cNvPr id="3" name="Title">
             <a:extLst xmlns:a="http://schemas.openxmlformats.org/drawingml/2006/main">
               <a:ext uri="{FF2B5EF4-FFF2-40B4-BE49-F238E27FC236}">
-                <a16:creationId xmlns:a16="http://schemas.microsoft.com/office/drawing/2014/main" id="{922CC6EB-9306-463D-81A0-BBCACE4BC706}"/>
+                <a16:creationId xmlns:a16="http://schemas.microsoft.com/office/drawing/2014/main" id="{422CB001-88BB-410A-9CC1-D3B2A7ADFA3B}"/>
               </a:ext>
             </a:extLst>
           </p:cNvPr>
@@ -3220,7 +3220,7 @@
           <p:cNvPr id="2" name="Left column">
             <a:extLst xmlns:a="http://schemas.openxmlformats.org/drawingml/2006/main">
               <a:ext uri="{FF2B5EF4-FFF2-40B4-BE49-F238E27FC236}">
-                <a16:creationId xmlns:a16="http://schemas.microsoft.com/office/drawing/2014/main" id="{975CA696-9F04-4A2C-8C0B-477EACB73BB0}"/>
+                <a16:creationId xmlns:a16="http://schemas.microsoft.com/office/drawing/2014/main" id="{BDF02484-3448-407B-A975-D29D8B86B5F4}"/>
               </a:ext>
             </a:extLst>
           </p:cNvPr>
@@ -3487,12 +3487,12 @@
   </p:cSld>
   <p:clrMap bg1="lt1" tx1="dk1" bg2="lt2" tx2="dk2" accent1="accent1" accent2="accent2" accent3="accent3" accent4="accent4" accent5="accent5" accent6="accent6" hlink="hlink" folHlink="folHlink"/>
   <p:sldLayoutIdLst>
-    <p:sldLayoutId xmlns:r="http://schemas.openxmlformats.org/officeDocument/2006/relationships" id="2147483649" r:id="R00f788dab261497f"/>
-    <p:sldLayoutId xmlns:r="http://schemas.openxmlformats.org/officeDocument/2006/relationships" id="2147483650" r:id="Ra66519ccc79143f1"/>
-    <p:sldLayoutId xmlns:r="http://schemas.openxmlformats.org/officeDocument/2006/relationships" id="2147483651" r:id="Rb2419462fc494fd5"/>
-    <p:sldLayoutId xmlns:r="http://schemas.openxmlformats.org/officeDocument/2006/relationships" id="2147483652" r:id="Re54557392a744189"/>
-    <p:sldLayoutId xmlns:r="http://schemas.openxmlformats.org/officeDocument/2006/relationships" id="2147483653" r:id="R10ff8a7db0bd43c7"/>
-    <p:sldLayoutId xmlns:r="http://schemas.openxmlformats.org/officeDocument/2006/relationships" id="2147483654" r:id="R69936b4bd1804747"/>
+    <p:sldLayoutId xmlns:r="http://schemas.openxmlformats.org/officeDocument/2006/relationships" id="2147483649" r:id="Ra545e9e2d94644f9"/>
+    <p:sldLayoutId xmlns:r="http://schemas.openxmlformats.org/officeDocument/2006/relationships" id="2147483650" r:id="R5c8d0fe559c9453a"/>
+    <p:sldLayoutId xmlns:r="http://schemas.openxmlformats.org/officeDocument/2006/relationships" id="2147483651" r:id="R30c0cb72790841a2"/>
+    <p:sldLayoutId xmlns:r="http://schemas.openxmlformats.org/officeDocument/2006/relationships" id="2147483652" r:id="R1a65aeb1d5424b5e"/>
+    <p:sldLayoutId xmlns:r="http://schemas.openxmlformats.org/officeDocument/2006/relationships" id="2147483653" r:id="Rc7a18e97904f4149"/>
+    <p:sldLayoutId xmlns:r="http://schemas.openxmlformats.org/officeDocument/2006/relationships" id="2147483654" r:id="R4c570acd95ca4ddd"/>
   </p:sldLayoutIdLst>
   <p:txStyles>
     <p:titleStyle>
@@ -4043,7 +4043,7 @@
           <p:cNvPr id="7" name="">
             <a:extLst xmlns:a="http://schemas.openxmlformats.org/drawingml/2006/main">
               <a:ext uri="{FF2B5EF4-FFF2-40B4-BE49-F238E27FC236}">
-                <a16:creationId xmlns:a16="http://schemas.microsoft.com/office/drawing/2014/main" id="{7B380089-7EFA-4B38-B8CF-22DC3FD27FC4}"/>
+                <a16:creationId xmlns:a16="http://schemas.microsoft.com/office/drawing/2014/main" id="{93552A18-4450-4592-A865-CA1F998F9EB6}"/>
               </a:ext>
             </a:extLst>
           </p:cNvPr>
@@ -4202,7 +4202,7 @@
           <p:cNvPr id="2" name="">
             <a:extLst xmlns:a="http://schemas.openxmlformats.org/drawingml/2006/main">
               <a:ext uri="{FF2B5EF4-FFF2-40B4-BE49-F238E27FC236}">
-                <a16:creationId xmlns:a16="http://schemas.microsoft.com/office/drawing/2014/main" id="{4C81C653-27D2-4AF4-847D-CCBEC518CB5D}"/>
+                <a16:creationId xmlns:a16="http://schemas.microsoft.com/office/drawing/2014/main" id="{38FDE5BD-D627-4D5F-898C-8DF8E1E34D22}"/>
               </a:ext>
             </a:extLst>
           </p:cNvPr>
@@ -4233,7 +4233,7 @@
           <p:cNvPr id="3" name="">
             <a:extLst xmlns:a="http://schemas.openxmlformats.org/drawingml/2006/main">
               <a:ext uri="{FF2B5EF4-FFF2-40B4-BE49-F238E27FC236}">
-                <a16:creationId xmlns:a16="http://schemas.microsoft.com/office/drawing/2014/main" id="{F75663F2-476F-490B-A287-4CDFDB96A7AB}"/>
+                <a16:creationId xmlns:a16="http://schemas.microsoft.com/office/drawing/2014/main" id="{AAE265B4-F2C6-44F1-AB8C-7CFB1DF63281}"/>
               </a:ext>
             </a:extLst>
           </p:cNvPr>
@@ -4415,7 +4415,7 @@
           <p:cNvPr id="4" name="">
             <a:extLst xmlns:a="http://schemas.openxmlformats.org/drawingml/2006/main">
               <a:ext uri="{FF2B5EF4-FFF2-40B4-BE49-F238E27FC236}">
-                <a16:creationId xmlns:a16="http://schemas.microsoft.com/office/drawing/2014/main" id="{903D815F-BDC2-4ECA-B918-2565B78CBCE4}"/>
+                <a16:creationId xmlns:a16="http://schemas.microsoft.com/office/drawing/2014/main" id="{F3AADF50-5E89-451A-B833-70FB51A982CC}"/>
               </a:ext>
             </a:extLst>
           </p:cNvPr>
@@ -4574,7 +4574,7 @@
           <p:cNvPr id="5" name="">
             <a:extLst xmlns:a="http://schemas.openxmlformats.org/drawingml/2006/main">
               <a:ext uri="{FF2B5EF4-FFF2-40B4-BE49-F238E27FC236}">
-                <a16:creationId xmlns:a16="http://schemas.microsoft.com/office/drawing/2014/main" id="{C7FA2CE7-6524-408A-9439-D62FCD93720D}"/>
+                <a16:creationId xmlns:a16="http://schemas.microsoft.com/office/drawing/2014/main" id="{A193950F-6C71-4C60-9C34-2AB84877D4A5}"/>
               </a:ext>
             </a:extLst>
           </p:cNvPr>
@@ -4733,7 +4733,7 @@
           <p:cNvPr id="6" name="">
             <a:extLst xmlns:a="http://schemas.openxmlformats.org/drawingml/2006/main">
               <a:ext uri="{FF2B5EF4-FFF2-40B4-BE49-F238E27FC236}">
-                <a16:creationId xmlns:a16="http://schemas.microsoft.com/office/drawing/2014/main" id="{352AB19F-9661-49B5-9059-709B50B11E9E}"/>
+                <a16:creationId xmlns:a16="http://schemas.microsoft.com/office/drawing/2014/main" id="{123F7533-F41A-4A61-96D0-E9B09275B76D}"/>
               </a:ext>
             </a:extLst>
           </p:cNvPr>
@@ -4743,7 +4743,7 @@
           <p:nvPr/>
         </p:nvPicPr>
         <p:blipFill>
-          <a:blip xmlns:r="http://schemas.openxmlformats.org/officeDocument/2006/relationships" xmlns:a="http://schemas.openxmlformats.org/drawingml/2006/main" r:embed="Ra9a6c380fc364fb7"/>
+          <a:blip xmlns:r="http://schemas.openxmlformats.org/officeDocument/2006/relationships" xmlns:a="http://schemas.openxmlformats.org/drawingml/2006/main" r:embed="R65ce5f89b80d43b3"/>
           <a:stretch xmlns:a="http://schemas.openxmlformats.org/drawingml/2006/main"/>
         </p:blipFill>
         <p:spPr>
@@ -4759,7 +4759,7 @@
     </p:spTree>
     <p:extLst>
       <p:ext uri="{BB962C8B-B14F-4D97-AF65-F5344CB8AC3E}">
-        <p14:creationId xmlns:p14="http://schemas.microsoft.com/office/powerpoint/2010/main" val="990198949"/>
+        <p14:creationId xmlns:p14="http://schemas.microsoft.com/office/powerpoint/2010/main" val="57876145"/>
       </p:ext>
     </p:extLst>
   </p:cSld>
@@ -4790,7 +4790,7 @@
           <p:cNvPr id="11" name="">
             <a:extLst xmlns:a="http://schemas.openxmlformats.org/drawingml/2006/main">
               <a:ext uri="{FF2B5EF4-FFF2-40B4-BE49-F238E27FC236}">
-                <a16:creationId xmlns:a16="http://schemas.microsoft.com/office/drawing/2014/main" id="{05AEA018-BD70-4246-8A7E-E35A59CF44A5}"/>
+                <a16:creationId xmlns:a16="http://schemas.microsoft.com/office/drawing/2014/main" id="{A4BA69F8-B7F5-4EC9-96D5-DDE58858D530}"/>
               </a:ext>
             </a:extLst>
           </p:cNvPr>
@@ -4949,7 +4949,7 @@
           <p:cNvPr id="2" name="">
             <a:extLst xmlns:a="http://schemas.openxmlformats.org/drawingml/2006/main">
               <a:ext uri="{FF2B5EF4-FFF2-40B4-BE49-F238E27FC236}">
-                <a16:creationId xmlns:a16="http://schemas.microsoft.com/office/drawing/2014/main" id="{89296822-1821-499F-932B-D3096239ECC9}"/>
+                <a16:creationId xmlns:a16="http://schemas.microsoft.com/office/drawing/2014/main" id="{0C5C01F1-928B-43D8-A6DD-A5E9D1EB3802}"/>
               </a:ext>
             </a:extLst>
           </p:cNvPr>
@@ -5108,7 +5108,7 @@
           <p:cNvPr id="3" name="">
             <a:extLst xmlns:a="http://schemas.openxmlformats.org/drawingml/2006/main">
               <a:ext uri="{FF2B5EF4-FFF2-40B4-BE49-F238E27FC236}">
-                <a16:creationId xmlns:a16="http://schemas.microsoft.com/office/drawing/2014/main" id="{CF9CF580-5120-448D-8758-78446A563162}"/>
+                <a16:creationId xmlns:a16="http://schemas.microsoft.com/office/drawing/2014/main" id="{48AFFEE4-AD95-4A99-8A9F-CBD212CD55A0}"/>
               </a:ext>
             </a:extLst>
           </p:cNvPr>
@@ -5139,7 +5139,7 @@
           <p:cNvPr id="4" name="">
             <a:extLst xmlns:a="http://schemas.openxmlformats.org/drawingml/2006/main">
               <a:ext uri="{FF2B5EF4-FFF2-40B4-BE49-F238E27FC236}">
-                <a16:creationId xmlns:a16="http://schemas.microsoft.com/office/drawing/2014/main" id="{B273D2B6-F673-4ECB-9CF7-809CE03664F4}"/>
+                <a16:creationId xmlns:a16="http://schemas.microsoft.com/office/drawing/2014/main" id="{761F2838-E76D-47FC-8B72-FFF55D19A815}"/>
               </a:ext>
             </a:extLst>
           </p:cNvPr>
@@ -5298,7 +5298,7 @@
           <p:cNvPr id="5" name="">
             <a:extLst xmlns:a="http://schemas.openxmlformats.org/drawingml/2006/main">
               <a:ext uri="{FF2B5EF4-FFF2-40B4-BE49-F238E27FC236}">
-                <a16:creationId xmlns:a16="http://schemas.microsoft.com/office/drawing/2014/main" id="{76C4E8F3-4FE4-4721-B531-AB85BE63EC0F}"/>
+                <a16:creationId xmlns:a16="http://schemas.microsoft.com/office/drawing/2014/main" id="{C3024C16-8DCF-4F33-9041-7F2D722FF4DA}"/>
               </a:ext>
             </a:extLst>
           </p:cNvPr>
@@ -5457,7 +5457,7 @@
           <p:cNvPr id="6" name="">
             <a:extLst xmlns:a="http://schemas.openxmlformats.org/drawingml/2006/main">
               <a:ext uri="{FF2B5EF4-FFF2-40B4-BE49-F238E27FC236}">
-                <a16:creationId xmlns:a16="http://schemas.microsoft.com/office/drawing/2014/main" id="{305E571C-96F3-4EF8-8C8D-CC7E8EE3D676}"/>
+                <a16:creationId xmlns:a16="http://schemas.microsoft.com/office/drawing/2014/main" id="{3D6DEC38-C791-470C-8257-F1C78A48B575}"/>
               </a:ext>
             </a:extLst>
           </p:cNvPr>
@@ -5616,7 +5616,7 @@
           <p:cNvPr id="7" name="">
             <a:extLst xmlns:a="http://schemas.openxmlformats.org/drawingml/2006/main">
               <a:ext uri="{FF2B5EF4-FFF2-40B4-BE49-F238E27FC236}">
-                <a16:creationId xmlns:a16="http://schemas.microsoft.com/office/drawing/2014/main" id="{89C2E4B4-AFCE-4A08-8300-D8DF6010477F}"/>
+                <a16:creationId xmlns:a16="http://schemas.microsoft.com/office/drawing/2014/main" id="{561315F9-267C-4525-9D7C-46973165017D}"/>
               </a:ext>
             </a:extLst>
           </p:cNvPr>
@@ -5775,7 +5775,7 @@
           <p:cNvPr id="8" name="">
             <a:extLst xmlns:a="http://schemas.openxmlformats.org/drawingml/2006/main">
               <a:ext uri="{FF2B5EF4-FFF2-40B4-BE49-F238E27FC236}">
-                <a16:creationId xmlns:a16="http://schemas.microsoft.com/office/drawing/2014/main" id="{23B9A322-4B73-4BFD-A28B-94EA3F4794BD}"/>
+                <a16:creationId xmlns:a16="http://schemas.microsoft.com/office/drawing/2014/main" id="{9BD973F3-3B07-4ED9-A2C6-E2C5C50BE93C}"/>
               </a:ext>
             </a:extLst>
           </p:cNvPr>
@@ -5934,7 +5934,7 @@
           <p:cNvPr id="9" name="">
             <a:extLst xmlns:a="http://schemas.openxmlformats.org/drawingml/2006/main">
               <a:ext uri="{FF2B5EF4-FFF2-40B4-BE49-F238E27FC236}">
-                <a16:creationId xmlns:a16="http://schemas.microsoft.com/office/drawing/2014/main" id="{B81CCC19-6136-4D66-9458-4BB4F2073BF2}"/>
+                <a16:creationId xmlns:a16="http://schemas.microsoft.com/office/drawing/2014/main" id="{16ACB633-D184-4D8F-9AA6-3314B487C6D3}"/>
               </a:ext>
             </a:extLst>
           </p:cNvPr>
@@ -5944,19 +5944,16 @@
           <p:nvPr/>
         </p:nvPicPr>
         <p:blipFill>
-          <a:blip xmlns:r="http://schemas.openxmlformats.org/officeDocument/2006/relationships" xmlns:a="http://schemas.openxmlformats.org/drawingml/2006/main" r:embed="Rb89c0f018bd14c7c"/>
-          <a:srcRect xmlns:a="http://schemas.openxmlformats.org/drawingml/2006/main" l="50000" t="0" r="25000" b="20000"/>
+          <a:blip xmlns:r="http://schemas.openxmlformats.org/officeDocument/2006/relationships" xmlns:a="http://schemas.openxmlformats.org/drawingml/2006/main" r:embed="R9f1b629526b546bc"/>
           <a:stretch xmlns:a="http://schemas.openxmlformats.org/drawingml/2006/main"/>
         </p:blipFill>
         <p:spPr>
           <a:xfrm xmlns:a="http://schemas.openxmlformats.org/drawingml/2006/main">
-            <a:off x="7239000" y="2286000"/>
+            <a:off x="7239000" y="2209800"/>
             <a:ext cx="3429000" cy="3429000"/>
           </a:xfrm>
-          <a:prstGeom xmlns:a="http://schemas.openxmlformats.org/drawingml/2006/main" prst="roundRect">
-            <a:avLst>
-              <a:gd name="adj" fmla="val 4444"/>
-            </a:avLst>
+          <a:prstGeom xmlns:a="http://schemas.openxmlformats.org/drawingml/2006/main" prst="rect">
+            <a:avLst/>
           </a:prstGeom>
         </p:spPr>
       </p:pic>
@@ -5965,7 +5962,7 @@
           <p:cNvPr id="10" name="">
             <a:extLst xmlns:a="http://schemas.openxmlformats.org/drawingml/2006/main">
               <a:ext uri="{FF2B5EF4-FFF2-40B4-BE49-F238E27FC236}">
-                <a16:creationId xmlns:a16="http://schemas.microsoft.com/office/drawing/2014/main" id="{0EF47408-51F4-4C11-A930-D38E45690464}"/>
+                <a16:creationId xmlns:a16="http://schemas.microsoft.com/office/drawing/2014/main" id="{EC474749-C188-4F34-A090-ADEE568BC19B}"/>
               </a:ext>
             </a:extLst>
           </p:cNvPr>
@@ -6122,7 +6119,7 @@
     </p:spTree>
     <p:extLst>
       <p:ext uri="{BB962C8B-B14F-4D97-AF65-F5344CB8AC3E}">
-        <p14:creationId xmlns:p14="http://schemas.microsoft.com/office/powerpoint/2010/main" val="327135998"/>
+        <p14:creationId xmlns:p14="http://schemas.microsoft.com/office/powerpoint/2010/main" val="821817270"/>
       </p:ext>
     </p:extLst>
   </p:cSld>
@@ -6153,7 +6150,7 @@
           <p:cNvPr id="22" name="">
             <a:extLst xmlns:a="http://schemas.openxmlformats.org/drawingml/2006/main">
               <a:ext uri="{FF2B5EF4-FFF2-40B4-BE49-F238E27FC236}">
-                <a16:creationId xmlns:a16="http://schemas.microsoft.com/office/drawing/2014/main" id="{4348B888-76E7-4EBC-B1CB-A4ED9ED21D5A}"/>
+                <a16:creationId xmlns:a16="http://schemas.microsoft.com/office/drawing/2014/main" id="{095FE3BB-4EFB-4216-A710-CC4B04C61AFE}"/>
               </a:ext>
             </a:extLst>
           </p:cNvPr>
@@ -6312,7 +6309,7 @@
           <p:cNvPr id="2" name="">
             <a:extLst xmlns:a="http://schemas.openxmlformats.org/drawingml/2006/main">
               <a:ext uri="{FF2B5EF4-FFF2-40B4-BE49-F238E27FC236}">
-                <a16:creationId xmlns:a16="http://schemas.microsoft.com/office/drawing/2014/main" id="{12E594C7-BEFB-4B75-8199-F796509249AF}"/>
+                <a16:creationId xmlns:a16="http://schemas.microsoft.com/office/drawing/2014/main" id="{58EE4310-69DA-4923-88A6-496F076266F6}"/>
               </a:ext>
             </a:extLst>
           </p:cNvPr>
@@ -6471,7 +6468,7 @@
           <p:cNvPr id="3" name="">
             <a:extLst xmlns:a="http://schemas.openxmlformats.org/drawingml/2006/main">
               <a:ext uri="{FF2B5EF4-FFF2-40B4-BE49-F238E27FC236}">
-                <a16:creationId xmlns:a16="http://schemas.microsoft.com/office/drawing/2014/main" id="{AF6E16C3-3AA1-4955-A273-FDEA8554DA26}"/>
+                <a16:creationId xmlns:a16="http://schemas.microsoft.com/office/drawing/2014/main" id="{6EC3776A-A180-4AD0-A754-1A656559C688}"/>
               </a:ext>
             </a:extLst>
           </p:cNvPr>
@@ -6502,7 +6499,7 @@
           <p:cNvPr id="4" name="">
             <a:extLst xmlns:a="http://schemas.openxmlformats.org/drawingml/2006/main">
               <a:ext uri="{FF2B5EF4-FFF2-40B4-BE49-F238E27FC236}">
-                <a16:creationId xmlns:a16="http://schemas.microsoft.com/office/drawing/2014/main" id="{A591F429-8CE5-4431-8E65-F00706B7FC0B}"/>
+                <a16:creationId xmlns:a16="http://schemas.microsoft.com/office/drawing/2014/main" id="{738A7F2A-E660-4612-AC2F-C11133403AF7}"/>
               </a:ext>
             </a:extLst>
           </p:cNvPr>
@@ -6661,7 +6658,7 @@
           <p:cNvPr id="5" name="">
             <a:extLst xmlns:a="http://schemas.openxmlformats.org/drawingml/2006/main">
               <a:ext uri="{FF2B5EF4-FFF2-40B4-BE49-F238E27FC236}">
-                <a16:creationId xmlns:a16="http://schemas.microsoft.com/office/drawing/2014/main" id="{8437BB55-D46A-490E-807D-29FF707BF5A7}"/>
+                <a16:creationId xmlns:a16="http://schemas.microsoft.com/office/drawing/2014/main" id="{03032B6F-8A65-4B5D-AC1A-DAF237454514}"/>
               </a:ext>
             </a:extLst>
           </p:cNvPr>
@@ -6820,7 +6817,7 @@
           <p:cNvPr id="6" name="">
             <a:extLst xmlns:a="http://schemas.openxmlformats.org/drawingml/2006/main">
               <a:ext uri="{FF2B5EF4-FFF2-40B4-BE49-F238E27FC236}">
-                <a16:creationId xmlns:a16="http://schemas.microsoft.com/office/drawing/2014/main" id="{BB8950D4-35D6-40A9-98CB-E4B6E5FA61C9}"/>
+                <a16:creationId xmlns:a16="http://schemas.microsoft.com/office/drawing/2014/main" id="{C7945991-1C60-48FA-A9F5-453EBA87220A}"/>
               </a:ext>
             </a:extLst>
           </p:cNvPr>
@@ -6830,19 +6827,16 @@
           <p:nvPr/>
         </p:nvPicPr>
         <p:blipFill>
-          <a:blip xmlns:r="http://schemas.openxmlformats.org/officeDocument/2006/relationships" xmlns:a="http://schemas.openxmlformats.org/drawingml/2006/main" r:embed="Rb8ceba73f6fd41ef"/>
-          <a:srcRect xmlns:a="http://schemas.openxmlformats.org/drawingml/2006/main" l="0" t="6000" r="0" b="41000"/>
+          <a:blip xmlns:r="http://schemas.openxmlformats.org/officeDocument/2006/relationships" xmlns:a="http://schemas.openxmlformats.org/drawingml/2006/main" r:embed="R232755f7673841d7"/>
           <a:stretch xmlns:a="http://schemas.openxmlformats.org/drawingml/2006/main"/>
         </p:blipFill>
         <p:spPr>
           <a:xfrm xmlns:a="http://schemas.openxmlformats.org/drawingml/2006/main">
-            <a:off x="895350" y="2171700"/>
-            <a:ext cx="3714750" cy="4171950"/>
+            <a:off x="1000125" y="2077286"/>
+            <a:ext cx="2457450" cy="3808329"/>
           </a:xfrm>
-          <a:prstGeom xmlns:a="http://schemas.openxmlformats.org/drawingml/2006/main" prst="roundRect">
-            <a:avLst>
-              <a:gd name="adj" fmla="val 4103"/>
-            </a:avLst>
+          <a:prstGeom xmlns:a="http://schemas.openxmlformats.org/drawingml/2006/main" prst="rect">
+            <a:avLst/>
           </a:prstGeom>
         </p:spPr>
       </p:pic>
@@ -6851,7 +6845,7 @@
           <p:cNvPr id="7" name="">
             <a:extLst xmlns:a="http://schemas.openxmlformats.org/drawingml/2006/main">
               <a:ext uri="{FF2B5EF4-FFF2-40B4-BE49-F238E27FC236}">
-                <a16:creationId xmlns:a16="http://schemas.microsoft.com/office/drawing/2014/main" id="{1F20B8ED-A326-4AA2-81FE-54B1B9C3BD9D}"/>
+                <a16:creationId xmlns:a16="http://schemas.microsoft.com/office/drawing/2014/main" id="{797B6E9F-4790-4622-80EB-C18EC480730F}"/>
               </a:ext>
             </a:extLst>
           </p:cNvPr>
@@ -7010,7 +7004,7 @@
           <p:cNvPr id="8" name="">
             <a:extLst xmlns:a="http://schemas.openxmlformats.org/drawingml/2006/main">
               <a:ext uri="{FF2B5EF4-FFF2-40B4-BE49-F238E27FC236}">
-                <a16:creationId xmlns:a16="http://schemas.microsoft.com/office/drawing/2014/main" id="{FE50695F-EFAB-46C9-AC0B-0A82D1EA7908}"/>
+                <a16:creationId xmlns:a16="http://schemas.microsoft.com/office/drawing/2014/main" id="{68122652-2C23-4C40-A3B8-DCE277B045B7}"/>
               </a:ext>
             </a:extLst>
           </p:cNvPr>
@@ -7169,7 +7163,7 @@
           <p:cNvPr id="9" name="">
             <a:extLst xmlns:a="http://schemas.openxmlformats.org/drawingml/2006/main">
               <a:ext uri="{FF2B5EF4-FFF2-40B4-BE49-F238E27FC236}">
-                <a16:creationId xmlns:a16="http://schemas.microsoft.com/office/drawing/2014/main" id="{8F644FB3-B191-47C9-BDD6-3FFE69CAE465}"/>
+                <a16:creationId xmlns:a16="http://schemas.microsoft.com/office/drawing/2014/main" id="{A8A99C38-938D-4E10-8AD0-1B8914438BF0}"/>
               </a:ext>
             </a:extLst>
           </p:cNvPr>
@@ -7328,7 +7322,7 @@
           <p:cNvPr id="10" name="">
             <a:extLst xmlns:a="http://schemas.openxmlformats.org/drawingml/2006/main">
               <a:ext uri="{FF2B5EF4-FFF2-40B4-BE49-F238E27FC236}">
-                <a16:creationId xmlns:a16="http://schemas.microsoft.com/office/drawing/2014/main" id="{B247509E-195E-4D8B-A06C-6BE20E326398}"/>
+                <a16:creationId xmlns:a16="http://schemas.microsoft.com/office/drawing/2014/main" id="{82BDDACE-18F5-4A91-BA88-396CF4C00740}"/>
               </a:ext>
             </a:extLst>
           </p:cNvPr>
@@ -7487,7 +7481,7 @@
           <p:cNvPr id="11" name="">
             <a:extLst xmlns:a="http://schemas.openxmlformats.org/drawingml/2006/main">
               <a:ext uri="{FF2B5EF4-FFF2-40B4-BE49-F238E27FC236}">
-                <a16:creationId xmlns:a16="http://schemas.microsoft.com/office/drawing/2014/main" id="{F33B640E-BA36-4CF9-9113-F5AFF450425F}"/>
+                <a16:creationId xmlns:a16="http://schemas.microsoft.com/office/drawing/2014/main" id="{F84156B4-95CC-4B36-9D27-169B129A28BF}"/>
               </a:ext>
             </a:extLst>
           </p:cNvPr>
@@ -7646,7 +7640,7 @@
           <p:cNvPr id="12" name="">
             <a:extLst xmlns:a="http://schemas.openxmlformats.org/drawingml/2006/main">
               <a:ext uri="{FF2B5EF4-FFF2-40B4-BE49-F238E27FC236}">
-                <a16:creationId xmlns:a16="http://schemas.microsoft.com/office/drawing/2014/main" id="{5AB5FDF7-37B4-4D5C-AB02-4E49DFE55B2B}"/>
+                <a16:creationId xmlns:a16="http://schemas.microsoft.com/office/drawing/2014/main" id="{A487997D-1306-4EF1-A547-DE97D890FA90}"/>
               </a:ext>
             </a:extLst>
           </p:cNvPr>
@@ -7805,7 +7799,7 @@
           <p:cNvPr id="13" name="">
             <a:extLst xmlns:a="http://schemas.openxmlformats.org/drawingml/2006/main">
               <a:ext uri="{FF2B5EF4-FFF2-40B4-BE49-F238E27FC236}">
-                <a16:creationId xmlns:a16="http://schemas.microsoft.com/office/drawing/2014/main" id="{A90ED4E9-CDBE-4EFE-ABD1-6241A0360092}"/>
+                <a16:creationId xmlns:a16="http://schemas.microsoft.com/office/drawing/2014/main" id="{74811252-F2E9-4F0B-8DD8-AC4C63F0C078}"/>
               </a:ext>
             </a:extLst>
           </p:cNvPr>
@@ -7964,7 +7958,7 @@
           <p:cNvPr id="14" name="">
             <a:extLst xmlns:a="http://schemas.openxmlformats.org/drawingml/2006/main">
               <a:ext uri="{FF2B5EF4-FFF2-40B4-BE49-F238E27FC236}">
-                <a16:creationId xmlns:a16="http://schemas.microsoft.com/office/drawing/2014/main" id="{A3C2B332-31AC-4C8D-9D8A-E7CD7BA36563}"/>
+                <a16:creationId xmlns:a16="http://schemas.microsoft.com/office/drawing/2014/main" id="{1ED6A37D-0AE8-408C-9A73-5B9626E975B7}"/>
               </a:ext>
             </a:extLst>
           </p:cNvPr>
@@ -8123,7 +8117,7 @@
           <p:cNvPr id="15" name="">
             <a:extLst xmlns:a="http://schemas.openxmlformats.org/drawingml/2006/main">
               <a:ext uri="{FF2B5EF4-FFF2-40B4-BE49-F238E27FC236}">
-                <a16:creationId xmlns:a16="http://schemas.microsoft.com/office/drawing/2014/main" id="{DB465776-A9FA-4093-9FD9-92622B2E98F3}"/>
+                <a16:creationId xmlns:a16="http://schemas.microsoft.com/office/drawing/2014/main" id="{AE8DA4DE-BC3D-46FD-809E-E4A155D5666B}"/>
               </a:ext>
             </a:extLst>
           </p:cNvPr>
@@ -8282,7 +8276,7 @@
           <p:cNvPr id="16" name="">
             <a:extLst xmlns:a="http://schemas.openxmlformats.org/drawingml/2006/main">
               <a:ext uri="{FF2B5EF4-FFF2-40B4-BE49-F238E27FC236}">
-                <a16:creationId xmlns:a16="http://schemas.microsoft.com/office/drawing/2014/main" id="{C2BB5EB3-0680-42A9-82FC-9B0BFE398D05}"/>
+                <a16:creationId xmlns:a16="http://schemas.microsoft.com/office/drawing/2014/main" id="{482DC01A-9DBA-4491-96E1-FB6EECD08056}"/>
               </a:ext>
             </a:extLst>
           </p:cNvPr>
@@ -8441,7 +8435,7 @@
           <p:cNvPr id="17" name="">
             <a:extLst xmlns:a="http://schemas.openxmlformats.org/drawingml/2006/main">
               <a:ext uri="{FF2B5EF4-FFF2-40B4-BE49-F238E27FC236}">
-                <a16:creationId xmlns:a16="http://schemas.microsoft.com/office/drawing/2014/main" id="{05FDC628-205D-4DC5-A0C1-E5C05D95D09A}"/>
+                <a16:creationId xmlns:a16="http://schemas.microsoft.com/office/drawing/2014/main" id="{3E043FCC-1911-470E-8571-D3FC08506988}"/>
               </a:ext>
             </a:extLst>
           </p:cNvPr>
@@ -8600,7 +8594,7 @@
           <p:cNvPr id="18" name="">
             <a:extLst xmlns:a="http://schemas.openxmlformats.org/drawingml/2006/main">
               <a:ext uri="{FF2B5EF4-FFF2-40B4-BE49-F238E27FC236}">
-                <a16:creationId xmlns:a16="http://schemas.microsoft.com/office/drawing/2014/main" id="{ADF56842-491A-420A-AF61-3E445CA3E8EB}"/>
+                <a16:creationId xmlns:a16="http://schemas.microsoft.com/office/drawing/2014/main" id="{FF840D6F-0CA3-422A-9D17-A4B446323112}"/>
               </a:ext>
             </a:extLst>
           </p:cNvPr>
@@ -8759,7 +8753,7 @@
           <p:cNvPr id="19" name="">
             <a:extLst xmlns:a="http://schemas.openxmlformats.org/drawingml/2006/main">
               <a:ext uri="{FF2B5EF4-FFF2-40B4-BE49-F238E27FC236}">
-                <a16:creationId xmlns:a16="http://schemas.microsoft.com/office/drawing/2014/main" id="{7CBE4FD8-D3C5-483C-8CEF-0F153974970B}"/>
+                <a16:creationId xmlns:a16="http://schemas.microsoft.com/office/drawing/2014/main" id="{53BAC232-D95E-40FD-B507-19C23B792E01}"/>
               </a:ext>
             </a:extLst>
           </p:cNvPr>
@@ -8918,7 +8912,7 @@
           <p:cNvPr id="20" name="">
             <a:extLst xmlns:a="http://schemas.openxmlformats.org/drawingml/2006/main">
               <a:ext uri="{FF2B5EF4-FFF2-40B4-BE49-F238E27FC236}">
-                <a16:creationId xmlns:a16="http://schemas.microsoft.com/office/drawing/2014/main" id="{910A3D39-DC27-470C-8138-7ACB03AE5FB6}"/>
+                <a16:creationId xmlns:a16="http://schemas.microsoft.com/office/drawing/2014/main" id="{9538E3AF-C0C7-4806-8DED-8BCFA8646BA2}"/>
               </a:ext>
             </a:extLst>
           </p:cNvPr>
@@ -9077,7 +9071,7 @@
           <p:cNvPr id="21" name="">
             <a:extLst xmlns:a="http://schemas.openxmlformats.org/drawingml/2006/main">
               <a:ext uri="{FF2B5EF4-FFF2-40B4-BE49-F238E27FC236}">
-                <a16:creationId xmlns:a16="http://schemas.microsoft.com/office/drawing/2014/main" id="{A17C3B80-C0B7-46FB-9225-1C131F9DAE00}"/>
+                <a16:creationId xmlns:a16="http://schemas.microsoft.com/office/drawing/2014/main" id="{07ADB6E3-B750-4792-ABE0-ECF36C55EFA0}"/>
               </a:ext>
             </a:extLst>
           </p:cNvPr>
@@ -9234,7 +9228,7 @@
     </p:spTree>
     <p:extLst>
       <p:ext uri="{BB962C8B-B14F-4D97-AF65-F5344CB8AC3E}">
-        <p14:creationId xmlns:p14="http://schemas.microsoft.com/office/powerpoint/2010/main" val="1102767826"/>
+        <p14:creationId xmlns:p14="http://schemas.microsoft.com/office/powerpoint/2010/main" val="501970780"/>
       </p:ext>
     </p:extLst>
   </p:cSld>
@@ -9265,7 +9259,7 @@
           <p:cNvPr id="11" name="">
             <a:extLst xmlns:a="http://schemas.openxmlformats.org/drawingml/2006/main">
               <a:ext uri="{FF2B5EF4-FFF2-40B4-BE49-F238E27FC236}">
-                <a16:creationId xmlns:a16="http://schemas.microsoft.com/office/drawing/2014/main" id="{BCCBCCE5-1EC3-408D-A292-4C7844A1A76C}"/>
+                <a16:creationId xmlns:a16="http://schemas.microsoft.com/office/drawing/2014/main" id="{768C31CE-525A-49A2-8995-741510933F3B}"/>
               </a:ext>
             </a:extLst>
           </p:cNvPr>
@@ -9424,7 +9418,7 @@
           <p:cNvPr id="2" name="">
             <a:extLst xmlns:a="http://schemas.openxmlformats.org/drawingml/2006/main">
               <a:ext uri="{FF2B5EF4-FFF2-40B4-BE49-F238E27FC236}">
-                <a16:creationId xmlns:a16="http://schemas.microsoft.com/office/drawing/2014/main" id="{81D8A487-38DF-49DE-A95C-60A7A891E798}"/>
+                <a16:creationId xmlns:a16="http://schemas.microsoft.com/office/drawing/2014/main" id="{B7B008DB-9F91-43B9-BEC0-C807E66D7166}"/>
               </a:ext>
             </a:extLst>
           </p:cNvPr>
@@ -9583,7 +9577,7 @@
           <p:cNvPr id="3" name="">
             <a:extLst xmlns:a="http://schemas.openxmlformats.org/drawingml/2006/main">
               <a:ext uri="{FF2B5EF4-FFF2-40B4-BE49-F238E27FC236}">
-                <a16:creationId xmlns:a16="http://schemas.microsoft.com/office/drawing/2014/main" id="{4EC356ED-D1CC-4EB9-A913-482C7A345E48}"/>
+                <a16:creationId xmlns:a16="http://schemas.microsoft.com/office/drawing/2014/main" id="{1D10F0EE-A8F7-45B3-A655-DCF81751AD31}"/>
               </a:ext>
             </a:extLst>
           </p:cNvPr>
@@ -9614,7 +9608,7 @@
           <p:cNvPr id="4" name="">
             <a:extLst xmlns:a="http://schemas.openxmlformats.org/drawingml/2006/main">
               <a:ext uri="{FF2B5EF4-FFF2-40B4-BE49-F238E27FC236}">
-                <a16:creationId xmlns:a16="http://schemas.microsoft.com/office/drawing/2014/main" id="{285C202D-DFB0-4444-A7E3-F36BC9FC8B37}"/>
+                <a16:creationId xmlns:a16="http://schemas.microsoft.com/office/drawing/2014/main" id="{10A35898-A525-46C4-926C-D6122FD9C7C5}"/>
               </a:ext>
             </a:extLst>
           </p:cNvPr>
@@ -9773,7 +9767,7 @@
           <p:cNvPr id="5" name="">
             <a:extLst xmlns:a="http://schemas.openxmlformats.org/drawingml/2006/main">
               <a:ext uri="{FF2B5EF4-FFF2-40B4-BE49-F238E27FC236}">
-                <a16:creationId xmlns:a16="http://schemas.microsoft.com/office/drawing/2014/main" id="{39064DE1-C6CE-4749-B298-4ACEAE5AEBDB}"/>
+                <a16:creationId xmlns:a16="http://schemas.microsoft.com/office/drawing/2014/main" id="{28A108C9-C3C7-40B8-919D-D438EAF5E258}"/>
               </a:ext>
             </a:extLst>
           </p:cNvPr>
@@ -9932,7 +9926,7 @@
           <p:cNvPr id="6" name="">
             <a:extLst xmlns:a="http://schemas.openxmlformats.org/drawingml/2006/main">
               <a:ext uri="{FF2B5EF4-FFF2-40B4-BE49-F238E27FC236}">
-                <a16:creationId xmlns:a16="http://schemas.microsoft.com/office/drawing/2014/main" id="{FCF5B86F-EDC2-46B9-AC03-ECE6C92D9BC5}"/>
+                <a16:creationId xmlns:a16="http://schemas.microsoft.com/office/drawing/2014/main" id="{65BDDDBD-2AC3-4A01-94E0-247C45D8F519}"/>
               </a:ext>
             </a:extLst>
           </p:cNvPr>
@@ -9942,19 +9936,16 @@
           <p:nvPr/>
         </p:nvPicPr>
         <p:blipFill>
-          <a:blip xmlns:r="http://schemas.openxmlformats.org/officeDocument/2006/relationships" xmlns:a="http://schemas.openxmlformats.org/drawingml/2006/main" r:embed="R38771c19ec8d43af"/>
-          <a:srcRect xmlns:a="http://schemas.openxmlformats.org/drawingml/2006/main" l="0" t="3000" r="0" b="39000"/>
+          <a:blip xmlns:r="http://schemas.openxmlformats.org/officeDocument/2006/relationships" xmlns:a="http://schemas.openxmlformats.org/drawingml/2006/main" r:embed="Ra8f9e140ad094418"/>
           <a:stretch xmlns:a="http://schemas.openxmlformats.org/drawingml/2006/main"/>
         </p:blipFill>
         <p:spPr>
           <a:xfrm xmlns:a="http://schemas.openxmlformats.org/drawingml/2006/main">
-            <a:off x="857250" y="2266950"/>
-            <a:ext cx="3429000" cy="4000500"/>
+            <a:off x="744794" y="2552700"/>
+            <a:ext cx="3711063" cy="3486150"/>
           </a:xfrm>
-          <a:prstGeom xmlns:a="http://schemas.openxmlformats.org/drawingml/2006/main" prst="roundRect">
-            <a:avLst>
-              <a:gd name="adj" fmla="val 4444"/>
-            </a:avLst>
+          <a:prstGeom xmlns:a="http://schemas.openxmlformats.org/drawingml/2006/main" prst="rect">
+            <a:avLst/>
           </a:prstGeom>
         </p:spPr>
       </p:pic>
@@ -9963,7 +9954,7 @@
           <p:cNvPr id="7" name="">
             <a:extLst xmlns:a="http://schemas.openxmlformats.org/drawingml/2006/main">
               <a:ext uri="{FF2B5EF4-FFF2-40B4-BE49-F238E27FC236}">
-                <a16:creationId xmlns:a16="http://schemas.microsoft.com/office/drawing/2014/main" id="{40B0CD8B-6F4E-4A7A-AF50-702ED541B2F4}"/>
+                <a16:creationId xmlns:a16="http://schemas.microsoft.com/office/drawing/2014/main" id="{580E446F-CE56-4FB9-B91E-5EBCBBAA6356}"/>
               </a:ext>
             </a:extLst>
           </p:cNvPr>
@@ -10122,7 +10113,7 @@
           <p:cNvPr id="8" name="">
             <a:extLst xmlns:a="http://schemas.openxmlformats.org/drawingml/2006/main">
               <a:ext uri="{FF2B5EF4-FFF2-40B4-BE49-F238E27FC236}">
-                <a16:creationId xmlns:a16="http://schemas.microsoft.com/office/drawing/2014/main" id="{88DE5170-5A54-4B67-A36B-AA7D4332C6C7}"/>
+                <a16:creationId xmlns:a16="http://schemas.microsoft.com/office/drawing/2014/main" id="{02855A13-F376-456C-B940-49DBECAC8CD8}"/>
               </a:ext>
             </a:extLst>
           </p:cNvPr>
@@ -10419,7 +10410,7 @@
           <p:cNvPr id="9" name="">
             <a:extLst xmlns:a="http://schemas.openxmlformats.org/drawingml/2006/main">
               <a:ext uri="{FF2B5EF4-FFF2-40B4-BE49-F238E27FC236}">
-                <a16:creationId xmlns:a16="http://schemas.microsoft.com/office/drawing/2014/main" id="{B4EFB529-A415-46E5-A94C-7A0FB8BC7CEA}"/>
+                <a16:creationId xmlns:a16="http://schemas.microsoft.com/office/drawing/2014/main" id="{E20CE856-006F-4067-B401-24F9CD72B3F2}"/>
               </a:ext>
             </a:extLst>
           </p:cNvPr>
@@ -10578,7 +10569,7 @@
           <p:cNvPr id="10" name="">
             <a:extLst xmlns:a="http://schemas.openxmlformats.org/drawingml/2006/main">
               <a:ext uri="{FF2B5EF4-FFF2-40B4-BE49-F238E27FC236}">
-                <a16:creationId xmlns:a16="http://schemas.microsoft.com/office/drawing/2014/main" id="{A8C62D93-84F4-4CAE-87ED-9AFF5F3E9AF0}"/>
+                <a16:creationId xmlns:a16="http://schemas.microsoft.com/office/drawing/2014/main" id="{7117C55A-2FEC-4B3F-B864-7E764CD44B3F}"/>
               </a:ext>
             </a:extLst>
           </p:cNvPr>
@@ -10735,7 +10726,7 @@
     </p:spTree>
     <p:extLst>
       <p:ext uri="{BB962C8B-B14F-4D97-AF65-F5344CB8AC3E}">
-        <p14:creationId xmlns:p14="http://schemas.microsoft.com/office/powerpoint/2010/main" val="1716075880"/>
+        <p14:creationId xmlns:p14="http://schemas.microsoft.com/office/powerpoint/2010/main" val="1451611894"/>
       </p:ext>
     </p:extLst>
   </p:cSld>
@@ -10766,7 +10757,7 @@
           <p:cNvPr id="13" name="">
             <a:extLst xmlns:a="http://schemas.openxmlformats.org/drawingml/2006/main">
               <a:ext uri="{FF2B5EF4-FFF2-40B4-BE49-F238E27FC236}">
-                <a16:creationId xmlns:a16="http://schemas.microsoft.com/office/drawing/2014/main" id="{148703D7-B06A-4E13-A261-46332E9BEA40}"/>
+                <a16:creationId xmlns:a16="http://schemas.microsoft.com/office/drawing/2014/main" id="{4795E706-FF90-42F5-9A62-D08B01B9C81A}"/>
               </a:ext>
             </a:extLst>
           </p:cNvPr>
@@ -10925,7 +10916,7 @@
           <p:cNvPr id="2" name="">
             <a:extLst xmlns:a="http://schemas.openxmlformats.org/drawingml/2006/main">
               <a:ext uri="{FF2B5EF4-FFF2-40B4-BE49-F238E27FC236}">
-                <a16:creationId xmlns:a16="http://schemas.microsoft.com/office/drawing/2014/main" id="{A731A63F-9128-43F4-B652-BED9B38EFD41}"/>
+                <a16:creationId xmlns:a16="http://schemas.microsoft.com/office/drawing/2014/main" id="{9F66DA67-9FFB-40D1-8C9E-3EE6CAF12E6A}"/>
               </a:ext>
             </a:extLst>
           </p:cNvPr>
@@ -11084,7 +11075,7 @@
           <p:cNvPr id="3" name="">
             <a:extLst xmlns:a="http://schemas.openxmlformats.org/drawingml/2006/main">
               <a:ext uri="{FF2B5EF4-FFF2-40B4-BE49-F238E27FC236}">
-                <a16:creationId xmlns:a16="http://schemas.microsoft.com/office/drawing/2014/main" id="{68114C29-6F1B-46C7-B4F6-AD66AA369466}"/>
+                <a16:creationId xmlns:a16="http://schemas.microsoft.com/office/drawing/2014/main" id="{1AE1A395-8D5C-40A8-A663-9246BF7BEB12}"/>
               </a:ext>
             </a:extLst>
           </p:cNvPr>
@@ -11115,7 +11106,7 @@
           <p:cNvPr id="4" name="">
             <a:extLst xmlns:a="http://schemas.openxmlformats.org/drawingml/2006/main">
               <a:ext uri="{FF2B5EF4-FFF2-40B4-BE49-F238E27FC236}">
-                <a16:creationId xmlns:a16="http://schemas.microsoft.com/office/drawing/2014/main" id="{79AFEEB8-CD5B-49C9-BB62-A5A7AB9F5F94}"/>
+                <a16:creationId xmlns:a16="http://schemas.microsoft.com/office/drawing/2014/main" id="{B0478804-A74D-4B78-8874-03C08E5F1947}"/>
               </a:ext>
             </a:extLst>
           </p:cNvPr>
@@ -11274,7 +11265,7 @@
           <p:cNvPr id="5" name="">
             <a:extLst xmlns:a="http://schemas.openxmlformats.org/drawingml/2006/main">
               <a:ext uri="{FF2B5EF4-FFF2-40B4-BE49-F238E27FC236}">
-                <a16:creationId xmlns:a16="http://schemas.microsoft.com/office/drawing/2014/main" id="{CB94328A-2C18-48AA-B1FB-AC7C0197B57C}"/>
+                <a16:creationId xmlns:a16="http://schemas.microsoft.com/office/drawing/2014/main" id="{B8BD77E4-3A32-4E2E-B734-5CC7A3CA057B}"/>
               </a:ext>
             </a:extLst>
           </p:cNvPr>
@@ -11433,7 +11424,7 @@
           <p:cNvPr id="6" name="">
             <a:extLst xmlns:a="http://schemas.openxmlformats.org/drawingml/2006/main">
               <a:ext uri="{FF2B5EF4-FFF2-40B4-BE49-F238E27FC236}">
-                <a16:creationId xmlns:a16="http://schemas.microsoft.com/office/drawing/2014/main" id="{6C2BFF19-DE32-499E-BE00-7FFB032B30F6}"/>
+                <a16:creationId xmlns:a16="http://schemas.microsoft.com/office/drawing/2014/main" id="{AFC22D2A-51F2-43F3-A034-364A1E84CC8D}"/>
               </a:ext>
             </a:extLst>
           </p:cNvPr>
@@ -11443,19 +11434,16 @@
           <p:nvPr/>
         </p:nvPicPr>
         <p:blipFill>
-          <a:blip xmlns:r="http://schemas.openxmlformats.org/officeDocument/2006/relationships" xmlns:a="http://schemas.openxmlformats.org/drawingml/2006/main" r:embed="R5637e03520c54d2c"/>
-          <a:srcRect xmlns:a="http://schemas.openxmlformats.org/drawingml/2006/main" l="0" t="4000" r="0" b="61000"/>
+          <a:blip xmlns:r="http://schemas.openxmlformats.org/officeDocument/2006/relationships" xmlns:a="http://schemas.openxmlformats.org/drawingml/2006/main" r:embed="R7f953b5257474efa"/>
           <a:stretch xmlns:a="http://schemas.openxmlformats.org/drawingml/2006/main"/>
         </p:blipFill>
         <p:spPr>
           <a:xfrm xmlns:a="http://schemas.openxmlformats.org/drawingml/2006/main">
-            <a:off x="876300" y="2571750"/>
-            <a:ext cx="3714750" cy="2857500"/>
+            <a:off x="685800" y="2802411"/>
+            <a:ext cx="4476750" cy="3272478"/>
           </a:xfrm>
-          <a:prstGeom xmlns:a="http://schemas.openxmlformats.org/drawingml/2006/main" prst="roundRect">
-            <a:avLst>
-              <a:gd name="adj" fmla="val 5333"/>
-            </a:avLst>
+          <a:prstGeom xmlns:a="http://schemas.openxmlformats.org/drawingml/2006/main" prst="rect">
+            <a:avLst/>
           </a:prstGeom>
         </p:spPr>
       </p:pic>
@@ -11464,7 +11452,7 @@
           <p:cNvPr id="7" name="">
             <a:extLst xmlns:a="http://schemas.openxmlformats.org/drawingml/2006/main">
               <a:ext uri="{FF2B5EF4-FFF2-40B4-BE49-F238E27FC236}">
-                <a16:creationId xmlns:a16="http://schemas.microsoft.com/office/drawing/2014/main" id="{DEBC6848-1089-4E5A-B7E0-4756CDC03AD8}"/>
+                <a16:creationId xmlns:a16="http://schemas.microsoft.com/office/drawing/2014/main" id="{416C800A-53DD-4DA9-B7AC-851579353383}"/>
               </a:ext>
             </a:extLst>
           </p:cNvPr>
@@ -11623,7 +11611,7 @@
           <p:cNvPr id="8" name="">
             <a:extLst xmlns:a="http://schemas.openxmlformats.org/drawingml/2006/main">
               <a:ext uri="{FF2B5EF4-FFF2-40B4-BE49-F238E27FC236}">
-                <a16:creationId xmlns:a16="http://schemas.microsoft.com/office/drawing/2014/main" id="{6FF258F6-7D5C-4FAD-85FA-44C1F9498C53}"/>
+                <a16:creationId xmlns:a16="http://schemas.microsoft.com/office/drawing/2014/main" id="{1105BADA-B70F-4EEA-922C-41663357422A}"/>
               </a:ext>
             </a:extLst>
           </p:cNvPr>
@@ -11782,7 +11770,7 @@
           <p:cNvPr id="9" name="">
             <a:extLst xmlns:a="http://schemas.openxmlformats.org/drawingml/2006/main">
               <a:ext uri="{FF2B5EF4-FFF2-40B4-BE49-F238E27FC236}">
-                <a16:creationId xmlns:a16="http://schemas.microsoft.com/office/drawing/2014/main" id="{27027013-D132-4448-AD2A-9ADF283A14DB}"/>
+                <a16:creationId xmlns:a16="http://schemas.microsoft.com/office/drawing/2014/main" id="{5F18F6A3-D2BD-496B-95C1-391569AA3A09}"/>
               </a:ext>
             </a:extLst>
           </p:cNvPr>
@@ -11941,7 +11929,7 @@
           <p:cNvPr id="10" name="">
             <a:extLst xmlns:a="http://schemas.openxmlformats.org/drawingml/2006/main">
               <a:ext uri="{FF2B5EF4-FFF2-40B4-BE49-F238E27FC236}">
-                <a16:creationId xmlns:a16="http://schemas.microsoft.com/office/drawing/2014/main" id="{D0A2AA56-86D2-485E-A984-13925483A534}"/>
+                <a16:creationId xmlns:a16="http://schemas.microsoft.com/office/drawing/2014/main" id="{E35AD53C-A401-47E2-83BD-671BC5476F37}"/>
               </a:ext>
             </a:extLst>
           </p:cNvPr>
@@ -12100,7 +12088,7 @@
           <p:cNvPr id="11" name="">
             <a:extLst xmlns:a="http://schemas.openxmlformats.org/drawingml/2006/main">
               <a:ext uri="{FF2B5EF4-FFF2-40B4-BE49-F238E27FC236}">
-                <a16:creationId xmlns:a16="http://schemas.microsoft.com/office/drawing/2014/main" id="{AB978E4C-C763-4830-B2BC-D910C116AD72}"/>
+                <a16:creationId xmlns:a16="http://schemas.microsoft.com/office/drawing/2014/main" id="{14D00071-A2ED-4F28-9395-FBE9793429F1}"/>
               </a:ext>
             </a:extLst>
           </p:cNvPr>
@@ -12259,7 +12247,7 @@
           <p:cNvPr id="12" name="">
             <a:extLst xmlns:a="http://schemas.openxmlformats.org/drawingml/2006/main">
               <a:ext uri="{FF2B5EF4-FFF2-40B4-BE49-F238E27FC236}">
-                <a16:creationId xmlns:a16="http://schemas.microsoft.com/office/drawing/2014/main" id="{76B02DDA-1E28-4F8A-8841-D7B7CF1D9402}"/>
+                <a16:creationId xmlns:a16="http://schemas.microsoft.com/office/drawing/2014/main" id="{D8604646-E3F0-4451-B856-723124AECBDF}"/>
               </a:ext>
             </a:extLst>
           </p:cNvPr>
@@ -12416,7 +12404,7 @@
     </p:spTree>
     <p:extLst>
       <p:ext uri="{BB962C8B-B14F-4D97-AF65-F5344CB8AC3E}">
-        <p14:creationId xmlns:p14="http://schemas.microsoft.com/office/powerpoint/2010/main" val="1139697095"/>
+        <p14:creationId xmlns:p14="http://schemas.microsoft.com/office/powerpoint/2010/main" val="31554453"/>
       </p:ext>
     </p:extLst>
   </p:cSld>
@@ -12447,7 +12435,7 @@
           <p:cNvPr id="12" name="">
             <a:extLst xmlns:a="http://schemas.openxmlformats.org/drawingml/2006/main">
               <a:ext uri="{FF2B5EF4-FFF2-40B4-BE49-F238E27FC236}">
-                <a16:creationId xmlns:a16="http://schemas.microsoft.com/office/drawing/2014/main" id="{692E5BE6-C642-4365-ABDD-3CF6AF025700}"/>
+                <a16:creationId xmlns:a16="http://schemas.microsoft.com/office/drawing/2014/main" id="{C0A389FB-4E44-4631-8255-BF1EEB10F46B}"/>
               </a:ext>
             </a:extLst>
           </p:cNvPr>
@@ -12606,7 +12594,7 @@
           <p:cNvPr id="2" name="">
             <a:extLst xmlns:a="http://schemas.openxmlformats.org/drawingml/2006/main">
               <a:ext uri="{FF2B5EF4-FFF2-40B4-BE49-F238E27FC236}">
-                <a16:creationId xmlns:a16="http://schemas.microsoft.com/office/drawing/2014/main" id="{001C4574-8374-4B7F-AF21-1102E2A31D64}"/>
+                <a16:creationId xmlns:a16="http://schemas.microsoft.com/office/drawing/2014/main" id="{B131853E-A1D2-4F17-BB8D-315DBEA58B9E}"/>
               </a:ext>
             </a:extLst>
           </p:cNvPr>
@@ -12765,7 +12753,7 @@
           <p:cNvPr id="3" name="">
             <a:extLst xmlns:a="http://schemas.openxmlformats.org/drawingml/2006/main">
               <a:ext uri="{FF2B5EF4-FFF2-40B4-BE49-F238E27FC236}">
-                <a16:creationId xmlns:a16="http://schemas.microsoft.com/office/drawing/2014/main" id="{AF5B9DEE-C142-4771-A357-5BC13B4A0A11}"/>
+                <a16:creationId xmlns:a16="http://schemas.microsoft.com/office/drawing/2014/main" id="{755CBE6A-8EA2-4AB2-AC9A-5C2A499422B3}"/>
               </a:ext>
             </a:extLst>
           </p:cNvPr>
@@ -12796,7 +12784,7 @@
           <p:cNvPr id="4" name="">
             <a:extLst xmlns:a="http://schemas.openxmlformats.org/drawingml/2006/main">
               <a:ext uri="{FF2B5EF4-FFF2-40B4-BE49-F238E27FC236}">
-                <a16:creationId xmlns:a16="http://schemas.microsoft.com/office/drawing/2014/main" id="{B7070594-E27B-47E6-A9F9-2F084DFC2F75}"/>
+                <a16:creationId xmlns:a16="http://schemas.microsoft.com/office/drawing/2014/main" id="{34D16C4C-0DD1-4AE9-BD0B-F43EF166CAFC}"/>
               </a:ext>
             </a:extLst>
           </p:cNvPr>
@@ -12955,7 +12943,7 @@
           <p:cNvPr id="5" name="">
             <a:extLst xmlns:a="http://schemas.openxmlformats.org/drawingml/2006/main">
               <a:ext uri="{FF2B5EF4-FFF2-40B4-BE49-F238E27FC236}">
-                <a16:creationId xmlns:a16="http://schemas.microsoft.com/office/drawing/2014/main" id="{7581A661-306E-48A4-AA58-FDF7FDAEED85}"/>
+                <a16:creationId xmlns:a16="http://schemas.microsoft.com/office/drawing/2014/main" id="{A3B14A62-CB96-4ACB-96DD-11826BA7BFAF}"/>
               </a:ext>
             </a:extLst>
           </p:cNvPr>
@@ -13114,7 +13102,7 @@
           <p:cNvPr id="6" name="">
             <a:extLst xmlns:a="http://schemas.openxmlformats.org/drawingml/2006/main">
               <a:ext uri="{FF2B5EF4-FFF2-40B4-BE49-F238E27FC236}">
-                <a16:creationId xmlns:a16="http://schemas.microsoft.com/office/drawing/2014/main" id="{DA1F3844-5F7C-4239-97D6-184D5524E867}"/>
+                <a16:creationId xmlns:a16="http://schemas.microsoft.com/office/drawing/2014/main" id="{25CDE789-7F83-4D73-BE94-7805E10ECB4A}"/>
               </a:ext>
             </a:extLst>
           </p:cNvPr>
@@ -13273,7 +13261,7 @@
           <p:cNvPr id="7" name="">
             <a:extLst xmlns:a="http://schemas.openxmlformats.org/drawingml/2006/main">
               <a:ext uri="{FF2B5EF4-FFF2-40B4-BE49-F238E27FC236}">
-                <a16:creationId xmlns:a16="http://schemas.microsoft.com/office/drawing/2014/main" id="{9FD59C05-E94C-4A6B-BD64-C4C54DB48C31}"/>
+                <a16:creationId xmlns:a16="http://schemas.microsoft.com/office/drawing/2014/main" id="{9649C237-3988-4391-9065-65F2594358C5}"/>
               </a:ext>
             </a:extLst>
           </p:cNvPr>
@@ -13432,7 +13420,7 @@
           <p:cNvPr id="8" name="">
             <a:extLst xmlns:a="http://schemas.openxmlformats.org/drawingml/2006/main">
               <a:ext uri="{FF2B5EF4-FFF2-40B4-BE49-F238E27FC236}">
-                <a16:creationId xmlns:a16="http://schemas.microsoft.com/office/drawing/2014/main" id="{2C49EB52-DD31-4AD2-A38C-5C43B666FF19}"/>
+                <a16:creationId xmlns:a16="http://schemas.microsoft.com/office/drawing/2014/main" id="{572D3D49-8401-4BE9-86B5-5C31192B4CC2}"/>
               </a:ext>
             </a:extLst>
           </p:cNvPr>
@@ -13591,7 +13579,7 @@
           <p:cNvPr id="9" name="">
             <a:extLst xmlns:a="http://schemas.openxmlformats.org/drawingml/2006/main">
               <a:ext uri="{FF2B5EF4-FFF2-40B4-BE49-F238E27FC236}">
-                <a16:creationId xmlns:a16="http://schemas.microsoft.com/office/drawing/2014/main" id="{9259193B-CBA2-4DB8-A27D-49B736D11592}"/>
+                <a16:creationId xmlns:a16="http://schemas.microsoft.com/office/drawing/2014/main" id="{10312649-DB75-40FA-A933-AE34C6512C96}"/>
               </a:ext>
             </a:extLst>
           </p:cNvPr>
@@ -13750,7 +13738,7 @@
           <p:cNvPr id="10" name="">
             <a:extLst xmlns:a="http://schemas.openxmlformats.org/drawingml/2006/main">
               <a:ext uri="{FF2B5EF4-FFF2-40B4-BE49-F238E27FC236}">
-                <a16:creationId xmlns:a16="http://schemas.microsoft.com/office/drawing/2014/main" id="{122BC7CD-B8B0-4D94-8BD4-F21885A4DCB6}"/>
+                <a16:creationId xmlns:a16="http://schemas.microsoft.com/office/drawing/2014/main" id="{7C7A3DC4-E7C7-4EFB-AAA7-017D8D4B86E8}"/>
               </a:ext>
             </a:extLst>
           </p:cNvPr>
@@ -13760,19 +13748,16 @@
           <p:nvPr/>
         </p:nvPicPr>
         <p:blipFill>
-          <a:blip xmlns:r="http://schemas.openxmlformats.org/officeDocument/2006/relationships" xmlns:a="http://schemas.openxmlformats.org/drawingml/2006/main" r:embed="R96456ca7ec274ce1"/>
-          <a:srcRect xmlns:a="http://schemas.openxmlformats.org/drawingml/2006/main" l="25000" t="50000" r="50000" b="25000"/>
+          <a:blip xmlns:r="http://schemas.openxmlformats.org/officeDocument/2006/relationships" xmlns:a="http://schemas.openxmlformats.org/drawingml/2006/main" r:embed="Rb988258d23d94864"/>
           <a:stretch xmlns:a="http://schemas.openxmlformats.org/drawingml/2006/main"/>
         </p:blipFill>
         <p:spPr>
           <a:xfrm xmlns:a="http://schemas.openxmlformats.org/drawingml/2006/main">
-            <a:off x="6667500" y="2724150"/>
-            <a:ext cx="4095750" cy="2724150"/>
+            <a:off x="6953250" y="2477029"/>
+            <a:ext cx="3619500" cy="3704167"/>
           </a:xfrm>
-          <a:prstGeom xmlns:a="http://schemas.openxmlformats.org/drawingml/2006/main" prst="roundRect">
-            <a:avLst>
-              <a:gd name="adj" fmla="val 5594"/>
-            </a:avLst>
+          <a:prstGeom xmlns:a="http://schemas.openxmlformats.org/drawingml/2006/main" prst="rect">
+            <a:avLst/>
           </a:prstGeom>
         </p:spPr>
       </p:pic>
@@ -13781,7 +13766,7 @@
           <p:cNvPr id="11" name="">
             <a:extLst xmlns:a="http://schemas.openxmlformats.org/drawingml/2006/main">
               <a:ext uri="{FF2B5EF4-FFF2-40B4-BE49-F238E27FC236}">
-                <a16:creationId xmlns:a16="http://schemas.microsoft.com/office/drawing/2014/main" id="{3D2151B2-E038-408A-B7CE-03F3982FA747}"/>
+                <a16:creationId xmlns:a16="http://schemas.microsoft.com/office/drawing/2014/main" id="{861B1CCE-2F62-453B-BF9F-0B15C7BD551C}"/>
               </a:ext>
             </a:extLst>
           </p:cNvPr>
@@ -13938,7 +13923,7 @@
     </p:spTree>
     <p:extLst>
       <p:ext uri="{BB962C8B-B14F-4D97-AF65-F5344CB8AC3E}">
-        <p14:creationId xmlns:p14="http://schemas.microsoft.com/office/powerpoint/2010/main" val="1436177375"/>
+        <p14:creationId xmlns:p14="http://schemas.microsoft.com/office/powerpoint/2010/main" val="13662895"/>
       </p:ext>
     </p:extLst>
   </p:cSld>
@@ -13969,7 +13954,7 @@
           <p:cNvPr id="11" name="">
             <a:extLst xmlns:a="http://schemas.openxmlformats.org/drawingml/2006/main">
               <a:ext uri="{FF2B5EF4-FFF2-40B4-BE49-F238E27FC236}">
-                <a16:creationId xmlns:a16="http://schemas.microsoft.com/office/drawing/2014/main" id="{BD45934E-FE9C-43F2-8862-133F73D73DF7}"/>
+                <a16:creationId xmlns:a16="http://schemas.microsoft.com/office/drawing/2014/main" id="{7AD595F0-20F1-4454-8F32-8C08133917AD}"/>
               </a:ext>
             </a:extLst>
           </p:cNvPr>
@@ -14128,7 +14113,7 @@
           <p:cNvPr id="2" name="">
             <a:extLst xmlns:a="http://schemas.openxmlformats.org/drawingml/2006/main">
               <a:ext uri="{FF2B5EF4-FFF2-40B4-BE49-F238E27FC236}">
-                <a16:creationId xmlns:a16="http://schemas.microsoft.com/office/drawing/2014/main" id="{A03B8E0E-4854-493C-A5D4-50A59FB0B2CF}"/>
+                <a16:creationId xmlns:a16="http://schemas.microsoft.com/office/drawing/2014/main" id="{053F6C2E-4370-461F-825B-55DCCA47F448}"/>
               </a:ext>
             </a:extLst>
           </p:cNvPr>
@@ -14287,7 +14272,7 @@
           <p:cNvPr id="3" name="">
             <a:extLst xmlns:a="http://schemas.openxmlformats.org/drawingml/2006/main">
               <a:ext uri="{FF2B5EF4-FFF2-40B4-BE49-F238E27FC236}">
-                <a16:creationId xmlns:a16="http://schemas.microsoft.com/office/drawing/2014/main" id="{AD0D2D7E-737D-4C1B-942B-2C1A64C4CAC6}"/>
+                <a16:creationId xmlns:a16="http://schemas.microsoft.com/office/drawing/2014/main" id="{0FAA88CE-1D13-4BA7-872F-1652C2BAAC4F}"/>
               </a:ext>
             </a:extLst>
           </p:cNvPr>
@@ -14318,7 +14303,7 @@
           <p:cNvPr id="4" name="">
             <a:extLst xmlns:a="http://schemas.openxmlformats.org/drawingml/2006/main">
               <a:ext uri="{FF2B5EF4-FFF2-40B4-BE49-F238E27FC236}">
-                <a16:creationId xmlns:a16="http://schemas.microsoft.com/office/drawing/2014/main" id="{BBDD4063-04DA-462D-9EE7-479F42F39CF5}"/>
+                <a16:creationId xmlns:a16="http://schemas.microsoft.com/office/drawing/2014/main" id="{968D03F8-C818-4C03-A460-0744A6DAE5DF}"/>
               </a:ext>
             </a:extLst>
           </p:cNvPr>
@@ -14477,7 +14462,7 @@
           <p:cNvPr id="5" name="">
             <a:extLst xmlns:a="http://schemas.openxmlformats.org/drawingml/2006/main">
               <a:ext uri="{FF2B5EF4-FFF2-40B4-BE49-F238E27FC236}">
-                <a16:creationId xmlns:a16="http://schemas.microsoft.com/office/drawing/2014/main" id="{5AB6BE9D-B946-41DE-8DF6-16FEBC9AACE1}"/>
+                <a16:creationId xmlns:a16="http://schemas.microsoft.com/office/drawing/2014/main" id="{20C01AA0-4C4C-47AF-9F68-E54724EC9029}"/>
               </a:ext>
             </a:extLst>
           </p:cNvPr>
@@ -14636,7 +14621,7 @@
           <p:cNvPr id="6" name="">
             <a:extLst xmlns:a="http://schemas.openxmlformats.org/drawingml/2006/main">
               <a:ext uri="{FF2B5EF4-FFF2-40B4-BE49-F238E27FC236}">
-                <a16:creationId xmlns:a16="http://schemas.microsoft.com/office/drawing/2014/main" id="{659D6087-5F68-4EA1-88B2-D732F6DA7DF8}"/>
+                <a16:creationId xmlns:a16="http://schemas.microsoft.com/office/drawing/2014/main" id="{5513C3D3-B991-4A81-A6A6-1BF9AF20D92E}"/>
               </a:ext>
             </a:extLst>
           </p:cNvPr>
@@ -14795,7 +14780,7 @@
           <p:cNvPr id="7" name="">
             <a:extLst xmlns:a="http://schemas.openxmlformats.org/drawingml/2006/main">
               <a:ext uri="{FF2B5EF4-FFF2-40B4-BE49-F238E27FC236}">
-                <a16:creationId xmlns:a16="http://schemas.microsoft.com/office/drawing/2014/main" id="{77BE9D50-C774-4ECC-ABD8-3604AC6DC42E}"/>
+                <a16:creationId xmlns:a16="http://schemas.microsoft.com/office/drawing/2014/main" id="{87FB1296-36C3-42B6-8185-4CF08F61375A}"/>
               </a:ext>
             </a:extLst>
           </p:cNvPr>
@@ -14954,7 +14939,7 @@
           <p:cNvPr id="8" name="">
             <a:extLst xmlns:a="http://schemas.openxmlformats.org/drawingml/2006/main">
               <a:ext uri="{FF2B5EF4-FFF2-40B4-BE49-F238E27FC236}">
-                <a16:creationId xmlns:a16="http://schemas.microsoft.com/office/drawing/2014/main" id="{5ECA7666-D7ED-4222-A553-4F29DDD3C1F3}"/>
+                <a16:creationId xmlns:a16="http://schemas.microsoft.com/office/drawing/2014/main" id="{9AE23858-5525-4D4F-B123-26F4D062C8F0}"/>
               </a:ext>
             </a:extLst>
           </p:cNvPr>
@@ -15113,7 +15098,7 @@
           <p:cNvPr id="9" name="">
             <a:extLst xmlns:a="http://schemas.openxmlformats.org/drawingml/2006/main">
               <a:ext uri="{FF2B5EF4-FFF2-40B4-BE49-F238E27FC236}">
-                <a16:creationId xmlns:a16="http://schemas.microsoft.com/office/drawing/2014/main" id="{6BEA0DD1-EC39-4656-9707-4A917898F7EB}"/>
+                <a16:creationId xmlns:a16="http://schemas.microsoft.com/office/drawing/2014/main" id="{E86F597C-20B4-45E8-A175-6DC85171229F}"/>
               </a:ext>
             </a:extLst>
           </p:cNvPr>
@@ -15272,7 +15257,7 @@
           <p:cNvPr id="10" name="">
             <a:extLst xmlns:a="http://schemas.openxmlformats.org/drawingml/2006/main">
               <a:ext uri="{FF2B5EF4-FFF2-40B4-BE49-F238E27FC236}">
-                <a16:creationId xmlns:a16="http://schemas.microsoft.com/office/drawing/2014/main" id="{20DF029C-CA3F-481D-B2D7-737D702EE16B}"/>
+                <a16:creationId xmlns:a16="http://schemas.microsoft.com/office/drawing/2014/main" id="{D2D26BFE-4A5E-4692-8521-4C78424EA475}"/>
               </a:ext>
             </a:extLst>
           </p:cNvPr>
@@ -15282,26 +15267,23 @@
           <p:nvPr/>
         </p:nvPicPr>
         <p:blipFill>
-          <a:blip xmlns:r="http://schemas.openxmlformats.org/officeDocument/2006/relationships" xmlns:a="http://schemas.openxmlformats.org/drawingml/2006/main" r:embed="R1cff2cd7fb114bf3"/>
-          <a:srcRect xmlns:a="http://schemas.openxmlformats.org/drawingml/2006/main" l="0" t="0" r="85500" b="0"/>
+          <a:blip xmlns:r="http://schemas.openxmlformats.org/officeDocument/2006/relationships" xmlns:a="http://schemas.openxmlformats.org/drawingml/2006/main" r:embed="R05086597d29e42c2"/>
           <a:stretch xmlns:a="http://schemas.openxmlformats.org/drawingml/2006/main"/>
         </p:blipFill>
         <p:spPr>
           <a:xfrm xmlns:a="http://schemas.openxmlformats.org/drawingml/2006/main">
-            <a:off x="7810500" y="2266950"/>
-            <a:ext cx="2857500" cy="3886200"/>
+            <a:off x="7953375" y="2049128"/>
+            <a:ext cx="2400300" cy="4140868"/>
           </a:xfrm>
-          <a:prstGeom xmlns:a="http://schemas.openxmlformats.org/drawingml/2006/main" prst="roundRect">
-            <a:avLst>
-              <a:gd name="adj" fmla="val 5333"/>
-            </a:avLst>
+          <a:prstGeom xmlns:a="http://schemas.openxmlformats.org/drawingml/2006/main" prst="rect">
+            <a:avLst/>
           </a:prstGeom>
         </p:spPr>
       </p:pic>
     </p:spTree>
     <p:extLst>
       <p:ext uri="{BB962C8B-B14F-4D97-AF65-F5344CB8AC3E}">
-        <p14:creationId xmlns:p14="http://schemas.microsoft.com/office/powerpoint/2010/main" val="1151976101"/>
+        <p14:creationId xmlns:p14="http://schemas.microsoft.com/office/powerpoint/2010/main" val="1397007780"/>
       </p:ext>
     </p:extLst>
   </p:cSld>
@@ -15332,7 +15314,7 @@
           <p:cNvPr id="9" name="">
             <a:extLst xmlns:a="http://schemas.openxmlformats.org/drawingml/2006/main">
               <a:ext uri="{FF2B5EF4-FFF2-40B4-BE49-F238E27FC236}">
-                <a16:creationId xmlns:a16="http://schemas.microsoft.com/office/drawing/2014/main" id="{7C87C0CA-D5B9-4508-A2FA-3E3A67407F5C}"/>
+                <a16:creationId xmlns:a16="http://schemas.microsoft.com/office/drawing/2014/main" id="{5EEBA050-D9A8-4C09-8B37-1F47EA423BA9}"/>
               </a:ext>
             </a:extLst>
           </p:cNvPr>
@@ -15491,7 +15473,7 @@
           <p:cNvPr id="2" name="">
             <a:extLst xmlns:a="http://schemas.openxmlformats.org/drawingml/2006/main">
               <a:ext uri="{FF2B5EF4-FFF2-40B4-BE49-F238E27FC236}">
-                <a16:creationId xmlns:a16="http://schemas.microsoft.com/office/drawing/2014/main" id="{D497444A-845E-4C99-BD8E-95DE45B9884D}"/>
+                <a16:creationId xmlns:a16="http://schemas.microsoft.com/office/drawing/2014/main" id="{9ED5FC6E-BED1-4C1D-A368-7D3A11884534}"/>
               </a:ext>
             </a:extLst>
           </p:cNvPr>
@@ -15650,7 +15632,7 @@
           <p:cNvPr id="3" name="">
             <a:extLst xmlns:a="http://schemas.openxmlformats.org/drawingml/2006/main">
               <a:ext uri="{FF2B5EF4-FFF2-40B4-BE49-F238E27FC236}">
-                <a16:creationId xmlns:a16="http://schemas.microsoft.com/office/drawing/2014/main" id="{BF772747-CD78-454D-B46E-FE32EC09F846}"/>
+                <a16:creationId xmlns:a16="http://schemas.microsoft.com/office/drawing/2014/main" id="{972C81CA-313D-4568-A96E-7C1692D78F3E}"/>
               </a:ext>
             </a:extLst>
           </p:cNvPr>
@@ -15681,7 +15663,7 @@
           <p:cNvPr id="4" name="">
             <a:extLst xmlns:a="http://schemas.openxmlformats.org/drawingml/2006/main">
               <a:ext uri="{FF2B5EF4-FFF2-40B4-BE49-F238E27FC236}">
-                <a16:creationId xmlns:a16="http://schemas.microsoft.com/office/drawing/2014/main" id="{A295F70F-A35D-4D09-9E9F-63EDD626C0F5}"/>
+                <a16:creationId xmlns:a16="http://schemas.microsoft.com/office/drawing/2014/main" id="{8F284049-9BD3-48C7-832D-A9A9B3C800A3}"/>
               </a:ext>
             </a:extLst>
           </p:cNvPr>
@@ -15840,7 +15822,7 @@
           <p:cNvPr id="5" name="">
             <a:extLst xmlns:a="http://schemas.openxmlformats.org/drawingml/2006/main">
               <a:ext uri="{FF2B5EF4-FFF2-40B4-BE49-F238E27FC236}">
-                <a16:creationId xmlns:a16="http://schemas.microsoft.com/office/drawing/2014/main" id="{1E070CAD-6ABD-49F7-9C43-55E3B1F94042}"/>
+                <a16:creationId xmlns:a16="http://schemas.microsoft.com/office/drawing/2014/main" id="{FB1B61D2-5667-4D1A-B176-0872AB634BDC}"/>
               </a:ext>
             </a:extLst>
           </p:cNvPr>
@@ -15999,7 +15981,7 @@
           <p:cNvPr id="6" name="">
             <a:extLst xmlns:a="http://schemas.openxmlformats.org/drawingml/2006/main">
               <a:ext uri="{FF2B5EF4-FFF2-40B4-BE49-F238E27FC236}">
-                <a16:creationId xmlns:a16="http://schemas.microsoft.com/office/drawing/2014/main" id="{44EEF70D-AA59-4BD2-A1EE-C2F925F8064B}"/>
+                <a16:creationId xmlns:a16="http://schemas.microsoft.com/office/drawing/2014/main" id="{D68A4414-09FE-4355-8983-282A7742E83F}"/>
               </a:ext>
             </a:extLst>
           </p:cNvPr>
@@ -16158,7 +16140,7 @@
           <p:cNvPr id="7" name="">
             <a:extLst xmlns:a="http://schemas.openxmlformats.org/drawingml/2006/main">
               <a:ext uri="{FF2B5EF4-FFF2-40B4-BE49-F238E27FC236}">
-                <a16:creationId xmlns:a16="http://schemas.microsoft.com/office/drawing/2014/main" id="{149FD37D-2A78-4CA5-85DE-1EF0358E42AF}"/>
+                <a16:creationId xmlns:a16="http://schemas.microsoft.com/office/drawing/2014/main" id="{F2EC0674-0EBC-4C9E-946A-D8FC639903DE}"/>
               </a:ext>
             </a:extLst>
           </p:cNvPr>
@@ -16168,7 +16150,7 @@
           <p:nvPr/>
         </p:nvPicPr>
         <p:blipFill>
-          <a:blip xmlns:r="http://schemas.openxmlformats.org/officeDocument/2006/relationships" xmlns:a="http://schemas.openxmlformats.org/drawingml/2006/main" r:embed="R09f7711a59644211"/>
+          <a:blip xmlns:r="http://schemas.openxmlformats.org/officeDocument/2006/relationships" xmlns:a="http://schemas.openxmlformats.org/drawingml/2006/main" r:embed="Reb4c82d1ceec4766"/>
           <a:stretch xmlns:a="http://schemas.openxmlformats.org/drawingml/2006/main"/>
         </p:blipFill>
         <p:spPr>
@@ -16186,7 +16168,7 @@
           <p:cNvPr id="8" name="">
             <a:extLst xmlns:a="http://schemas.openxmlformats.org/drawingml/2006/main">
               <a:ext uri="{FF2B5EF4-FFF2-40B4-BE49-F238E27FC236}">
-                <a16:creationId xmlns:a16="http://schemas.microsoft.com/office/drawing/2014/main" id="{E65AF497-B4A8-4056-B840-0A1EB1F153AE}"/>
+                <a16:creationId xmlns:a16="http://schemas.microsoft.com/office/drawing/2014/main" id="{98CBF65D-1C89-4A86-8FA8-219B4BEAED75}"/>
               </a:ext>
             </a:extLst>
           </p:cNvPr>
@@ -16343,7 +16325,7 @@
     </p:spTree>
     <p:extLst>
       <p:ext uri="{BB962C8B-B14F-4D97-AF65-F5344CB8AC3E}">
-        <p14:creationId xmlns:p14="http://schemas.microsoft.com/office/powerpoint/2010/main" val="1766995183"/>
+        <p14:creationId xmlns:p14="http://schemas.microsoft.com/office/powerpoint/2010/main" val="2063028049"/>
       </p:ext>
     </p:extLst>
   </p:cSld>

</xml_diff>